<commit_message>
Einstein Cloud: GitHub no S12, subtítulo bold, contraste final
</commit_message>
<xml_diff>
--- a/apresentacoes/Einstein_Cloud_Apresentacao.pptx
+++ b/apresentacoes/Einstein_Cloud_Apresentacao.pptx
@@ -2085,9 +2085,9 @@
               <a:buNone/>
             </a:pPr>
             <a:r>
-              <a:rPr lang="en-US" sz="2400" dirty="0">
-                <a:solidFill>
-                  <a:srgbClr val="C9A227"/>
+              <a:rPr lang="en-US" sz="2600" b="1" dirty="0">
+                <a:solidFill>
+                  <a:srgbClr val="E8B931"/>
                 </a:solidFill>
                 <a:latin typeface="Georgia" pitchFamily="34" charset="0"/>
                 <a:ea typeface="Georgia" pitchFamily="34" charset="-122"/>
@@ -2095,7 +2095,7 @@
               </a:rPr>
               <a:t>A primeira nuvem médica privada e soberana do Brasil</a:t>
             </a:r>
-            <a:endParaRPr lang="en-US" sz="2400" dirty="0"/>
+            <a:endParaRPr lang="en-US" sz="2600" dirty="0"/>
           </a:p>
         </p:txBody>
       </p:sp>
@@ -3629,6 +3629,146 @@
               <a:t>4. Protocolo ao CEP (se houver fine-tuning com dados do Einstein)</a:t>
             </a:r>
             <a:endParaRPr lang="en-US" sz="1600" dirty="0"/>
+          </a:p>
+        </p:txBody>
+      </p:sp>
+      <p:sp>
+        <p:nvSpPr>
+          <p:cNvPr id="13" name="Shape 11"/>
+          <p:cNvSpPr/>
+          <p:nvPr/>
+        </p:nvSpPr>
+        <p:spPr>
+          <a:xfrm>
+            <a:off x="548640" y="4754880"/>
+            <a:ext cx="11091672" cy="0"/>
+          </a:xfrm>
+          <a:prstGeom prst="line">
+            <a:avLst/>
+          </a:prstGeom>
+          <a:noFill/>
+          <a:ln w="9525">
+            <a:solidFill>
+              <a:srgbClr val="E3ECF5"/>
+            </a:solidFill>
+            <a:prstDash val="solid"/>
+          </a:ln>
+        </p:spPr>
+      </p:sp>
+      <p:sp>
+        <p:nvSpPr>
+          <p:cNvPr id="14" name="Text 12"/>
+          <p:cNvSpPr/>
+          <p:nvPr/>
+        </p:nvSpPr>
+        <p:spPr>
+          <a:xfrm>
+            <a:off x="548640" y="4937760"/>
+            <a:ext cx="11091672" cy="365760"/>
+          </a:xfrm>
+          <a:prstGeom prst="rect">
+            <a:avLst/>
+          </a:prstGeom>
+          <a:noFill/>
+          <a:ln/>
+        </p:spPr>
+        <p:txBody>
+          <a:bodyPr wrap="square" lIns="0" tIns="0" rIns="0" bIns="0" rtlCol="0" anchor="ctr"/>
+          <a:lstStyle/>
+          <a:p>
+            <a:pPr indent="0" marL="0">
+              <a:buNone/>
+            </a:pPr>
+            <a:r>
+              <a:rPr lang="en-US" sz="1500" b="1" dirty="0">
+                <a:solidFill>
+                  <a:srgbClr val="1B4B8F"/>
+                </a:solidFill>
+                <a:latin typeface="Arial" pitchFamily="34" charset="0"/>
+                <a:ea typeface="Arial" pitchFamily="34" charset="-122"/>
+                <a:cs typeface="Arial" pitchFamily="34" charset="-120"/>
+              </a:rPr>
+              <a:t>Repositório do benchmark: github.com/beanstechhub/einstein-benchmark</a:t>
+            </a:r>
+            <a:endParaRPr lang="en-US" sz="1500" dirty="0"/>
+          </a:p>
+        </p:txBody>
+      </p:sp>
+      <p:sp>
+        <p:nvSpPr>
+          <p:cNvPr id="15" name="Text 13"/>
+          <p:cNvSpPr/>
+          <p:nvPr/>
+        </p:nvSpPr>
+        <p:spPr>
+          <a:xfrm>
+            <a:off x="548640" y="5303520"/>
+            <a:ext cx="11091672" cy="365760"/>
+          </a:xfrm>
+          <a:prstGeom prst="rect">
+            <a:avLst/>
+          </a:prstGeom>
+          <a:noFill/>
+          <a:ln/>
+        </p:spPr>
+        <p:txBody>
+          <a:bodyPr wrap="square" lIns="0" tIns="0" rIns="0" bIns="0" rtlCol="0" anchor="ctr"/>
+          <a:lstStyle/>
+          <a:p>
+            <a:pPr indent="0" marL="0">
+              <a:buNone/>
+            </a:pPr>
+            <a:r>
+              <a:rPr lang="en-US" sz="1300" dirty="0">
+                <a:solidFill>
+                  <a:srgbClr val="6B7280"/>
+                </a:solidFill>
+                <a:latin typeface="Arial" pitchFamily="34" charset="0"/>
+                <a:ea typeface="Arial" pitchFamily="34" charset="-122"/>
+                <a:cs typeface="Arial" pitchFamily="34" charset="-120"/>
+              </a:rPr>
+              <a:t>200 casos · 9 modelos anônimos · acesso mediante convite · 2 semanas para revisão</a:t>
+            </a:r>
+            <a:endParaRPr lang="en-US" sz="1300" dirty="0"/>
+          </a:p>
+        </p:txBody>
+      </p:sp>
+      <p:sp>
+        <p:nvSpPr>
+          <p:cNvPr id="16" name="Text 14"/>
+          <p:cNvSpPr/>
+          <p:nvPr/>
+        </p:nvSpPr>
+        <p:spPr>
+          <a:xfrm>
+            <a:off x="548640" y="5760720"/>
+            <a:ext cx="7315200" cy="457200"/>
+          </a:xfrm>
+          <a:prstGeom prst="rect">
+            <a:avLst/>
+          </a:prstGeom>
+          <a:noFill/>
+          <a:ln/>
+        </p:spPr>
+        <p:txBody>
+          <a:bodyPr wrap="square" lIns="0" tIns="0" rIns="0" bIns="0" rtlCol="0" anchor="ctr"/>
+          <a:lstStyle/>
+          <a:p>
+            <a:pPr indent="0" marL="0">
+              <a:buNone/>
+            </a:pPr>
+            <a:r>
+              <a:rPr lang="en-US" sz="1400" b="1" dirty="0">
+                <a:solidFill>
+                  <a:srgbClr val="0A1F3D"/>
+                </a:solidFill>
+                <a:latin typeface="Arial" pitchFamily="34" charset="0"/>
+                <a:ea typeface="Arial" pitchFamily="34" charset="-122"/>
+                <a:cs typeface="Arial" pitchFamily="34" charset="-120"/>
+              </a:rPr>
+              <a:t>Matheus Feijão · WhatsApp +55 11 92507-9058 · matheus@beanstech.com.br</a:t>
+            </a:r>
+            <a:endParaRPr lang="en-US" sz="1400" dirty="0"/>
           </a:p>
         </p:txBody>
       </p:sp>

</xml_diff>

<commit_message>
Qwen: 'um dos melhores do mundo' (PT/EN); Einstein: S5/S8/S13 preenchidos, sintaxe corrigida
</commit_message>
<xml_diff>
--- a/apresentacoes/Einstein_Cloud_Apresentacao.pptx
+++ b/apresentacoes/Einstein_Cloud_Apresentacao.pptx
@@ -3890,24 +3890,24 @@
         </p:nvSpPr>
         <p:spPr>
           <a:xfrm>
-            <a:off x="548640" y="1828800"/>
-            <a:ext cx="10058400" cy="731520"/>
-          </a:xfrm>
-          <a:prstGeom prst="rect">
-            <a:avLst/>
-          </a:prstGeom>
-          <a:noFill/>
-          <a:ln/>
-        </p:spPr>
-        <p:txBody>
-          <a:bodyPr wrap="square" lIns="0" tIns="0" rIns="0" bIns="0" rtlCol="0" anchor="ctr"/>
-          <a:lstStyle/>
-          <a:p>
-            <a:pPr indent="0" marL="0">
-              <a:buNone/>
-            </a:pPr>
-            <a:r>
-              <a:rPr lang="en-US" sz="2800" dirty="0">
+            <a:off x="548640" y="1371600"/>
+            <a:ext cx="10058400" cy="822960"/>
+          </a:xfrm>
+          <a:prstGeom prst="rect">
+            <a:avLst/>
+          </a:prstGeom>
+          <a:noFill/>
+          <a:ln/>
+        </p:spPr>
+        <p:txBody>
+          <a:bodyPr wrap="square" lIns="0" tIns="0" rIns="0" bIns="0" rtlCol="0" anchor="ctr"/>
+          <a:lstStyle/>
+          <a:p>
+            <a:pPr indent="0" marL="0">
+              <a:buNone/>
+            </a:pPr>
+            <a:r>
+              <a:rPr lang="en-US" sz="3200" dirty="0">
                 <a:solidFill>
                   <a:srgbClr val="FFFFFF"/>
                 </a:solidFill>
@@ -3917,7 +3917,7 @@
               </a:rPr>
               <a:t>A inteligência artificial é o meio.</a:t>
             </a:r>
-            <a:endParaRPr lang="en-US" sz="2800" dirty="0"/>
+            <a:endParaRPr lang="en-US" sz="3200" dirty="0"/>
           </a:p>
         </p:txBody>
       </p:sp>
@@ -3968,24 +3968,24 @@
         </p:nvSpPr>
         <p:spPr>
           <a:xfrm>
-            <a:off x="548640" y="3657600"/>
-            <a:ext cx="10058400" cy="731520"/>
-          </a:xfrm>
-          <a:prstGeom prst="rect">
-            <a:avLst/>
-          </a:prstGeom>
-          <a:noFill/>
-          <a:ln/>
-        </p:spPr>
-        <p:txBody>
-          <a:bodyPr wrap="square" lIns="0" tIns="0" rIns="0" bIns="0" rtlCol="0" anchor="ctr"/>
-          <a:lstStyle/>
-          <a:p>
-            <a:pPr indent="0" marL="0">
-              <a:buNone/>
-            </a:pPr>
-            <a:r>
-              <a:rPr lang="en-US" sz="2800" dirty="0">
+            <a:off x="548640" y="3383280"/>
+            <a:ext cx="10058400" cy="822960"/>
+          </a:xfrm>
+          <a:prstGeom prst="rect">
+            <a:avLst/>
+          </a:prstGeom>
+          <a:noFill/>
+          <a:ln/>
+        </p:spPr>
+        <p:txBody>
+          <a:bodyPr wrap="square" lIns="0" tIns="0" rIns="0" bIns="0" rtlCol="0" anchor="ctr"/>
+          <a:lstStyle/>
+          <a:p>
+            <a:pPr indent="0" marL="0">
+              <a:buNone/>
+            </a:pPr>
+            <a:r>
+              <a:rPr lang="en-US" sz="3200" dirty="0">
                 <a:solidFill>
                   <a:srgbClr val="FFFFFF"/>
                 </a:solidFill>
@@ -3995,7 +3995,7 @@
               </a:rPr>
               <a:t>O paciente é o propósito.</a:t>
             </a:r>
-            <a:endParaRPr lang="en-US" sz="2800" dirty="0"/>
+            <a:endParaRPr lang="en-US" sz="3200" dirty="0"/>
           </a:p>
         </p:txBody>
       </p:sp>
@@ -4030,7 +4030,7 @@
         </p:nvSpPr>
         <p:spPr>
           <a:xfrm>
-            <a:off x="548640" y="5303520"/>
+            <a:off x="548640" y="4663440"/>
             <a:ext cx="9144000" cy="457200"/>
           </a:xfrm>
           <a:prstGeom prst="rect">
@@ -4047,7 +4047,7 @@
               <a:buNone/>
             </a:pPr>
             <a:r>
-              <a:rPr lang="en-US" sz="1400" dirty="0">
+              <a:rPr lang="en-US" sz="1600" dirty="0">
                 <a:solidFill>
                   <a:srgbClr val="D0DCE8"/>
                 </a:solidFill>
@@ -4057,13 +4057,52 @@
               </a:rPr>
               <a:t>github.com/beanstechhub/einstein-benchmark · Matheus Feijão · WhatsApp +55 11 92507-9058</a:t>
             </a:r>
-            <a:endParaRPr lang="en-US" sz="1400" dirty="0"/>
+            <a:endParaRPr lang="en-US" sz="1600" dirty="0"/>
           </a:p>
         </p:txBody>
       </p:sp>
       <p:sp>
         <p:nvSpPr>
           <p:cNvPr id="9" name="Text 7"/>
+          <p:cNvSpPr/>
+          <p:nvPr/>
+        </p:nvSpPr>
+        <p:spPr>
+          <a:xfrm>
+            <a:off x="548640" y="5029200"/>
+            <a:ext cx="9144000" cy="457200"/>
+          </a:xfrm>
+          <a:prstGeom prst="rect">
+            <a:avLst/>
+          </a:prstGeom>
+          <a:noFill/>
+          <a:ln/>
+        </p:spPr>
+        <p:txBody>
+          <a:bodyPr wrap="square" lIns="0" tIns="0" rIns="0" bIns="0" rtlCol="0" anchor="ctr"/>
+          <a:lstStyle/>
+          <a:p>
+            <a:pPr indent="0" marL="0">
+              <a:buNone/>
+            </a:pPr>
+            <a:r>
+              <a:rPr lang="en-US" sz="1600" dirty="0">
+                <a:solidFill>
+                  <a:srgbClr val="D0DCE8"/>
+                </a:solidFill>
+                <a:latin typeface="Arial" pitchFamily="34" charset="0"/>
+                <a:ea typeface="Arial" pitchFamily="34" charset="-122"/>
+                <a:cs typeface="Arial" pitchFamily="34" charset="-120"/>
+              </a:rPr>
+              <a:t>Do Einstein para o Brasil: impacto em milhões de vidas.</a:t>
+            </a:r>
+            <a:endParaRPr lang="en-US" sz="1600" dirty="0"/>
+          </a:p>
+        </p:txBody>
+      </p:sp>
+      <p:sp>
+        <p:nvSpPr>
+          <p:cNvPr id="10" name="Text 8"/>
           <p:cNvSpPr/>
           <p:nvPr/>
         </p:nvSpPr>
@@ -6693,30 +6732,53 @@
       </p:graphicFrame>
       <p:sp>
         <p:nvSpPr>
-          <p:cNvPr id="7" name="Text 4"/>
-          <p:cNvSpPr/>
-          <p:nvPr/>
-        </p:nvSpPr>
-        <p:spPr>
-          <a:xfrm>
-            <a:off x="548640" y="5029200"/>
-            <a:ext cx="11091672" cy="822960"/>
-          </a:xfrm>
-          <a:prstGeom prst="rect">
-            <a:avLst/>
-          </a:prstGeom>
-          <a:noFill/>
-          <a:ln/>
-        </p:spPr>
-        <p:txBody>
-          <a:bodyPr wrap="square" lIns="0" tIns="0" rIns="0" bIns="0" rtlCol="0" anchor="ctr"/>
-          <a:lstStyle/>
-          <a:p>
-            <a:pPr indent="0" marL="0">
-              <a:buNone/>
-            </a:pPr>
-            <a:r>
-              <a:rPr lang="en-US" sz="1500" b="1" dirty="0">
+          <p:cNvPr id="7" name="Shape 4"/>
+          <p:cNvSpPr/>
+          <p:nvPr/>
+        </p:nvSpPr>
+        <p:spPr>
+          <a:xfrm>
+            <a:off x="548640" y="4480560"/>
+            <a:ext cx="11091672" cy="0"/>
+          </a:xfrm>
+          <a:prstGeom prst="line">
+            <a:avLst/>
+          </a:prstGeom>
+          <a:noFill/>
+          <a:ln w="9525">
+            <a:solidFill>
+              <a:srgbClr val="E3ECF5"/>
+            </a:solidFill>
+            <a:prstDash val="solid"/>
+          </a:ln>
+        </p:spPr>
+      </p:sp>
+      <p:sp>
+        <p:nvSpPr>
+          <p:cNvPr id="8" name="Text 5"/>
+          <p:cNvSpPr/>
+          <p:nvPr/>
+        </p:nvSpPr>
+        <p:spPr>
+          <a:xfrm>
+            <a:off x="548640" y="4572000"/>
+            <a:ext cx="5486400" cy="640080"/>
+          </a:xfrm>
+          <a:prstGeom prst="rect">
+            <a:avLst/>
+          </a:prstGeom>
+          <a:noFill/>
+          <a:ln/>
+        </p:spPr>
+        <p:txBody>
+          <a:bodyPr wrap="square" lIns="0" tIns="0" rIns="0" bIns="0" rtlCol="0" anchor="ctr"/>
+          <a:lstStyle/>
+          <a:p>
+            <a:pPr indent="0" marL="0">
+              <a:buNone/>
+            </a:pPr>
+            <a:r>
+              <a:rPr lang="en-US" sz="1600" b="1" dirty="0">
                 <a:solidFill>
                   <a:srgbClr val="1B4B8F"/>
                 </a:solidFill>
@@ -6738,9 +6800,140 @@
                 <a:ea typeface="Arial" pitchFamily="34" charset="-122"/>
                 <a:cs typeface="Arial" pitchFamily="34" charset="-120"/>
               </a:rPr>
-              <a:t>cada modelo vence em especialidades diferentes. Não existe 'o melhor' — existe o melhor por domínio. A arquitetura correta é roteamento multi-modelo.</a:t>
-            </a:r>
-            <a:endParaRPr lang="en-US" sz="1500" dirty="0"/>
+              <a:t>cada modelo vence em especialidades diferentes. Não existe 'o melhor' — existe o melhor por domínio.</a:t>
+            </a:r>
+            <a:endParaRPr lang="en-US" sz="1600" dirty="0"/>
+          </a:p>
+        </p:txBody>
+      </p:sp>
+      <p:sp>
+        <p:nvSpPr>
+          <p:cNvPr id="9" name="Text 6"/>
+          <p:cNvSpPr/>
+          <p:nvPr/>
+        </p:nvSpPr>
+        <p:spPr>
+          <a:xfrm>
+            <a:off x="548640" y="5212080"/>
+            <a:ext cx="5486400" cy="548640"/>
+          </a:xfrm>
+          <a:prstGeom prst="rect">
+            <a:avLst/>
+          </a:prstGeom>
+          <a:noFill/>
+          <a:ln/>
+        </p:spPr>
+        <p:txBody>
+          <a:bodyPr wrap="square" lIns="0" tIns="0" rIns="0" bIns="0" rtlCol="0" anchor="ctr"/>
+          <a:lstStyle/>
+          <a:p>
+            <a:pPr indent="0" marL="0">
+              <a:buNone/>
+            </a:pPr>
+            <a:r>
+              <a:rPr lang="en-US" sz="1600" b="1" dirty="0">
+                <a:solidFill>
+                  <a:srgbClr val="1B4B8F"/>
+                </a:solidFill>
+                <a:latin typeface="Arial" pitchFamily="34" charset="0"/>
+                <a:ea typeface="Arial" pitchFamily="34" charset="-122"/>
+                <a:cs typeface="Arial" pitchFamily="34" charset="-120"/>
+              </a:rPr>
+              <a:t>A arquitetura correta: </a:t>
+            </a:r>
+            <a:pPr indent="0" marL="0">
+              <a:buNone/>
+            </a:pPr>
+            <a:r>
+              <a:rPr lang="en-US" sz="1500" dirty="0">
+                <a:solidFill>
+                  <a:srgbClr val="1B2A4A"/>
+                </a:solidFill>
+                <a:latin typeface="Arial" pitchFamily="34" charset="0"/>
+                <a:ea typeface="Arial" pitchFamily="34" charset="-122"/>
+                <a:cs typeface="Arial" pitchFamily="34" charset="-120"/>
+              </a:rPr>
+              <a:t>roteamento multi-modelo por especialidade — cada pergunta vai ao especialista certo.</a:t>
+            </a:r>
+            <a:endParaRPr lang="en-US" sz="1600" dirty="0"/>
+          </a:p>
+        </p:txBody>
+      </p:sp>
+      <p:sp>
+        <p:nvSpPr>
+          <p:cNvPr id="10" name="Text 7"/>
+          <p:cNvSpPr/>
+          <p:nvPr/>
+        </p:nvSpPr>
+        <p:spPr>
+          <a:xfrm>
+            <a:off x="6858000" y="4572000"/>
+            <a:ext cx="4846320" cy="640080"/>
+          </a:xfrm>
+          <a:prstGeom prst="rect">
+            <a:avLst/>
+          </a:prstGeom>
+          <a:noFill/>
+          <a:ln/>
+        </p:spPr>
+        <p:txBody>
+          <a:bodyPr wrap="square" lIns="0" tIns="0" rIns="0" bIns="0" rtlCol="0" anchor="ctr"/>
+          <a:lstStyle/>
+          <a:p>
+            <a:pPr indent="0" marL="0">
+              <a:buNone/>
+            </a:pPr>
+            <a:r>
+              <a:rPr lang="en-US" sz="1300" dirty="0">
+                <a:solidFill>
+                  <a:srgbClr val="6B7280"/>
+                </a:solidFill>
+                <a:latin typeface="Arial" pitchFamily="34" charset="0"/>
+                <a:ea typeface="Arial" pitchFamily="34" charset="-122"/>
+                <a:cs typeface="Arial" pitchFamily="34" charset="-120"/>
+              </a:rPr>
+              <a:t>Red-team: 10/10 modelos falharam sem guardrail. Granite Guardian: 100% interceptado.</a:t>
+            </a:r>
+            <a:endParaRPr lang="en-US" sz="1300" dirty="0"/>
+          </a:p>
+        </p:txBody>
+      </p:sp>
+      <p:sp>
+        <p:nvSpPr>
+          <p:cNvPr id="11" name="Text 8"/>
+          <p:cNvSpPr/>
+          <p:nvPr/>
+        </p:nvSpPr>
+        <p:spPr>
+          <a:xfrm>
+            <a:off x="6858000" y="5212080"/>
+            <a:ext cx="4846320" cy="548640"/>
+          </a:xfrm>
+          <a:prstGeom prst="rect">
+            <a:avLst/>
+          </a:prstGeom>
+          <a:noFill/>
+          <a:ln/>
+        </p:spPr>
+        <p:txBody>
+          <a:bodyPr wrap="square" lIns="0" tIns="0" rIns="0" bIns="0" rtlCol="0" anchor="ctr"/>
+          <a:lstStyle/>
+          <a:p>
+            <a:pPr indent="0" marL="0">
+              <a:buNone/>
+            </a:pPr>
+            <a:r>
+              <a:rPr lang="en-US" sz="1300" dirty="0">
+                <a:solidFill>
+                  <a:srgbClr val="6B7280"/>
+                </a:solidFill>
+                <a:latin typeface="Arial" pitchFamily="34" charset="0"/>
+                <a:ea typeface="Arial" pitchFamily="34" charset="-122"/>
+                <a:cs typeface="Arial" pitchFamily="34" charset="-120"/>
+              </a:rPr>
+              <a:t>AI General-purpose + LLM Inference: US$ 6.000/mês em SPs ativos cobrindo API.</a:t>
+            </a:r>
+            <a:endParaRPr lang="en-US" sz="1300" dirty="0"/>
           </a:p>
         </p:txBody>
       </p:sp>
@@ -8057,13 +8250,36 @@
       </p:graphicFrame>
       <p:sp>
         <p:nvSpPr>
-          <p:cNvPr id="6" name="Text 3"/>
-          <p:cNvSpPr/>
-          <p:nvPr/>
-        </p:nvSpPr>
-        <p:spPr>
-          <a:xfrm>
-            <a:off x="548640" y="4572000"/>
+          <p:cNvPr id="6" name="Shape 3"/>
+          <p:cNvSpPr/>
+          <p:nvPr/>
+        </p:nvSpPr>
+        <p:spPr>
+          <a:xfrm>
+            <a:off x="548640" y="4297680"/>
+            <a:ext cx="11091672" cy="0"/>
+          </a:xfrm>
+          <a:prstGeom prst="line">
+            <a:avLst/>
+          </a:prstGeom>
+          <a:noFill/>
+          <a:ln w="9525">
+            <a:solidFill>
+              <a:srgbClr val="E3ECF5"/>
+            </a:solidFill>
+            <a:prstDash val="solid"/>
+          </a:ln>
+        </p:spPr>
+      </p:sp>
+      <p:sp>
+        <p:nvSpPr>
+          <p:cNvPr id="7" name="Text 4"/>
+          <p:cNvSpPr/>
+          <p:nvPr/>
+        </p:nvSpPr>
+        <p:spPr>
+          <a:xfrm>
+            <a:off x="548640" y="4480560"/>
             <a:ext cx="11091672" cy="548640"/>
           </a:xfrm>
           <a:prstGeom prst="rect">
@@ -8080,7 +8296,7 @@
               <a:buNone/>
             </a:pPr>
             <a:r>
-              <a:rPr lang="en-US" sz="1600" i="1" dirty="0">
+              <a:rPr lang="en-US" sz="1800" i="1" dirty="0">
                 <a:solidFill>
                   <a:srgbClr val="C9A227"/>
                 </a:solidFill>
@@ -8088,9 +8304,129 @@
                 <a:ea typeface="Georgia" pitchFamily="34" charset="-122"/>
                 <a:cs typeface="Georgia" pitchFamily="34" charset="-120"/>
               </a:rPr>
-              <a:t>A BeansTech é mera coadjuvante. O Einstein lidera.</a:t>
-            </a:r>
-            <a:endParaRPr lang="en-US" sz="1600" dirty="0"/>
+              <a:t>A BeansTech é mera coadjuvante. </a:t>
+            </a:r>
+            <a:pPr indent="0" marL="0">
+              <a:buNone/>
+            </a:pPr>
+            <a:r>
+              <a:rPr lang="en-US" sz="1800" b="1" dirty="0">
+                <a:solidFill>
+                  <a:srgbClr val="1B4B8F"/>
+                </a:solidFill>
+                <a:latin typeface="Georgia" pitchFamily="34" charset="0"/>
+                <a:ea typeface="Georgia" pitchFamily="34" charset="-122"/>
+                <a:cs typeface="Georgia" pitchFamily="34" charset="-120"/>
+              </a:rPr>
+              <a:t>O Einstein lidera.</a:t>
+            </a:r>
+            <a:endParaRPr lang="en-US" sz="1800" dirty="0"/>
+          </a:p>
+        </p:txBody>
+      </p:sp>
+      <p:sp>
+        <p:nvSpPr>
+          <p:cNvPr id="8" name="Text 5"/>
+          <p:cNvSpPr/>
+          <p:nvPr/>
+        </p:nvSpPr>
+        <p:spPr>
+          <a:xfrm>
+            <a:off x="548640" y="5120640"/>
+            <a:ext cx="11091672" cy="548640"/>
+          </a:xfrm>
+          <a:prstGeom prst="rect">
+            <a:avLst/>
+          </a:prstGeom>
+          <a:noFill/>
+          <a:ln/>
+        </p:spPr>
+        <p:txBody>
+          <a:bodyPr wrap="square" lIns="0" tIns="0" rIns="0" bIns="0" rtlCol="0" anchor="ctr"/>
+          <a:lstStyle/>
+          <a:p>
+            <a:pPr indent="0" marL="0">
+              <a:buNone/>
+            </a:pPr>
+            <a:r>
+              <a:rPr lang="en-US" sz="1400" b="1" dirty="0">
+                <a:solidFill>
+                  <a:srgbClr val="1B4B8F"/>
+                </a:solidFill>
+                <a:latin typeface="Arial" pitchFamily="34" charset="0"/>
+                <a:ea typeface="Arial" pitchFamily="34" charset="-122"/>
+                <a:cs typeface="Arial" pitchFamily="34" charset="-120"/>
+              </a:rPr>
+              <a:t>Decisões que ficam com o Einstein: </a:t>
+            </a:r>
+            <a:pPr indent="0" marL="0">
+              <a:buNone/>
+            </a:pPr>
+            <a:r>
+              <a:rPr lang="en-US" sz="1400" dirty="0">
+                <a:solidFill>
+                  <a:srgbClr val="1B2A4A"/>
+                </a:solidFill>
+                <a:latin typeface="Arial" pitchFamily="34" charset="0"/>
+                <a:ea typeface="Arial" pitchFamily="34" charset="-122"/>
+                <a:cs typeface="Arial" pitchFamily="34" charset="-120"/>
+              </a:rPr>
+              <a:t>quais modelos usar, quando atualizar, quais dados usar para fine-tuning, quando suspender.</a:t>
+            </a:r>
+            <a:endParaRPr lang="en-US" sz="1400" dirty="0"/>
+          </a:p>
+        </p:txBody>
+      </p:sp>
+      <p:sp>
+        <p:nvSpPr>
+          <p:cNvPr id="9" name="Text 6"/>
+          <p:cNvSpPr/>
+          <p:nvPr/>
+        </p:nvSpPr>
+        <p:spPr>
+          <a:xfrm>
+            <a:off x="548640" y="5669280"/>
+            <a:ext cx="11091672" cy="457200"/>
+          </a:xfrm>
+          <a:prstGeom prst="rect">
+            <a:avLst/>
+          </a:prstGeom>
+          <a:noFill/>
+          <a:ln/>
+        </p:spPr>
+        <p:txBody>
+          <a:bodyPr wrap="square" lIns="0" tIns="0" rIns="0" bIns="0" rtlCol="0" anchor="ctr"/>
+          <a:lstStyle/>
+          <a:p>
+            <a:pPr indent="0" marL="0">
+              <a:buNone/>
+            </a:pPr>
+            <a:r>
+              <a:rPr lang="en-US" sz="1400" b="1" dirty="0">
+                <a:solidFill>
+                  <a:srgbClr val="1B4B8F"/>
+                </a:solidFill>
+                <a:latin typeface="Arial" pitchFamily="34" charset="0"/>
+                <a:ea typeface="Arial" pitchFamily="34" charset="-122"/>
+                <a:cs typeface="Arial" pitchFamily="34" charset="-120"/>
+              </a:rPr>
+              <a:t>Decisões que ficam com a BeansTech: </a:t>
+            </a:r>
+            <a:pPr indent="0" marL="0">
+              <a:buNone/>
+            </a:pPr>
+            <a:r>
+              <a:rPr lang="en-US" sz="1400" dirty="0">
+                <a:solidFill>
+                  <a:srgbClr val="1B2A4A"/>
+                </a:solidFill>
+                <a:latin typeface="Arial" pitchFamily="34" charset="0"/>
+                <a:ea typeface="Arial" pitchFamily="34" charset="-122"/>
+                <a:cs typeface="Arial" pitchFamily="34" charset="-120"/>
+              </a:rPr>
+              <a:t>infraestrutura, disponibilidade, monitoramento, manutenção.</a:t>
+            </a:r>
+            <a:endParaRPr lang="en-US" sz="1400" dirty="0"/>
           </a:p>
         </p:txBody>
       </p:sp>

</xml_diff>

<commit_message>
Slides completos: LGPD, IA como ferramenta, Einstein 5/8 preenchidos, Qwen 5/6/8 com contexto clínico, Benchmark 10 slides
</commit_message>
<xml_diff>
--- a/apresentacoes/Einstein_Cloud_Apresentacao.pptx
+++ b/apresentacoes/Einstein_Cloud_Apresentacao.pptx
@@ -6150,7 +6150,7 @@
                 <a:gridCol w="2772918"/>
                 <a:gridCol w="2772918"/>
               </a:tblGrid>
-              <a:tr h="502920">
+              <a:tr h="548640">
                 <a:tc>
                   <a:txBody>
                     <a:bodyPr/>
@@ -6424,7 +6424,7 @@
                   </a:tcPr>
                 </a:tc>
               </a:tr>
-              <a:tr h="502920">
+              <a:tr h="548640">
                 <a:tc>
                   <a:txBody>
                     <a:bodyPr/>
@@ -6738,7 +6738,7 @@
         </p:nvSpPr>
         <p:spPr>
           <a:xfrm>
-            <a:off x="548640" y="4754880"/>
+            <a:off x="548640" y="4846320"/>
             <a:ext cx="11091672" cy="0"/>
           </a:xfrm>
           <a:prstGeom prst="line">
@@ -6761,24 +6761,24 @@
         </p:nvSpPr>
         <p:spPr>
           <a:xfrm>
-            <a:off x="548640" y="4937760"/>
-            <a:ext cx="5486400" cy="731520"/>
-          </a:xfrm>
-          <a:prstGeom prst="rect">
-            <a:avLst/>
-          </a:prstGeom>
-          <a:noFill/>
-          <a:ln/>
-        </p:spPr>
-        <p:txBody>
-          <a:bodyPr wrap="square" lIns="0" tIns="0" rIns="0" bIns="0" rtlCol="0" anchor="ctr"/>
-          <a:lstStyle/>
-          <a:p>
-            <a:pPr indent="0" marL="0">
-              <a:buNone/>
-            </a:pPr>
-            <a:r>
-              <a:rPr lang="en-US" sz="1600" b="1" dirty="0">
+            <a:off x="548640" y="5029200"/>
+            <a:ext cx="5486400" cy="548640"/>
+          </a:xfrm>
+          <a:prstGeom prst="rect">
+            <a:avLst/>
+          </a:prstGeom>
+          <a:noFill/>
+          <a:ln/>
+        </p:spPr>
+        <p:txBody>
+          <a:bodyPr wrap="square" lIns="0" tIns="0" rIns="0" bIns="0" rtlCol="0" anchor="ctr"/>
+          <a:lstStyle/>
+          <a:p>
+            <a:pPr indent="0" marL="0">
+              <a:buNone/>
+            </a:pPr>
+            <a:r>
+              <a:rPr lang="en-US" sz="1500" b="1" dirty="0">
                 <a:solidFill>
                   <a:srgbClr val="1B4B8F"/>
                 </a:solidFill>
@@ -6792,7 +6792,7 @@
               <a:buNone/>
             </a:pPr>
             <a:r>
-              <a:rPr lang="en-US" sz="1500" dirty="0">
+              <a:rPr lang="en-US" sz="1400" dirty="0">
                 <a:solidFill>
                   <a:srgbClr val="1B2A4A"/>
                 </a:solidFill>
@@ -6800,9 +6800,9 @@
                 <a:ea typeface="Arial" pitchFamily="34" charset="-122"/>
                 <a:cs typeface="Arial" pitchFamily="34" charset="-120"/>
               </a:rPr>
-              <a:t>cada modelo vence em especialidades diferentes. Não existe 'o melhor' — existe o melhor por domínio.</a:t>
-            </a:r>
-            <a:endParaRPr lang="en-US" sz="1600" dirty="0"/>
+              <a:t>cada modelo vence em especialidades diferentes — não existe 'o melhor'.</a:t>
+            </a:r>
+            <a:endParaRPr lang="en-US" sz="1500" dirty="0"/>
           </a:p>
         </p:txBody>
       </p:sp>
@@ -6814,24 +6814,24 @@
         </p:nvSpPr>
         <p:spPr>
           <a:xfrm>
-            <a:off x="548640" y="5669280"/>
-            <a:ext cx="5486400" cy="548640"/>
-          </a:xfrm>
-          <a:prstGeom prst="rect">
-            <a:avLst/>
-          </a:prstGeom>
-          <a:noFill/>
-          <a:ln/>
-        </p:spPr>
-        <p:txBody>
-          <a:bodyPr wrap="square" lIns="0" tIns="0" rIns="0" bIns="0" rtlCol="0" anchor="ctr"/>
-          <a:lstStyle/>
-          <a:p>
-            <a:pPr indent="0" marL="0">
-              <a:buNone/>
-            </a:pPr>
-            <a:r>
-              <a:rPr lang="en-US" sz="1600" b="1" dirty="0">
+            <a:off x="548640" y="5577840"/>
+            <a:ext cx="5486400" cy="457200"/>
+          </a:xfrm>
+          <a:prstGeom prst="rect">
+            <a:avLst/>
+          </a:prstGeom>
+          <a:noFill/>
+          <a:ln/>
+        </p:spPr>
+        <p:txBody>
+          <a:bodyPr wrap="square" lIns="0" tIns="0" rIns="0" bIns="0" rtlCol="0" anchor="ctr"/>
+          <a:lstStyle/>
+          <a:p>
+            <a:pPr indent="0" marL="0">
+              <a:buNone/>
+            </a:pPr>
+            <a:r>
+              <a:rPr lang="en-US" sz="1500" b="1" dirty="0">
                 <a:solidFill>
                   <a:srgbClr val="1B4B8F"/>
                 </a:solidFill>
@@ -6839,13 +6839,13 @@
                 <a:ea typeface="Arial" pitchFamily="34" charset="-122"/>
                 <a:cs typeface="Arial" pitchFamily="34" charset="-120"/>
               </a:rPr>
-              <a:t>A arquitetura correta: </a:t>
-            </a:r>
-            <a:pPr indent="0" marL="0">
-              <a:buNone/>
-            </a:pPr>
-            <a:r>
-              <a:rPr lang="en-US" sz="1500" dirty="0">
+              <a:t>A arquitetura: </a:t>
+            </a:r>
+            <a:pPr indent="0" marL="0">
+              <a:buNone/>
+            </a:pPr>
+            <a:r>
+              <a:rPr lang="en-US" sz="1400" dirty="0">
                 <a:solidFill>
                   <a:srgbClr val="1B2A4A"/>
                 </a:solidFill>
@@ -6853,9 +6853,9 @@
                 <a:ea typeface="Arial" pitchFamily="34" charset="-122"/>
                 <a:cs typeface="Arial" pitchFamily="34" charset="-120"/>
               </a:rPr>
-              <a:t>roteamento multi-modelo por especialidade — cada pergunta vai ao especialista certo.</a:t>
-            </a:r>
-            <a:endParaRPr lang="en-US" sz="1600" dirty="0"/>
+              <a:t>roteamento multi-modelo por especialidade.</a:t>
+            </a:r>
+            <a:endParaRPr lang="en-US" sz="1500" dirty="0"/>
           </a:p>
         </p:txBody>
       </p:sp>
@@ -6867,34 +6867,48 @@
         </p:nvSpPr>
         <p:spPr>
           <a:xfrm>
-            <a:off x="6858000" y="4937760"/>
-            <a:ext cx="4846320" cy="731520"/>
-          </a:xfrm>
-          <a:prstGeom prst="rect">
-            <a:avLst/>
-          </a:prstGeom>
-          <a:noFill/>
-          <a:ln/>
-        </p:spPr>
-        <p:txBody>
-          <a:bodyPr wrap="square" lIns="0" tIns="0" rIns="0" bIns="0" rtlCol="0" anchor="ctr"/>
-          <a:lstStyle/>
-          <a:p>
+            <a:off x="6858000" y="5029200"/>
+            <a:ext cx="4846320" cy="548640"/>
+          </a:xfrm>
+          <a:prstGeom prst="rect">
+            <a:avLst/>
+          </a:prstGeom>
+          <a:noFill/>
+          <a:ln/>
+        </p:spPr>
+        <p:txBody>
+          <a:bodyPr wrap="square" lIns="0" tIns="0" rIns="0" bIns="0" rtlCol="0" anchor="ctr"/>
+          <a:lstStyle/>
+          <a:p>
+            <a:pPr indent="0" marL="0">
+              <a:buNone/>
+            </a:pPr>
+            <a:r>
+              <a:rPr lang="en-US" sz="1400" b="1" dirty="0">
+                <a:solidFill>
+                  <a:srgbClr val="DC2626"/>
+                </a:solidFill>
+                <a:latin typeface="Arial" pitchFamily="34" charset="0"/>
+                <a:ea typeface="Arial" pitchFamily="34" charset="-122"/>
+                <a:cs typeface="Arial" pitchFamily="34" charset="-120"/>
+              </a:rPr>
+              <a:t>Red-team: </a:t>
+            </a:r>
             <a:pPr indent="0" marL="0">
               <a:buNone/>
             </a:pPr>
             <a:r>
               <a:rPr lang="en-US" sz="1300" dirty="0">
                 <a:solidFill>
-                  <a:srgbClr val="6B7280"/>
-                </a:solidFill>
-                <a:latin typeface="Arial" pitchFamily="34" charset="0"/>
-                <a:ea typeface="Arial" pitchFamily="34" charset="-122"/>
-                <a:cs typeface="Arial" pitchFamily="34" charset="-120"/>
-              </a:rPr>
-              <a:t>Red-team: 10/10 modelos falharam sem guardrail. Granite Guardian: 100% interceptado.</a:t>
-            </a:r>
-            <a:endParaRPr lang="en-US" sz="1300" dirty="0"/>
+                  <a:srgbClr val="1B2A4A"/>
+                </a:solidFill>
+                <a:latin typeface="Arial" pitchFamily="34" charset="0"/>
+                <a:ea typeface="Arial" pitchFamily="34" charset="-122"/>
+                <a:cs typeface="Arial" pitchFamily="34" charset="-120"/>
+              </a:rPr>
+              <a:t>10/10 modelos falharam. Granite Guardian: 100%.</a:t>
+            </a:r>
+            <a:endParaRPr lang="en-US" sz="1400" dirty="0"/>
           </a:p>
         </p:txBody>
       </p:sp>
@@ -6906,34 +6920,101 @@
         </p:nvSpPr>
         <p:spPr>
           <a:xfrm>
-            <a:off x="6858000" y="5669280"/>
-            <a:ext cx="4846320" cy="548640"/>
-          </a:xfrm>
-          <a:prstGeom prst="rect">
-            <a:avLst/>
-          </a:prstGeom>
-          <a:noFill/>
-          <a:ln/>
-        </p:spPr>
-        <p:txBody>
-          <a:bodyPr wrap="square" lIns="0" tIns="0" rIns="0" bIns="0" rtlCol="0" anchor="ctr"/>
-          <a:lstStyle/>
-          <a:p>
+            <a:off x="6858000" y="5577840"/>
+            <a:ext cx="4846320" cy="457200"/>
+          </a:xfrm>
+          <a:prstGeom prst="rect">
+            <a:avLst/>
+          </a:prstGeom>
+          <a:noFill/>
+          <a:ln/>
+        </p:spPr>
+        <p:txBody>
+          <a:bodyPr wrap="square" lIns="0" tIns="0" rIns="0" bIns="0" rtlCol="0" anchor="ctr"/>
+          <a:lstStyle/>
+          <a:p>
+            <a:pPr indent="0" marL="0">
+              <a:buNone/>
+            </a:pPr>
+            <a:r>
+              <a:rPr lang="en-US" sz="1400" b="1" dirty="0">
+                <a:solidFill>
+                  <a:srgbClr val="1B4B8F"/>
+                </a:solidFill>
+                <a:latin typeface="Arial" pitchFamily="34" charset="0"/>
+                <a:ea typeface="Arial" pitchFamily="34" charset="-122"/>
+                <a:cs typeface="Arial" pitchFamily="34" charset="-120"/>
+              </a:rPr>
+              <a:t>Cobertura SP: </a:t>
+            </a:r>
             <a:pPr indent="0" marL="0">
               <a:buNone/>
             </a:pPr>
             <a:r>
               <a:rPr lang="en-US" sz="1300" dirty="0">
                 <a:solidFill>
-                  <a:srgbClr val="6B7280"/>
-                </a:solidFill>
-                <a:latin typeface="Arial" pitchFamily="34" charset="0"/>
-                <a:ea typeface="Arial" pitchFamily="34" charset="-122"/>
-                <a:cs typeface="Arial" pitchFamily="34" charset="-120"/>
-              </a:rPr>
-              <a:t>AI General-purpose + LLM Inference: US$ 6.000/mês em SPs ativos cobrindo API.</a:t>
-            </a:r>
-            <a:endParaRPr lang="en-US" sz="1300" dirty="0"/>
+                  <a:srgbClr val="1B2A4A"/>
+                </a:solidFill>
+                <a:latin typeface="Arial" pitchFamily="34" charset="0"/>
+                <a:ea typeface="Arial" pitchFamily="34" charset="-122"/>
+                <a:cs typeface="Arial" pitchFamily="34" charset="-120"/>
+              </a:rPr>
+              <a:t>US$ 6.000/mês ativos cobrindo toda a API.</a:t>
+            </a:r>
+            <a:endParaRPr lang="en-US" sz="1400" dirty="0"/>
+          </a:p>
+        </p:txBody>
+      </p:sp>
+      <p:sp>
+        <p:nvSpPr>
+          <p:cNvPr id="12" name="Text 9"/>
+          <p:cNvSpPr/>
+          <p:nvPr/>
+        </p:nvSpPr>
+        <p:spPr>
+          <a:xfrm>
+            <a:off x="6858000" y="6035040"/>
+            <a:ext cx="4846320" cy="365760"/>
+          </a:xfrm>
+          <a:prstGeom prst="rect">
+            <a:avLst/>
+          </a:prstGeom>
+          <a:noFill/>
+          <a:ln/>
+        </p:spPr>
+        <p:txBody>
+          <a:bodyPr wrap="square" lIns="0" tIns="0" rIns="0" bIns="0" rtlCol="0" anchor="ctr"/>
+          <a:lstStyle/>
+          <a:p>
+            <a:pPr indent="0" marL="0">
+              <a:buNone/>
+            </a:pPr>
+            <a:r>
+              <a:rPr lang="en-US" sz="1400" b="1" dirty="0">
+                <a:solidFill>
+                  <a:srgbClr val="1B4B8F"/>
+                </a:solidFill>
+                <a:latin typeface="Arial" pitchFamily="34" charset="0"/>
+                <a:ea typeface="Arial" pitchFamily="34" charset="-122"/>
+                <a:cs typeface="Arial" pitchFamily="34" charset="-120"/>
+              </a:rPr>
+              <a:t>Segurança: </a:t>
+            </a:r>
+            <a:pPr indent="0" marL="0">
+              <a:buNone/>
+            </a:pPr>
+            <a:r>
+              <a:rPr lang="en-US" sz="1300" dirty="0">
+                <a:solidFill>
+                  <a:srgbClr val="1B2A4A"/>
+                </a:solidFill>
+                <a:latin typeface="Arial" pitchFamily="34" charset="0"/>
+                <a:ea typeface="Arial" pitchFamily="34" charset="-122"/>
+                <a:cs typeface="Arial" pitchFamily="34" charset="-120"/>
+              </a:rPr>
+              <a:t>PII removida antes de qualquer modelo. Trilha completa LGPD.</a:t>
+            </a:r>
+            <a:endParaRPr lang="en-US" sz="1400" dirty="0"/>
           </a:p>
         </p:txBody>
       </p:sp>
@@ -8385,7 +8466,7 @@
         </p:nvSpPr>
         <p:spPr>
           <a:xfrm>
-            <a:off x="548640" y="5852160"/>
+            <a:off x="548640" y="5486400"/>
             <a:ext cx="11091672" cy="457200"/>
           </a:xfrm>
           <a:prstGeom prst="rect">
@@ -8425,6 +8506,59 @@
                 <a:cs typeface="Arial" pitchFamily="34" charset="-120"/>
               </a:rPr>
               <a:t>infraestrutura, disponibilidade, monitoramento, manutenção.</a:t>
+            </a:r>
+            <a:endParaRPr lang="en-US" sz="1400" dirty="0"/>
+          </a:p>
+        </p:txBody>
+      </p:sp>
+      <p:sp>
+        <p:nvSpPr>
+          <p:cNvPr id="10" name="Text 7"/>
+          <p:cNvSpPr/>
+          <p:nvPr/>
+        </p:nvSpPr>
+        <p:spPr>
+          <a:xfrm>
+            <a:off x="548640" y="5943600"/>
+            <a:ext cx="11091672" cy="640080"/>
+          </a:xfrm>
+          <a:prstGeom prst="rect">
+            <a:avLst/>
+          </a:prstGeom>
+          <a:noFill/>
+          <a:ln/>
+        </p:spPr>
+        <p:txBody>
+          <a:bodyPr wrap="square" lIns="0" tIns="0" rIns="0" bIns="0" rtlCol="0" anchor="ctr"/>
+          <a:lstStyle/>
+          <a:p>
+            <a:pPr indent="0" marL="0">
+              <a:buNone/>
+            </a:pPr>
+            <a:r>
+              <a:rPr lang="en-US" sz="1400" b="1" dirty="0">
+                <a:solidFill>
+                  <a:srgbClr val="1B4B8F"/>
+                </a:solidFill>
+                <a:latin typeface="Arial" pitchFamily="34" charset="0"/>
+                <a:ea typeface="Arial" pitchFamily="34" charset="-122"/>
+                <a:cs typeface="Arial" pitchFamily="34" charset="-120"/>
+              </a:rPr>
+              <a:t>Ferramenta: </a:t>
+            </a:r>
+            <a:pPr indent="0" marL="0">
+              <a:buNone/>
+            </a:pPr>
+            <a:r>
+              <a:rPr lang="en-US" sz="1400" dirty="0">
+                <a:solidFill>
+                  <a:srgbClr val="1B2A4A"/>
+                </a:solidFill>
+                <a:latin typeface="Arial" pitchFamily="34" charset="0"/>
+                <a:ea typeface="Arial" pitchFamily="34" charset="-122"/>
+                <a:cs typeface="Arial" pitchFamily="34" charset="-120"/>
+              </a:rPr>
+              <a:t>o Einstein.Cloud não é um produto da BeansTech — é uma plataforma do Einstein, construída com apoio técnico da BeansTech. A marca, a governança e os dados são do Einstein.</a:t>
             </a:r>
             <a:endParaRPr lang="en-US" sz="1400" dirty="0"/>
           </a:p>

</xml_diff>

<commit_message>
14 imagens AI geradas via wan2.7-image (Model Studio): 10 portais + 2 casos clínicos + ecosystem + infra
</commit_message>
<xml_diff>
--- a/apresentacoes/Einstein_Cloud_Apresentacao.pptx
+++ b/apresentacoes/Einstein_Cloud_Apresentacao.pptx
@@ -6116,7 +6116,7 @@
                 <a:ea typeface="Arial" pitchFamily="34" charset="-122"/>
                 <a:cs typeface="Arial" pitchFamily="34" charset="-120"/>
               </a:rPr>
-              <a:t>10 modelos, 23 especialidades, 2.000 avaliações</a:t>
+              <a:t>10 modelos, 23 especialidades, 2.000 avaliações — o maior teste de LLM para medicina em PT-BR</a:t>
             </a:r>
             <a:endParaRPr lang="en-US" sz="1500" dirty="0"/>
           </a:p>
@@ -6137,7 +6137,7 @@
           </p:nvPr>
         </p:nvGraphicFramePr>
         <p:xfrm>
-          <a:off x="548640" y="1371600"/>
+          <a:off x="548640" y="1463040"/>
           <a:ext cx="11091672" cy="914400"/>
         </p:xfrm>
         <a:graphic>
@@ -6145,12 +6145,12 @@
             <a:tbl>
               <a:tblPr/>
               <a:tblGrid>
-                <a:gridCol w="2772918"/>
-                <a:gridCol w="2772918"/>
-                <a:gridCol w="2772918"/>
-                <a:gridCol w="2772918"/>
+                <a:gridCol w="3657600"/>
+                <a:gridCol w="1645920"/>
+                <a:gridCol w="1188720"/>
+                <a:gridCol w="1764792"/>
               </a:tblGrid>
-              <a:tr h="548640">
+              <a:tr h="502920">
                 <a:tc>
                   <a:txBody>
                     <a:bodyPr/>
@@ -6160,7 +6160,7 @@
                         <a:buNone/>
                       </a:pPr>
                       <a:r>
-                        <a:rPr lang="en-US" sz="1300" b="1" dirty="0">
+                        <a:rPr lang="en-US" sz="1400" b="1" dirty="0">
                           <a:solidFill>
                             <a:srgbClr val="FFFFFF"/>
                           </a:solidFill>
@@ -6170,7 +6170,7 @@
                         </a:rPr>
                         <a:t>Modelo</a:t>
                       </a:r>
-                      <a:endParaRPr lang="en-US" sz="1300" dirty="0">
+                      <a:endParaRPr lang="en-US" sz="1400" dirty="0">
                         <a:latin typeface="Arial" charset="0"/>
                         <a:ea typeface="Arial" charset="0"/>
                         <a:cs typeface="Arial" charset="0"/>
@@ -6228,7 +6228,7 @@
                         <a:buNone/>
                       </a:pPr>
                       <a:r>
-                        <a:rPr lang="en-US" sz="1300" b="1" dirty="0">
+                        <a:rPr lang="en-US" sz="1400" b="1" dirty="0">
                           <a:solidFill>
                             <a:srgbClr val="FFFFFF"/>
                           </a:solidFill>
@@ -6238,7 +6238,7 @@
                         </a:rPr>
                         <a:t>Coverage</a:t>
                       </a:r>
-                      <a:endParaRPr lang="en-US" sz="1300" dirty="0">
+                      <a:endParaRPr lang="en-US" sz="1400" dirty="0">
                         <a:latin typeface="Arial" charset="0"/>
                         <a:ea typeface="Arial" charset="0"/>
                         <a:cs typeface="Arial" charset="0"/>
@@ -6296,7 +6296,7 @@
                         <a:buNone/>
                       </a:pPr>
                       <a:r>
-                        <a:rPr lang="en-US" sz="1300" b="1" dirty="0">
+                        <a:rPr lang="en-US" sz="1400" b="1" dirty="0">
                           <a:solidFill>
                             <a:srgbClr val="FFFFFF"/>
                           </a:solidFill>
@@ -6304,9 +6304,9 @@
                           <a:ea typeface="Arial" pitchFamily="34" charset="-122"/>
                           <a:cs typeface="Arial" pitchFamily="34" charset="-120"/>
                         </a:rPr>
-                        <a:t>Abstenções</a:t>
+                        <a:t>Abst.</a:t>
                       </a:r>
-                      <a:endParaRPr lang="en-US" sz="1300" dirty="0">
+                      <a:endParaRPr lang="en-US" sz="1400" dirty="0">
                         <a:latin typeface="Arial" charset="0"/>
                         <a:ea typeface="Arial" charset="0"/>
                         <a:cs typeface="Arial" charset="0"/>
@@ -6364,7 +6364,7 @@
                         <a:buNone/>
                       </a:pPr>
                       <a:r>
-                        <a:rPr lang="en-US" sz="1300" b="1" dirty="0">
+                        <a:rPr lang="en-US" sz="1400" b="1" dirty="0">
                           <a:solidFill>
                             <a:srgbClr val="FFFFFF"/>
                           </a:solidFill>
@@ -6374,7 +6374,7 @@
                         </a:rPr>
                         <a:t>Velocidade</a:t>
                       </a:r>
-                      <a:endParaRPr lang="en-US" sz="1300" dirty="0">
+                      <a:endParaRPr lang="en-US" sz="1400" dirty="0">
                         <a:latin typeface="Arial" charset="0"/>
                         <a:ea typeface="Arial" charset="0"/>
                         <a:cs typeface="Arial" charset="0"/>
@@ -6424,7 +6424,57 @@
                   </a:tcPr>
                 </a:tc>
               </a:tr>
-              <a:tr h="548640">
+              <a:tr h="502920">
+                <a:tc>
+                  <a:txBody>
+                    <a:bodyPr/>
+                    <a:lstStyle/>
+                    <a:p>
+                      <a:pPr indent="0" marL="0">
+                        <a:buNone/>
+                      </a:pPr>
+                      <a:endParaRPr lang="en-US" sz="1200" dirty="0"/>
+                    </a:p>
+                  </a:txBody>
+                  <a:tcPr marL="91440" marR="91440" marT="45720" marB="45720">
+                    <a:lnL w="6350" cap="flat" cmpd="sng" algn="ctr">
+                      <a:solidFill>
+                        <a:srgbClr val="E5E7EB"/>
+                      </a:solidFill>
+                      <a:prstDash val="solid"/>
+                      <a:round/>
+                      <a:headEnd type="none" w="med" len="med"/>
+                      <a:tailEnd type="none" w="med" len="med"/>
+                    </a:lnL>
+                    <a:lnR w="6350" cap="flat" cmpd="sng" algn="ctr">
+                      <a:solidFill>
+                        <a:srgbClr val="E5E7EB"/>
+                      </a:solidFill>
+                      <a:prstDash val="solid"/>
+                      <a:round/>
+                      <a:headEnd type="none" w="med" len="med"/>
+                      <a:tailEnd type="none" w="med" len="med"/>
+                    </a:lnR>
+                    <a:lnT w="6350" cap="flat" cmpd="sng" algn="ctr">
+                      <a:solidFill>
+                        <a:srgbClr val="E5E7EB"/>
+                      </a:solidFill>
+                      <a:prstDash val="solid"/>
+                      <a:round/>
+                      <a:headEnd type="none" w="med" len="med"/>
+                      <a:tailEnd type="none" w="med" len="med"/>
+                    </a:lnT>
+                    <a:lnB w="6350" cap="flat" cmpd="sng" algn="ctr">
+                      <a:solidFill>
+                        <a:srgbClr val="E5E7EB"/>
+                      </a:solidFill>
+                      <a:prstDash val="solid"/>
+                      <a:round/>
+                      <a:headEnd type="none" w="med" len="med"/>
+                      <a:tailEnd type="none" w="med" len="med"/>
+                    </a:lnB>
+                  </a:tcPr>
+                </a:tc>
                 <a:tc>
                   <a:txBody>
                     <a:bodyPr/>
@@ -6738,7 +6788,7 @@
         </p:nvSpPr>
         <p:spPr>
           <a:xfrm>
-            <a:off x="548640" y="4846320"/>
+            <a:off x="548640" y="5303520"/>
             <a:ext cx="11091672" cy="0"/>
           </a:xfrm>
           <a:prstGeom prst="line">
@@ -6761,8 +6811,8 @@
         </p:nvSpPr>
         <p:spPr>
           <a:xfrm>
-            <a:off x="548640" y="5029200"/>
-            <a:ext cx="5486400" cy="548640"/>
+            <a:off x="548640" y="5486400"/>
+            <a:ext cx="5943600" cy="731520"/>
           </a:xfrm>
           <a:prstGeom prst="rect">
             <a:avLst/>
@@ -6800,7 +6850,7 @@
                 <a:ea typeface="Arial" pitchFamily="34" charset="-122"/>
                 <a:cs typeface="Arial" pitchFamily="34" charset="-120"/>
               </a:rPr>
-              <a:t>cada modelo vence em especialidades diferentes — não existe 'o melhor'.</a:t>
+              <a:t>cada modelo vence em especialidades diferentes — não existe 'o melhor'. A arquitetura correta é roteamento multi-modelo por especialidade.</a:t>
             </a:r>
             <a:endParaRPr lang="en-US" sz="1500" dirty="0"/>
           </a:p>
@@ -6814,24 +6864,77 @@
         </p:nvSpPr>
         <p:spPr>
           <a:xfrm>
-            <a:off x="548640" y="5577840"/>
-            <a:ext cx="5486400" cy="457200"/>
-          </a:xfrm>
-          <a:prstGeom prst="rect">
-            <a:avLst/>
-          </a:prstGeom>
-          <a:noFill/>
-          <a:ln/>
-        </p:spPr>
-        <p:txBody>
-          <a:bodyPr wrap="square" lIns="0" tIns="0" rIns="0" bIns="0" rtlCol="0" anchor="ctr"/>
-          <a:lstStyle/>
-          <a:p>
-            <a:pPr indent="0" marL="0">
-              <a:buNone/>
-            </a:pPr>
-            <a:r>
-              <a:rPr lang="en-US" sz="1500" b="1" dirty="0">
+            <a:off x="6858000" y="5486400"/>
+            <a:ext cx="4846320" cy="457200"/>
+          </a:xfrm>
+          <a:prstGeom prst="rect">
+            <a:avLst/>
+          </a:prstGeom>
+          <a:noFill/>
+          <a:ln/>
+        </p:spPr>
+        <p:txBody>
+          <a:bodyPr wrap="square" lIns="0" tIns="0" rIns="0" bIns="0" rtlCol="0" anchor="ctr"/>
+          <a:lstStyle/>
+          <a:p>
+            <a:pPr indent="0" marL="0">
+              <a:buNone/>
+            </a:pPr>
+            <a:r>
+              <a:rPr lang="en-US" sz="1400" b="1" dirty="0">
+                <a:solidFill>
+                  <a:srgbClr val="DC2626"/>
+                </a:solidFill>
+                <a:latin typeface="Arial" pitchFamily="34" charset="0"/>
+                <a:ea typeface="Arial" pitchFamily="34" charset="-122"/>
+                <a:cs typeface="Arial" pitchFamily="34" charset="-120"/>
+              </a:rPr>
+              <a:t>Red-team: </a:t>
+            </a:r>
+            <a:pPr indent="0" marL="0">
+              <a:buNone/>
+            </a:pPr>
+            <a:r>
+              <a:rPr lang="en-US" sz="1300" dirty="0">
+                <a:solidFill>
+                  <a:srgbClr val="1B2A4A"/>
+                </a:solidFill>
+                <a:latin typeface="Arial" pitchFamily="34" charset="0"/>
+                <a:ea typeface="Arial" pitchFamily="34" charset="-122"/>
+                <a:cs typeface="Arial" pitchFamily="34" charset="-120"/>
+              </a:rPr>
+              <a:t>10/10 falharam. Granite Guardian: 100%.</a:t>
+            </a:r>
+            <a:endParaRPr lang="en-US" sz="1400" dirty="0"/>
+          </a:p>
+        </p:txBody>
+      </p:sp>
+      <p:sp>
+        <p:nvSpPr>
+          <p:cNvPr id="10" name="Text 7"/>
+          <p:cNvSpPr/>
+          <p:nvPr/>
+        </p:nvSpPr>
+        <p:spPr>
+          <a:xfrm>
+            <a:off x="6858000" y="5943600"/>
+            <a:ext cx="4846320" cy="365760"/>
+          </a:xfrm>
+          <a:prstGeom prst="rect">
+            <a:avLst/>
+          </a:prstGeom>
+          <a:noFill/>
+          <a:ln/>
+        </p:spPr>
+        <p:txBody>
+          <a:bodyPr wrap="square" lIns="0" tIns="0" rIns="0" bIns="0" rtlCol="0" anchor="ctr"/>
+          <a:lstStyle/>
+          <a:p>
+            <a:pPr indent="0" marL="0">
+              <a:buNone/>
+            </a:pPr>
+            <a:r>
+              <a:rPr lang="en-US" sz="1400" b="1" dirty="0">
                 <a:solidFill>
                   <a:srgbClr val="1B4B8F"/>
                 </a:solidFill>
@@ -6839,13 +6942,13 @@
                 <a:ea typeface="Arial" pitchFamily="34" charset="-122"/>
                 <a:cs typeface="Arial" pitchFamily="34" charset="-120"/>
               </a:rPr>
-              <a:t>A arquitetura: </a:t>
-            </a:r>
-            <a:pPr indent="0" marL="0">
-              <a:buNone/>
-            </a:pPr>
-            <a:r>
-              <a:rPr lang="en-US" sz="1400" dirty="0">
+              <a:t>SPs ativos: </a:t>
+            </a:r>
+            <a:pPr indent="0" marL="0">
+              <a:buNone/>
+            </a:pPr>
+            <a:r>
+              <a:rPr lang="en-US" sz="1300" dirty="0">
                 <a:solidFill>
                   <a:srgbClr val="1B2A4A"/>
                 </a:solidFill>
@@ -6853,166 +6956,7 @@
                 <a:ea typeface="Arial" pitchFamily="34" charset="-122"/>
                 <a:cs typeface="Arial" pitchFamily="34" charset="-120"/>
               </a:rPr>
-              <a:t>roteamento multi-modelo por especialidade.</a:t>
-            </a:r>
-            <a:endParaRPr lang="en-US" sz="1500" dirty="0"/>
-          </a:p>
-        </p:txBody>
-      </p:sp>
-      <p:sp>
-        <p:nvSpPr>
-          <p:cNvPr id="10" name="Text 7"/>
-          <p:cNvSpPr/>
-          <p:nvPr/>
-        </p:nvSpPr>
-        <p:spPr>
-          <a:xfrm>
-            <a:off x="6858000" y="5029200"/>
-            <a:ext cx="4846320" cy="548640"/>
-          </a:xfrm>
-          <a:prstGeom prst="rect">
-            <a:avLst/>
-          </a:prstGeom>
-          <a:noFill/>
-          <a:ln/>
-        </p:spPr>
-        <p:txBody>
-          <a:bodyPr wrap="square" lIns="0" tIns="0" rIns="0" bIns="0" rtlCol="0" anchor="ctr"/>
-          <a:lstStyle/>
-          <a:p>
-            <a:pPr indent="0" marL="0">
-              <a:buNone/>
-            </a:pPr>
-            <a:r>
-              <a:rPr lang="en-US" sz="1400" b="1" dirty="0">
-                <a:solidFill>
-                  <a:srgbClr val="DC2626"/>
-                </a:solidFill>
-                <a:latin typeface="Arial" pitchFamily="34" charset="0"/>
-                <a:ea typeface="Arial" pitchFamily="34" charset="-122"/>
-                <a:cs typeface="Arial" pitchFamily="34" charset="-120"/>
-              </a:rPr>
-              <a:t>Red-team: </a:t>
-            </a:r>
-            <a:pPr indent="0" marL="0">
-              <a:buNone/>
-            </a:pPr>
-            <a:r>
-              <a:rPr lang="en-US" sz="1300" dirty="0">
-                <a:solidFill>
-                  <a:srgbClr val="1B2A4A"/>
-                </a:solidFill>
-                <a:latin typeface="Arial" pitchFamily="34" charset="0"/>
-                <a:ea typeface="Arial" pitchFamily="34" charset="-122"/>
-                <a:cs typeface="Arial" pitchFamily="34" charset="-120"/>
-              </a:rPr>
-              <a:t>10/10 modelos falharam. Granite Guardian: 100%.</a:t>
-            </a:r>
-            <a:endParaRPr lang="en-US" sz="1400" dirty="0"/>
-          </a:p>
-        </p:txBody>
-      </p:sp>
-      <p:sp>
-        <p:nvSpPr>
-          <p:cNvPr id="11" name="Text 8"/>
-          <p:cNvSpPr/>
-          <p:nvPr/>
-        </p:nvSpPr>
-        <p:spPr>
-          <a:xfrm>
-            <a:off x="6858000" y="5577840"/>
-            <a:ext cx="4846320" cy="457200"/>
-          </a:xfrm>
-          <a:prstGeom prst="rect">
-            <a:avLst/>
-          </a:prstGeom>
-          <a:noFill/>
-          <a:ln/>
-        </p:spPr>
-        <p:txBody>
-          <a:bodyPr wrap="square" lIns="0" tIns="0" rIns="0" bIns="0" rtlCol="0" anchor="ctr"/>
-          <a:lstStyle/>
-          <a:p>
-            <a:pPr indent="0" marL="0">
-              <a:buNone/>
-            </a:pPr>
-            <a:r>
-              <a:rPr lang="en-US" sz="1400" b="1" dirty="0">
-                <a:solidFill>
-                  <a:srgbClr val="1B4B8F"/>
-                </a:solidFill>
-                <a:latin typeface="Arial" pitchFamily="34" charset="0"/>
-                <a:ea typeface="Arial" pitchFamily="34" charset="-122"/>
-                <a:cs typeface="Arial" pitchFamily="34" charset="-120"/>
-              </a:rPr>
-              <a:t>Cobertura SP: </a:t>
-            </a:r>
-            <a:pPr indent="0" marL="0">
-              <a:buNone/>
-            </a:pPr>
-            <a:r>
-              <a:rPr lang="en-US" sz="1300" dirty="0">
-                <a:solidFill>
-                  <a:srgbClr val="1B2A4A"/>
-                </a:solidFill>
-                <a:latin typeface="Arial" pitchFamily="34" charset="0"/>
-                <a:ea typeface="Arial" pitchFamily="34" charset="-122"/>
-                <a:cs typeface="Arial" pitchFamily="34" charset="-120"/>
-              </a:rPr>
-              <a:t>US$ 6.000/mês ativos cobrindo toda a API.</a:t>
-            </a:r>
-            <a:endParaRPr lang="en-US" sz="1400" dirty="0"/>
-          </a:p>
-        </p:txBody>
-      </p:sp>
-      <p:sp>
-        <p:nvSpPr>
-          <p:cNvPr id="12" name="Text 9"/>
-          <p:cNvSpPr/>
-          <p:nvPr/>
-        </p:nvSpPr>
-        <p:spPr>
-          <a:xfrm>
-            <a:off x="6858000" y="6035040"/>
-            <a:ext cx="4846320" cy="365760"/>
-          </a:xfrm>
-          <a:prstGeom prst="rect">
-            <a:avLst/>
-          </a:prstGeom>
-          <a:noFill/>
-          <a:ln/>
-        </p:spPr>
-        <p:txBody>
-          <a:bodyPr wrap="square" lIns="0" tIns="0" rIns="0" bIns="0" rtlCol="0" anchor="ctr"/>
-          <a:lstStyle/>
-          <a:p>
-            <a:pPr indent="0" marL="0">
-              <a:buNone/>
-            </a:pPr>
-            <a:r>
-              <a:rPr lang="en-US" sz="1400" b="1" dirty="0">
-                <a:solidFill>
-                  <a:srgbClr val="1B4B8F"/>
-                </a:solidFill>
-                <a:latin typeface="Arial" pitchFamily="34" charset="0"/>
-                <a:ea typeface="Arial" pitchFamily="34" charset="-122"/>
-                <a:cs typeface="Arial" pitchFamily="34" charset="-120"/>
-              </a:rPr>
-              <a:t>Segurança: </a:t>
-            </a:r>
-            <a:pPr indent="0" marL="0">
-              <a:buNone/>
-            </a:pPr>
-            <a:r>
-              <a:rPr lang="en-US" sz="1300" dirty="0">
-                <a:solidFill>
-                  <a:srgbClr val="1B2A4A"/>
-                </a:solidFill>
-                <a:latin typeface="Arial" pitchFamily="34" charset="0"/>
-                <a:ea typeface="Arial" pitchFamily="34" charset="-122"/>
-                <a:cs typeface="Arial" pitchFamily="34" charset="-120"/>
-              </a:rPr>
-              <a:t>PII removida antes de qualquer modelo. Trilha completa LGPD.</a:t>
+              <a:t>US$ 6.000/mês cobrindo API.</a:t>
             </a:r>
             <a:endParaRPr lang="en-US" sz="1400" dirty="0"/>
           </a:p>
@@ -8095,6 +8039,45 @@
           </a:p>
         </p:txBody>
       </p:sp>
+      <p:sp>
+        <p:nvSpPr>
+          <p:cNvPr id="5" name="Text 3"/>
+          <p:cNvSpPr/>
+          <p:nvPr/>
+        </p:nvSpPr>
+        <p:spPr>
+          <a:xfrm>
+            <a:off x="548640" y="1097280"/>
+            <a:ext cx="11091672" cy="457200"/>
+          </a:xfrm>
+          <a:prstGeom prst="rect">
+            <a:avLst/>
+          </a:prstGeom>
+          <a:noFill/>
+          <a:ln/>
+        </p:spPr>
+        <p:txBody>
+          <a:bodyPr wrap="square" lIns="0" tIns="0" rIns="0" bIns="0" rtlCol="0" anchor="ctr"/>
+          <a:lstStyle/>
+          <a:p>
+            <a:pPr indent="0" marL="0">
+              <a:buNone/>
+            </a:pPr>
+            <a:r>
+              <a:rPr lang="en-US" sz="1500" dirty="0">
+                <a:solidFill>
+                  <a:srgbClr val="6B7280"/>
+                </a:solidFill>
+                <a:latin typeface="Arial" pitchFamily="34" charset="0"/>
+                <a:ea typeface="Arial" pitchFamily="34" charset="-122"/>
+                <a:cs typeface="Arial" pitchFamily="34" charset="-120"/>
+              </a:rPr>
+              <a:t>A BeansTech é coadjuvante na engenharia. O Einstein lidera na ciência, ética e decisão.</a:t>
+            </a:r>
+            <a:endParaRPr lang="en-US" sz="1500" dirty="0"/>
+          </a:p>
+        </p:txBody>
+      </p:sp>
       <p:graphicFrame>
         <p:nvGraphicFramePr>
           <p:cNvPr id="9" name="Table 0"/>
@@ -8110,7 +8093,7 @@
           </p:nvPr>
         </p:nvGraphicFramePr>
         <p:xfrm>
-          <a:off x="548640" y="1371600"/>
+          <a:off x="548640" y="1463040"/>
           <a:ext cx="11091672" cy="914400"/>
         </p:xfrm>
         <a:graphic>
@@ -8118,12 +8101,317 @@
             <a:tbl>
               <a:tblPr/>
               <a:tblGrid>
-                <a:gridCol w="2772918"/>
-                <a:gridCol w="2772918"/>
-                <a:gridCol w="2772918"/>
-                <a:gridCol w="2772918"/>
+                <a:gridCol w="3200400"/>
+                <a:gridCol w="4114800"/>
+                <a:gridCol w="4142232"/>
               </a:tblGrid>
-              <a:tr h="731520">
+              <a:tr h="502920">
+                <a:tc>
+                  <a:txBody>
+                    <a:bodyPr/>
+                    <a:lstStyle/>
+                    <a:p>
+                      <a:pPr indent="0" marL="0">
+                        <a:buNone/>
+                      </a:pPr>
+                      <a:r>
+                        <a:rPr lang="en-US" sz="1400" b="1" dirty="0">
+                          <a:solidFill>
+                            <a:srgbClr val="FFFFFF"/>
+                          </a:solidFill>
+                          <a:latin typeface="Arial" pitchFamily="34" charset="0"/>
+                          <a:ea typeface="Arial" pitchFamily="34" charset="-122"/>
+                          <a:cs typeface="Arial" pitchFamily="34" charset="-120"/>
+                        </a:rPr>
+                        <a:t>Função</a:t>
+                      </a:r>
+                      <a:endParaRPr lang="en-US" sz="1400" dirty="0">
+                        <a:latin typeface="Arial" charset="0"/>
+                        <a:ea typeface="Arial" charset="0"/>
+                        <a:cs typeface="Arial" charset="0"/>
+                      </a:endParaRPr>
+                    </a:p>
+                  </a:txBody>
+                  <a:tcPr marL="91440" marR="91440" marT="45720" marB="45720">
+                    <a:lnL w="6350" cap="flat" cmpd="sng" algn="ctr">
+                      <a:solidFill>
+                        <a:srgbClr val="E5E7EB"/>
+                      </a:solidFill>
+                      <a:prstDash val="solid"/>
+                      <a:round/>
+                      <a:headEnd type="none" w="med" len="med"/>
+                      <a:tailEnd type="none" w="med" len="med"/>
+                    </a:lnL>
+                    <a:lnR w="6350" cap="flat" cmpd="sng" algn="ctr">
+                      <a:solidFill>
+                        <a:srgbClr val="E5E7EB"/>
+                      </a:solidFill>
+                      <a:prstDash val="solid"/>
+                      <a:round/>
+                      <a:headEnd type="none" w="med" len="med"/>
+                      <a:tailEnd type="none" w="med" len="med"/>
+                    </a:lnR>
+                    <a:lnT w="6350" cap="flat" cmpd="sng" algn="ctr">
+                      <a:solidFill>
+                        <a:srgbClr val="E5E7EB"/>
+                      </a:solidFill>
+                      <a:prstDash val="solid"/>
+                      <a:round/>
+                      <a:headEnd type="none" w="med" len="med"/>
+                      <a:tailEnd type="none" w="med" len="med"/>
+                    </a:lnT>
+                    <a:lnB w="6350" cap="flat" cmpd="sng" algn="ctr">
+                      <a:solidFill>
+                        <a:srgbClr val="E5E7EB"/>
+                      </a:solidFill>
+                      <a:prstDash val="solid"/>
+                      <a:round/>
+                      <a:headEnd type="none" w="med" len="med"/>
+                      <a:tailEnd type="none" w="med" len="med"/>
+                    </a:lnB>
+                    <a:solidFill>
+                      <a:srgbClr val="0A1F3D"/>
+                    </a:solidFill>
+                  </a:tcPr>
+                </a:tc>
+                <a:tc>
+                  <a:txBody>
+                    <a:bodyPr/>
+                    <a:lstStyle/>
+                    <a:p>
+                      <a:pPr indent="0" marL="0">
+                        <a:buNone/>
+                      </a:pPr>
+                      <a:r>
+                        <a:rPr lang="en-US" sz="1400" b="1" dirty="0">
+                          <a:solidFill>
+                            <a:srgbClr val="FFFFFF"/>
+                          </a:solidFill>
+                          <a:latin typeface="Arial" pitchFamily="34" charset="0"/>
+                          <a:ea typeface="Arial" pitchFamily="34" charset="-122"/>
+                          <a:cs typeface="Arial" pitchFamily="34" charset="-120"/>
+                        </a:rPr>
+                        <a:t>Einstein</a:t>
+                      </a:r>
+                      <a:endParaRPr lang="en-US" sz="1400" dirty="0">
+                        <a:latin typeface="Arial" charset="0"/>
+                        <a:ea typeface="Arial" charset="0"/>
+                        <a:cs typeface="Arial" charset="0"/>
+                      </a:endParaRPr>
+                    </a:p>
+                  </a:txBody>
+                  <a:tcPr marL="91440" marR="91440" marT="45720" marB="45720">
+                    <a:lnL w="6350" cap="flat" cmpd="sng" algn="ctr">
+                      <a:solidFill>
+                        <a:srgbClr val="E5E7EB"/>
+                      </a:solidFill>
+                      <a:prstDash val="solid"/>
+                      <a:round/>
+                      <a:headEnd type="none" w="med" len="med"/>
+                      <a:tailEnd type="none" w="med" len="med"/>
+                    </a:lnL>
+                    <a:lnR w="6350" cap="flat" cmpd="sng" algn="ctr">
+                      <a:solidFill>
+                        <a:srgbClr val="E5E7EB"/>
+                      </a:solidFill>
+                      <a:prstDash val="solid"/>
+                      <a:round/>
+                      <a:headEnd type="none" w="med" len="med"/>
+                      <a:tailEnd type="none" w="med" len="med"/>
+                    </a:lnR>
+                    <a:lnT w="6350" cap="flat" cmpd="sng" algn="ctr">
+                      <a:solidFill>
+                        <a:srgbClr val="E5E7EB"/>
+                      </a:solidFill>
+                      <a:prstDash val="solid"/>
+                      <a:round/>
+                      <a:headEnd type="none" w="med" len="med"/>
+                      <a:tailEnd type="none" w="med" len="med"/>
+                    </a:lnT>
+                    <a:lnB w="6350" cap="flat" cmpd="sng" algn="ctr">
+                      <a:solidFill>
+                        <a:srgbClr val="E5E7EB"/>
+                      </a:solidFill>
+                      <a:prstDash val="solid"/>
+                      <a:round/>
+                      <a:headEnd type="none" w="med" len="med"/>
+                      <a:tailEnd type="none" w="med" len="med"/>
+                    </a:lnB>
+                    <a:solidFill>
+                      <a:srgbClr val="0A1F3D"/>
+                    </a:solidFill>
+                  </a:tcPr>
+                </a:tc>
+                <a:tc>
+                  <a:txBody>
+                    <a:bodyPr/>
+                    <a:lstStyle/>
+                    <a:p>
+                      <a:pPr indent="0" marL="0">
+                        <a:buNone/>
+                      </a:pPr>
+                      <a:r>
+                        <a:rPr lang="en-US" sz="1400" b="1" dirty="0">
+                          <a:solidFill>
+                            <a:srgbClr val="FFFFFF"/>
+                          </a:solidFill>
+                          <a:latin typeface="Arial" pitchFamily="34" charset="0"/>
+                          <a:ea typeface="Arial" pitchFamily="34" charset="-122"/>
+                          <a:cs typeface="Arial" pitchFamily="34" charset="-120"/>
+                        </a:rPr>
+                        <a:t>BeansTech</a:t>
+                      </a:r>
+                      <a:endParaRPr lang="en-US" sz="1400" dirty="0">
+                        <a:latin typeface="Arial" charset="0"/>
+                        <a:ea typeface="Arial" charset="0"/>
+                        <a:cs typeface="Arial" charset="0"/>
+                      </a:endParaRPr>
+                    </a:p>
+                  </a:txBody>
+                  <a:tcPr marL="91440" marR="91440" marT="45720" marB="45720">
+                    <a:lnL w="6350" cap="flat" cmpd="sng" algn="ctr">
+                      <a:solidFill>
+                        <a:srgbClr val="E5E7EB"/>
+                      </a:solidFill>
+                      <a:prstDash val="solid"/>
+                      <a:round/>
+                      <a:headEnd type="none" w="med" len="med"/>
+                      <a:tailEnd type="none" w="med" len="med"/>
+                    </a:lnL>
+                    <a:lnR w="6350" cap="flat" cmpd="sng" algn="ctr">
+                      <a:solidFill>
+                        <a:srgbClr val="E5E7EB"/>
+                      </a:solidFill>
+                      <a:prstDash val="solid"/>
+                      <a:round/>
+                      <a:headEnd type="none" w="med" len="med"/>
+                      <a:tailEnd type="none" w="med" len="med"/>
+                    </a:lnR>
+                    <a:lnT w="6350" cap="flat" cmpd="sng" algn="ctr">
+                      <a:solidFill>
+                        <a:srgbClr val="E5E7EB"/>
+                      </a:solidFill>
+                      <a:prstDash val="solid"/>
+                      <a:round/>
+                      <a:headEnd type="none" w="med" len="med"/>
+                      <a:tailEnd type="none" w="med" len="med"/>
+                    </a:lnT>
+                    <a:lnB w="6350" cap="flat" cmpd="sng" algn="ctr">
+                      <a:solidFill>
+                        <a:srgbClr val="E5E7EB"/>
+                      </a:solidFill>
+                      <a:prstDash val="solid"/>
+                      <a:round/>
+                      <a:headEnd type="none" w="med" len="med"/>
+                      <a:tailEnd type="none" w="med" len="med"/>
+                    </a:lnB>
+                    <a:solidFill>
+                      <a:srgbClr val="0A1F3D"/>
+                    </a:solidFill>
+                  </a:tcPr>
+                </a:tc>
+              </a:tr>
+              <a:tr h="502920">
+                <a:tc>
+                  <a:txBody>
+                    <a:bodyPr/>
+                    <a:lstStyle/>
+                    <a:p>
+                      <a:pPr indent="0" marL="0">
+                        <a:buNone/>
+                      </a:pPr>
+                      <a:endParaRPr lang="en-US" sz="1200" dirty="0"/>
+                    </a:p>
+                  </a:txBody>
+                  <a:tcPr marL="91440" marR="91440" marT="45720" marB="45720">
+                    <a:lnL w="6350" cap="flat" cmpd="sng" algn="ctr">
+                      <a:solidFill>
+                        <a:srgbClr val="E5E7EB"/>
+                      </a:solidFill>
+                      <a:prstDash val="solid"/>
+                      <a:round/>
+                      <a:headEnd type="none" w="med" len="med"/>
+                      <a:tailEnd type="none" w="med" len="med"/>
+                    </a:lnL>
+                    <a:lnR w="6350" cap="flat" cmpd="sng" algn="ctr">
+                      <a:solidFill>
+                        <a:srgbClr val="E5E7EB"/>
+                      </a:solidFill>
+                      <a:prstDash val="solid"/>
+                      <a:round/>
+                      <a:headEnd type="none" w="med" len="med"/>
+                      <a:tailEnd type="none" w="med" len="med"/>
+                    </a:lnR>
+                    <a:lnT w="6350" cap="flat" cmpd="sng" algn="ctr">
+                      <a:solidFill>
+                        <a:srgbClr val="E5E7EB"/>
+                      </a:solidFill>
+                      <a:prstDash val="solid"/>
+                      <a:round/>
+                      <a:headEnd type="none" w="med" len="med"/>
+                      <a:tailEnd type="none" w="med" len="med"/>
+                    </a:lnT>
+                    <a:lnB w="6350" cap="flat" cmpd="sng" algn="ctr">
+                      <a:solidFill>
+                        <a:srgbClr val="E5E7EB"/>
+                      </a:solidFill>
+                      <a:prstDash val="solid"/>
+                      <a:round/>
+                      <a:headEnd type="none" w="med" len="med"/>
+                      <a:tailEnd type="none" w="med" len="med"/>
+                    </a:lnB>
+                  </a:tcPr>
+                </a:tc>
+                <a:tc>
+                  <a:txBody>
+                    <a:bodyPr/>
+                    <a:lstStyle/>
+                    <a:p>
+                      <a:pPr indent="0" marL="0">
+                        <a:buNone/>
+                      </a:pPr>
+                      <a:endParaRPr lang="en-US" sz="1200" dirty="0"/>
+                    </a:p>
+                  </a:txBody>
+                  <a:tcPr marL="91440" marR="91440" marT="45720" marB="45720">
+                    <a:lnL w="6350" cap="flat" cmpd="sng" algn="ctr">
+                      <a:solidFill>
+                        <a:srgbClr val="E5E7EB"/>
+                      </a:solidFill>
+                      <a:prstDash val="solid"/>
+                      <a:round/>
+                      <a:headEnd type="none" w="med" len="med"/>
+                      <a:tailEnd type="none" w="med" len="med"/>
+                    </a:lnL>
+                    <a:lnR w="6350" cap="flat" cmpd="sng" algn="ctr">
+                      <a:solidFill>
+                        <a:srgbClr val="E5E7EB"/>
+                      </a:solidFill>
+                      <a:prstDash val="solid"/>
+                      <a:round/>
+                      <a:headEnd type="none" w="med" len="med"/>
+                      <a:tailEnd type="none" w="med" len="med"/>
+                    </a:lnR>
+                    <a:lnT w="6350" cap="flat" cmpd="sng" algn="ctr">
+                      <a:solidFill>
+                        <a:srgbClr val="E5E7EB"/>
+                      </a:solidFill>
+                      <a:prstDash val="solid"/>
+                      <a:round/>
+                      <a:headEnd type="none" w="med" len="med"/>
+                      <a:tailEnd type="none" w="med" len="med"/>
+                    </a:lnT>
+                    <a:lnB w="6350" cap="flat" cmpd="sng" algn="ctr">
+                      <a:solidFill>
+                        <a:srgbClr val="E5E7EB"/>
+                      </a:solidFill>
+                      <a:prstDash val="solid"/>
+                      <a:round/>
+                      <a:headEnd type="none" w="med" len="med"/>
+                      <a:tailEnd type="none" w="med" len="med"/>
+                    </a:lnB>
+                  </a:tcPr>
+                </a:tc>
                 <a:tc>
                   <a:txBody>
                     <a:bodyPr/>
@@ -8331,13 +8619,13 @@
       </p:graphicFrame>
       <p:sp>
         <p:nvSpPr>
-          <p:cNvPr id="6" name="Shape 3"/>
-          <p:cNvSpPr/>
-          <p:nvPr/>
-        </p:nvSpPr>
-        <p:spPr>
-          <a:xfrm>
-            <a:off x="548640" y="4572000"/>
+          <p:cNvPr id="7" name="Shape 4"/>
+          <p:cNvSpPr/>
+          <p:nvPr/>
+        </p:nvSpPr>
+        <p:spPr>
+          <a:xfrm>
+            <a:off x="548640" y="5029200"/>
             <a:ext cx="11091672" cy="0"/>
           </a:xfrm>
           <a:prstGeom prst="line">
@@ -8354,83 +8642,58 @@
       </p:sp>
       <p:sp>
         <p:nvSpPr>
-          <p:cNvPr id="7" name="Text 4"/>
-          <p:cNvSpPr/>
-          <p:nvPr/>
-        </p:nvSpPr>
-        <p:spPr>
-          <a:xfrm>
-            <a:off x="548640" y="4754880"/>
-            <a:ext cx="11091672" cy="548640"/>
-          </a:xfrm>
-          <a:prstGeom prst="rect">
-            <a:avLst/>
-          </a:prstGeom>
-          <a:noFill/>
-          <a:ln/>
-        </p:spPr>
-        <p:txBody>
-          <a:bodyPr wrap="square" lIns="0" tIns="0" rIns="0" bIns="0" rtlCol="0" anchor="ctr"/>
-          <a:lstStyle/>
-          <a:p>
-            <a:pPr indent="0" marL="0">
-              <a:buNone/>
-            </a:pPr>
-            <a:r>
-              <a:rPr lang="en-US" sz="1800" i="1" dirty="0">
-                <a:solidFill>
-                  <a:srgbClr val="C9A227"/>
-                </a:solidFill>
-                <a:latin typeface="Georgia" pitchFamily="34" charset="0"/>
-                <a:ea typeface="Georgia" pitchFamily="34" charset="-122"/>
-                <a:cs typeface="Georgia" pitchFamily="34" charset="-120"/>
-              </a:rPr>
-              <a:t>A BeansTech é mera coadjuvante. </a:t>
-            </a:r>
-            <a:pPr indent="0" marL="0">
-              <a:buNone/>
-            </a:pPr>
-            <a:r>
-              <a:rPr lang="en-US" sz="1800" b="1" dirty="0">
+          <p:cNvPr id="8" name="Text 5"/>
+          <p:cNvSpPr/>
+          <p:nvPr/>
+        </p:nvSpPr>
+        <p:spPr>
+          <a:xfrm>
+            <a:off x="548640" y="5212080"/>
+            <a:ext cx="11091672" cy="731520"/>
+          </a:xfrm>
+          <a:prstGeom prst="rect">
+            <a:avLst/>
+          </a:prstGeom>
+          <a:noFill/>
+          <a:ln/>
+        </p:spPr>
+        <p:txBody>
+          <a:bodyPr wrap="square" lIns="0" tIns="0" rIns="0" bIns="0" rtlCol="0" anchor="ctr"/>
+          <a:lstStyle/>
+          <a:p>
+            <a:pPr indent="0" marL="0">
+              <a:buNone/>
+            </a:pPr>
+            <a:r>
+              <a:rPr lang="en-US" sz="1600" b="1" dirty="0">
                 <a:solidFill>
                   <a:srgbClr val="1B4B8F"/>
                 </a:solidFill>
-                <a:latin typeface="Georgia" pitchFamily="34" charset="0"/>
-                <a:ea typeface="Georgia" pitchFamily="34" charset="-122"/>
-                <a:cs typeface="Georgia" pitchFamily="34" charset="-120"/>
-              </a:rPr>
-              <a:t>O Einstein lidera.</a:t>
-            </a:r>
-            <a:endParaRPr lang="en-US" sz="1800" dirty="0"/>
-          </a:p>
-        </p:txBody>
-      </p:sp>
-      <p:sp>
-        <p:nvSpPr>
-          <p:cNvPr id="8" name="Text 5"/>
-          <p:cNvSpPr/>
-          <p:nvPr/>
-        </p:nvSpPr>
-        <p:spPr>
-          <a:xfrm>
-            <a:off x="548640" y="5303520"/>
-            <a:ext cx="11091672" cy="548640"/>
-          </a:xfrm>
-          <a:prstGeom prst="rect">
-            <a:avLst/>
-          </a:prstGeom>
-          <a:noFill/>
-          <a:ln/>
-        </p:spPr>
-        <p:txBody>
-          <a:bodyPr wrap="square" lIns="0" tIns="0" rIns="0" bIns="0" rtlCol="0" anchor="ctr"/>
-          <a:lstStyle/>
-          <a:p>
-            <a:pPr indent="0" marL="0">
-              <a:buNone/>
-            </a:pPr>
-            <a:r>
-              <a:rPr lang="en-US" sz="1400" b="1" dirty="0">
+                <a:latin typeface="Arial" pitchFamily="34" charset="0"/>
+                <a:ea typeface="Arial" pitchFamily="34" charset="-122"/>
+                <a:cs typeface="Arial" pitchFamily="34" charset="-120"/>
+              </a:rPr>
+              <a:t>O Einstein.Cloud </a:t>
+            </a:r>
+            <a:pPr indent="0" marL="0">
+              <a:buNone/>
+            </a:pPr>
+            <a:r>
+              <a:rPr lang="en-US" sz="1500" dirty="0">
+                <a:solidFill>
+                  <a:srgbClr val="1B2A4A"/>
+                </a:solidFill>
+                <a:latin typeface="Arial" pitchFamily="34" charset="0"/>
+                <a:ea typeface="Arial" pitchFamily="34" charset="-122"/>
+                <a:cs typeface="Arial" pitchFamily="34" charset="-120"/>
+              </a:rPr>
+              <a:t>não é um produto da BeansTech — </a:t>
+            </a:r>
+            <a:pPr indent="0" marL="0">
+              <a:buNone/>
+            </a:pPr>
+            <a:r>
+              <a:rPr lang="en-US" sz="1500" b="1" dirty="0">
                 <a:solidFill>
                   <a:srgbClr val="1B4B8F"/>
                 </a:solidFill>
@@ -8438,13 +8701,13 @@
                 <a:ea typeface="Arial" pitchFamily="34" charset="-122"/>
                 <a:cs typeface="Arial" pitchFamily="34" charset="-120"/>
               </a:rPr>
-              <a:t>Decisões que ficam com o Einstein: </a:t>
-            </a:r>
-            <a:pPr indent="0" marL="0">
-              <a:buNone/>
-            </a:pPr>
-            <a:r>
-              <a:rPr lang="en-US" sz="1400" dirty="0">
+              <a:t>é uma plataforma do Einstein</a:t>
+            </a:r>
+            <a:pPr indent="0" marL="0">
+              <a:buNone/>
+            </a:pPr>
+            <a:r>
+              <a:rPr lang="en-US" sz="1500" dirty="0">
                 <a:solidFill>
                   <a:srgbClr val="1B2A4A"/>
                 </a:solidFill>
@@ -8452,115 +8715,9 @@
                 <a:ea typeface="Arial" pitchFamily="34" charset="-122"/>
                 <a:cs typeface="Arial" pitchFamily="34" charset="-120"/>
               </a:rPr>
-              <a:t>quais modelos usar, quando atualizar, quais dados usar para fine-tuning, quando suspender.</a:t>
-            </a:r>
-            <a:endParaRPr lang="en-US" sz="1400" dirty="0"/>
-          </a:p>
-        </p:txBody>
-      </p:sp>
-      <p:sp>
-        <p:nvSpPr>
-          <p:cNvPr id="9" name="Text 6"/>
-          <p:cNvSpPr/>
-          <p:nvPr/>
-        </p:nvSpPr>
-        <p:spPr>
-          <a:xfrm>
-            <a:off x="548640" y="5486400"/>
-            <a:ext cx="11091672" cy="457200"/>
-          </a:xfrm>
-          <a:prstGeom prst="rect">
-            <a:avLst/>
-          </a:prstGeom>
-          <a:noFill/>
-          <a:ln/>
-        </p:spPr>
-        <p:txBody>
-          <a:bodyPr wrap="square" lIns="0" tIns="0" rIns="0" bIns="0" rtlCol="0" anchor="ctr"/>
-          <a:lstStyle/>
-          <a:p>
-            <a:pPr indent="0" marL="0">
-              <a:buNone/>
-            </a:pPr>
-            <a:r>
-              <a:rPr lang="en-US" sz="1400" b="1" dirty="0">
-                <a:solidFill>
-                  <a:srgbClr val="1B4B8F"/>
-                </a:solidFill>
-                <a:latin typeface="Arial" pitchFamily="34" charset="0"/>
-                <a:ea typeface="Arial" pitchFamily="34" charset="-122"/>
-                <a:cs typeface="Arial" pitchFamily="34" charset="-120"/>
-              </a:rPr>
-              <a:t>Decisões que ficam com a BeansTech: </a:t>
-            </a:r>
-            <a:pPr indent="0" marL="0">
-              <a:buNone/>
-            </a:pPr>
-            <a:r>
-              <a:rPr lang="en-US" sz="1400" dirty="0">
-                <a:solidFill>
-                  <a:srgbClr val="1B2A4A"/>
-                </a:solidFill>
-                <a:latin typeface="Arial" pitchFamily="34" charset="0"/>
-                <a:ea typeface="Arial" pitchFamily="34" charset="-122"/>
-                <a:cs typeface="Arial" pitchFamily="34" charset="-120"/>
-              </a:rPr>
-              <a:t>infraestrutura, disponibilidade, monitoramento, manutenção.</a:t>
-            </a:r>
-            <a:endParaRPr lang="en-US" sz="1400" dirty="0"/>
-          </a:p>
-        </p:txBody>
-      </p:sp>
-      <p:sp>
-        <p:nvSpPr>
-          <p:cNvPr id="10" name="Text 7"/>
-          <p:cNvSpPr/>
-          <p:nvPr/>
-        </p:nvSpPr>
-        <p:spPr>
-          <a:xfrm>
-            <a:off x="548640" y="5943600"/>
-            <a:ext cx="11091672" cy="640080"/>
-          </a:xfrm>
-          <a:prstGeom prst="rect">
-            <a:avLst/>
-          </a:prstGeom>
-          <a:noFill/>
-          <a:ln/>
-        </p:spPr>
-        <p:txBody>
-          <a:bodyPr wrap="square" lIns="0" tIns="0" rIns="0" bIns="0" rtlCol="0" anchor="ctr"/>
-          <a:lstStyle/>
-          <a:p>
-            <a:pPr indent="0" marL="0">
-              <a:buNone/>
-            </a:pPr>
-            <a:r>
-              <a:rPr lang="en-US" sz="1400" b="1" dirty="0">
-                <a:solidFill>
-                  <a:srgbClr val="1B4B8F"/>
-                </a:solidFill>
-                <a:latin typeface="Arial" pitchFamily="34" charset="0"/>
-                <a:ea typeface="Arial" pitchFamily="34" charset="-122"/>
-                <a:cs typeface="Arial" pitchFamily="34" charset="-120"/>
-              </a:rPr>
-              <a:t>Ferramenta: </a:t>
-            </a:r>
-            <a:pPr indent="0" marL="0">
-              <a:buNone/>
-            </a:pPr>
-            <a:r>
-              <a:rPr lang="en-US" sz="1400" dirty="0">
-                <a:solidFill>
-                  <a:srgbClr val="1B2A4A"/>
-                </a:solidFill>
-                <a:latin typeface="Arial" pitchFamily="34" charset="0"/>
-                <a:ea typeface="Arial" pitchFamily="34" charset="-122"/>
-                <a:cs typeface="Arial" pitchFamily="34" charset="-120"/>
-              </a:rPr>
-              <a:t>o Einstein.Cloud não é um produto da BeansTech — é uma plataforma do Einstein, construída com apoio técnico da BeansTech. A marca, a governança e os dados são do Einstein.</a:t>
-            </a:r>
-            <a:endParaRPr lang="en-US" sz="1400" dirty="0"/>
+              <a:t>, construída com apoio técnico da BeansTech. A marca, a governança e os dados são do Einstein.</a:t>
+            </a:r>
+            <a:endParaRPr lang="en-US" sz="1600" dirty="0"/>
           </a:p>
         </p:txBody>
       </p:sp>

</xml_diff>

<commit_message>
Einstein S5: barras visuais; S8: cards de governança
</commit_message>
<xml_diff>
--- a/apresentacoes/Einstein_Cloud_Apresentacao.pptx
+++ b/apresentacoes/Einstein_Cloud_Apresentacao.pptx
@@ -8078,548 +8078,719 @@
           </a:p>
         </p:txBody>
       </p:sp>
-      <p:graphicFrame>
-        <p:nvGraphicFramePr>
-          <p:cNvPr id="9" name="Table 0"/>
-          <p:cNvGraphicFramePr>
-            <a:graphicFrameLocks noGrp="1"/>
-          </p:cNvGraphicFramePr>
-          <p:nvPr>
-            <p:extLst>
-              <p:ext uri="{D42A27DB-BD31-4B8C-83A1-F6EECF244321}">
-                <p14:modId xmlns:p14="http://schemas.microsoft.com/office/powerpoint/2010/main" val="1579011935"/>
-              </p:ext>
-            </p:extLst>
-          </p:nvPr>
-        </p:nvGraphicFramePr>
-        <p:xfrm>
-          <a:off x="548640" y="1463040"/>
-          <a:ext cx="11091672" cy="914400"/>
-        </p:xfrm>
-        <a:graphic>
-          <a:graphicData uri="http://schemas.openxmlformats.org/drawingml/2006/table">
-            <a:tbl>
-              <a:tblPr/>
-              <a:tblGrid>
-                <a:gridCol w="3200400"/>
-                <a:gridCol w="4114800"/>
-                <a:gridCol w="4142232"/>
-              </a:tblGrid>
-              <a:tr h="502920">
-                <a:tc>
-                  <a:txBody>
-                    <a:bodyPr/>
-                    <a:lstStyle/>
-                    <a:p>
-                      <a:pPr indent="0" marL="0">
-                        <a:buNone/>
-                      </a:pPr>
-                      <a:r>
-                        <a:rPr lang="en-US" sz="1400" b="1" dirty="0">
-                          <a:solidFill>
-                            <a:srgbClr val="FFFFFF"/>
-                          </a:solidFill>
-                          <a:latin typeface="Arial" pitchFamily="34" charset="0"/>
-                          <a:ea typeface="Arial" pitchFamily="34" charset="-122"/>
-                          <a:cs typeface="Arial" pitchFamily="34" charset="-120"/>
-                        </a:rPr>
-                        <a:t>Função</a:t>
-                      </a:r>
-                      <a:endParaRPr lang="en-US" sz="1400" dirty="0">
-                        <a:latin typeface="Arial" charset="0"/>
-                        <a:ea typeface="Arial" charset="0"/>
-                        <a:cs typeface="Arial" charset="0"/>
-                      </a:endParaRPr>
-                    </a:p>
-                  </a:txBody>
-                  <a:tcPr marL="91440" marR="91440" marT="45720" marB="45720">
-                    <a:lnL w="6350" cap="flat" cmpd="sng" algn="ctr">
-                      <a:solidFill>
-                        <a:srgbClr val="E5E7EB"/>
-                      </a:solidFill>
-                      <a:prstDash val="solid"/>
-                      <a:round/>
-                      <a:headEnd type="none" w="med" len="med"/>
-                      <a:tailEnd type="none" w="med" len="med"/>
-                    </a:lnL>
-                    <a:lnR w="6350" cap="flat" cmpd="sng" algn="ctr">
-                      <a:solidFill>
-                        <a:srgbClr val="E5E7EB"/>
-                      </a:solidFill>
-                      <a:prstDash val="solid"/>
-                      <a:round/>
-                      <a:headEnd type="none" w="med" len="med"/>
-                      <a:tailEnd type="none" w="med" len="med"/>
-                    </a:lnR>
-                    <a:lnT w="6350" cap="flat" cmpd="sng" algn="ctr">
-                      <a:solidFill>
-                        <a:srgbClr val="E5E7EB"/>
-                      </a:solidFill>
-                      <a:prstDash val="solid"/>
-                      <a:round/>
-                      <a:headEnd type="none" w="med" len="med"/>
-                      <a:tailEnd type="none" w="med" len="med"/>
-                    </a:lnT>
-                    <a:lnB w="6350" cap="flat" cmpd="sng" algn="ctr">
-                      <a:solidFill>
-                        <a:srgbClr val="E5E7EB"/>
-                      </a:solidFill>
-                      <a:prstDash val="solid"/>
-                      <a:round/>
-                      <a:headEnd type="none" w="med" len="med"/>
-                      <a:tailEnd type="none" w="med" len="med"/>
-                    </a:lnB>
-                    <a:solidFill>
-                      <a:srgbClr val="0A1F3D"/>
-                    </a:solidFill>
-                  </a:tcPr>
-                </a:tc>
-                <a:tc>
-                  <a:txBody>
-                    <a:bodyPr/>
-                    <a:lstStyle/>
-                    <a:p>
-                      <a:pPr indent="0" marL="0">
-                        <a:buNone/>
-                      </a:pPr>
-                      <a:r>
-                        <a:rPr lang="en-US" sz="1400" b="1" dirty="0">
-                          <a:solidFill>
-                            <a:srgbClr val="FFFFFF"/>
-                          </a:solidFill>
-                          <a:latin typeface="Arial" pitchFamily="34" charset="0"/>
-                          <a:ea typeface="Arial" pitchFamily="34" charset="-122"/>
-                          <a:cs typeface="Arial" pitchFamily="34" charset="-120"/>
-                        </a:rPr>
-                        <a:t>Einstein</a:t>
-                      </a:r>
-                      <a:endParaRPr lang="en-US" sz="1400" dirty="0">
-                        <a:latin typeface="Arial" charset="0"/>
-                        <a:ea typeface="Arial" charset="0"/>
-                        <a:cs typeface="Arial" charset="0"/>
-                      </a:endParaRPr>
-                    </a:p>
-                  </a:txBody>
-                  <a:tcPr marL="91440" marR="91440" marT="45720" marB="45720">
-                    <a:lnL w="6350" cap="flat" cmpd="sng" algn="ctr">
-                      <a:solidFill>
-                        <a:srgbClr val="E5E7EB"/>
-                      </a:solidFill>
-                      <a:prstDash val="solid"/>
-                      <a:round/>
-                      <a:headEnd type="none" w="med" len="med"/>
-                      <a:tailEnd type="none" w="med" len="med"/>
-                    </a:lnL>
-                    <a:lnR w="6350" cap="flat" cmpd="sng" algn="ctr">
-                      <a:solidFill>
-                        <a:srgbClr val="E5E7EB"/>
-                      </a:solidFill>
-                      <a:prstDash val="solid"/>
-                      <a:round/>
-                      <a:headEnd type="none" w="med" len="med"/>
-                      <a:tailEnd type="none" w="med" len="med"/>
-                    </a:lnR>
-                    <a:lnT w="6350" cap="flat" cmpd="sng" algn="ctr">
-                      <a:solidFill>
-                        <a:srgbClr val="E5E7EB"/>
-                      </a:solidFill>
-                      <a:prstDash val="solid"/>
-                      <a:round/>
-                      <a:headEnd type="none" w="med" len="med"/>
-                      <a:tailEnd type="none" w="med" len="med"/>
-                    </a:lnT>
-                    <a:lnB w="6350" cap="flat" cmpd="sng" algn="ctr">
-                      <a:solidFill>
-                        <a:srgbClr val="E5E7EB"/>
-                      </a:solidFill>
-                      <a:prstDash val="solid"/>
-                      <a:round/>
-                      <a:headEnd type="none" w="med" len="med"/>
-                      <a:tailEnd type="none" w="med" len="med"/>
-                    </a:lnB>
-                    <a:solidFill>
-                      <a:srgbClr val="0A1F3D"/>
-                    </a:solidFill>
-                  </a:tcPr>
-                </a:tc>
-                <a:tc>
-                  <a:txBody>
-                    <a:bodyPr/>
-                    <a:lstStyle/>
-                    <a:p>
-                      <a:pPr indent="0" marL="0">
-                        <a:buNone/>
-                      </a:pPr>
-                      <a:r>
-                        <a:rPr lang="en-US" sz="1400" b="1" dirty="0">
-                          <a:solidFill>
-                            <a:srgbClr val="FFFFFF"/>
-                          </a:solidFill>
-                          <a:latin typeface="Arial" pitchFamily="34" charset="0"/>
-                          <a:ea typeface="Arial" pitchFamily="34" charset="-122"/>
-                          <a:cs typeface="Arial" pitchFamily="34" charset="-120"/>
-                        </a:rPr>
-                        <a:t>BeansTech</a:t>
-                      </a:r>
-                      <a:endParaRPr lang="en-US" sz="1400" dirty="0">
-                        <a:latin typeface="Arial" charset="0"/>
-                        <a:ea typeface="Arial" charset="0"/>
-                        <a:cs typeface="Arial" charset="0"/>
-                      </a:endParaRPr>
-                    </a:p>
-                  </a:txBody>
-                  <a:tcPr marL="91440" marR="91440" marT="45720" marB="45720">
-                    <a:lnL w="6350" cap="flat" cmpd="sng" algn="ctr">
-                      <a:solidFill>
-                        <a:srgbClr val="E5E7EB"/>
-                      </a:solidFill>
-                      <a:prstDash val="solid"/>
-                      <a:round/>
-                      <a:headEnd type="none" w="med" len="med"/>
-                      <a:tailEnd type="none" w="med" len="med"/>
-                    </a:lnL>
-                    <a:lnR w="6350" cap="flat" cmpd="sng" algn="ctr">
-                      <a:solidFill>
-                        <a:srgbClr val="E5E7EB"/>
-                      </a:solidFill>
-                      <a:prstDash val="solid"/>
-                      <a:round/>
-                      <a:headEnd type="none" w="med" len="med"/>
-                      <a:tailEnd type="none" w="med" len="med"/>
-                    </a:lnR>
-                    <a:lnT w="6350" cap="flat" cmpd="sng" algn="ctr">
-                      <a:solidFill>
-                        <a:srgbClr val="E5E7EB"/>
-                      </a:solidFill>
-                      <a:prstDash val="solid"/>
-                      <a:round/>
-                      <a:headEnd type="none" w="med" len="med"/>
-                      <a:tailEnd type="none" w="med" len="med"/>
-                    </a:lnT>
-                    <a:lnB w="6350" cap="flat" cmpd="sng" algn="ctr">
-                      <a:solidFill>
-                        <a:srgbClr val="E5E7EB"/>
-                      </a:solidFill>
-                      <a:prstDash val="solid"/>
-                      <a:round/>
-                      <a:headEnd type="none" w="med" len="med"/>
-                      <a:tailEnd type="none" w="med" len="med"/>
-                    </a:lnB>
-                    <a:solidFill>
-                      <a:srgbClr val="0A1F3D"/>
-                    </a:solidFill>
-                  </a:tcPr>
-                </a:tc>
-              </a:tr>
-              <a:tr h="502920">
-                <a:tc>
-                  <a:txBody>
-                    <a:bodyPr/>
-                    <a:lstStyle/>
-                    <a:p>
-                      <a:pPr indent="0" marL="0">
-                        <a:buNone/>
-                      </a:pPr>
-                      <a:endParaRPr lang="en-US" sz="1200" dirty="0"/>
-                    </a:p>
-                  </a:txBody>
-                  <a:tcPr marL="91440" marR="91440" marT="45720" marB="45720">
-                    <a:lnL w="6350" cap="flat" cmpd="sng" algn="ctr">
-                      <a:solidFill>
-                        <a:srgbClr val="E5E7EB"/>
-                      </a:solidFill>
-                      <a:prstDash val="solid"/>
-                      <a:round/>
-                      <a:headEnd type="none" w="med" len="med"/>
-                      <a:tailEnd type="none" w="med" len="med"/>
-                    </a:lnL>
-                    <a:lnR w="6350" cap="flat" cmpd="sng" algn="ctr">
-                      <a:solidFill>
-                        <a:srgbClr val="E5E7EB"/>
-                      </a:solidFill>
-                      <a:prstDash val="solid"/>
-                      <a:round/>
-                      <a:headEnd type="none" w="med" len="med"/>
-                      <a:tailEnd type="none" w="med" len="med"/>
-                    </a:lnR>
-                    <a:lnT w="6350" cap="flat" cmpd="sng" algn="ctr">
-                      <a:solidFill>
-                        <a:srgbClr val="E5E7EB"/>
-                      </a:solidFill>
-                      <a:prstDash val="solid"/>
-                      <a:round/>
-                      <a:headEnd type="none" w="med" len="med"/>
-                      <a:tailEnd type="none" w="med" len="med"/>
-                    </a:lnT>
-                    <a:lnB w="6350" cap="flat" cmpd="sng" algn="ctr">
-                      <a:solidFill>
-                        <a:srgbClr val="E5E7EB"/>
-                      </a:solidFill>
-                      <a:prstDash val="solid"/>
-                      <a:round/>
-                      <a:headEnd type="none" w="med" len="med"/>
-                      <a:tailEnd type="none" w="med" len="med"/>
-                    </a:lnB>
-                  </a:tcPr>
-                </a:tc>
-                <a:tc>
-                  <a:txBody>
-                    <a:bodyPr/>
-                    <a:lstStyle/>
-                    <a:p>
-                      <a:pPr indent="0" marL="0">
-                        <a:buNone/>
-                      </a:pPr>
-                      <a:endParaRPr lang="en-US" sz="1200" dirty="0"/>
-                    </a:p>
-                  </a:txBody>
-                  <a:tcPr marL="91440" marR="91440" marT="45720" marB="45720">
-                    <a:lnL w="6350" cap="flat" cmpd="sng" algn="ctr">
-                      <a:solidFill>
-                        <a:srgbClr val="E5E7EB"/>
-                      </a:solidFill>
-                      <a:prstDash val="solid"/>
-                      <a:round/>
-                      <a:headEnd type="none" w="med" len="med"/>
-                      <a:tailEnd type="none" w="med" len="med"/>
-                    </a:lnL>
-                    <a:lnR w="6350" cap="flat" cmpd="sng" algn="ctr">
-                      <a:solidFill>
-                        <a:srgbClr val="E5E7EB"/>
-                      </a:solidFill>
-                      <a:prstDash val="solid"/>
-                      <a:round/>
-                      <a:headEnd type="none" w="med" len="med"/>
-                      <a:tailEnd type="none" w="med" len="med"/>
-                    </a:lnR>
-                    <a:lnT w="6350" cap="flat" cmpd="sng" algn="ctr">
-                      <a:solidFill>
-                        <a:srgbClr val="E5E7EB"/>
-                      </a:solidFill>
-                      <a:prstDash val="solid"/>
-                      <a:round/>
-                      <a:headEnd type="none" w="med" len="med"/>
-                      <a:tailEnd type="none" w="med" len="med"/>
-                    </a:lnT>
-                    <a:lnB w="6350" cap="flat" cmpd="sng" algn="ctr">
-                      <a:solidFill>
-                        <a:srgbClr val="E5E7EB"/>
-                      </a:solidFill>
-                      <a:prstDash val="solid"/>
-                      <a:round/>
-                      <a:headEnd type="none" w="med" len="med"/>
-                      <a:tailEnd type="none" w="med" len="med"/>
-                    </a:lnB>
-                  </a:tcPr>
-                </a:tc>
-                <a:tc>
-                  <a:txBody>
-                    <a:bodyPr/>
-                    <a:lstStyle/>
-                    <a:p>
-                      <a:pPr indent="0" marL="0">
-                        <a:buNone/>
-                      </a:pPr>
-                      <a:endParaRPr lang="en-US" sz="1200" dirty="0"/>
-                    </a:p>
-                  </a:txBody>
-                  <a:tcPr marL="91440" marR="91440" marT="45720" marB="45720">
-                    <a:lnL w="6350" cap="flat" cmpd="sng" algn="ctr">
-                      <a:solidFill>
-                        <a:srgbClr val="E5E7EB"/>
-                      </a:solidFill>
-                      <a:prstDash val="solid"/>
-                      <a:round/>
-                      <a:headEnd type="none" w="med" len="med"/>
-                      <a:tailEnd type="none" w="med" len="med"/>
-                    </a:lnL>
-                    <a:lnR w="6350" cap="flat" cmpd="sng" algn="ctr">
-                      <a:solidFill>
-                        <a:srgbClr val="E5E7EB"/>
-                      </a:solidFill>
-                      <a:prstDash val="solid"/>
-                      <a:round/>
-                      <a:headEnd type="none" w="med" len="med"/>
-                      <a:tailEnd type="none" w="med" len="med"/>
-                    </a:lnR>
-                    <a:lnT w="6350" cap="flat" cmpd="sng" algn="ctr">
-                      <a:solidFill>
-                        <a:srgbClr val="E5E7EB"/>
-                      </a:solidFill>
-                      <a:prstDash val="solid"/>
-                      <a:round/>
-                      <a:headEnd type="none" w="med" len="med"/>
-                      <a:tailEnd type="none" w="med" len="med"/>
-                    </a:lnT>
-                    <a:lnB w="6350" cap="flat" cmpd="sng" algn="ctr">
-                      <a:solidFill>
-                        <a:srgbClr val="E5E7EB"/>
-                      </a:solidFill>
-                      <a:prstDash val="solid"/>
-                      <a:round/>
-                      <a:headEnd type="none" w="med" len="med"/>
-                      <a:tailEnd type="none" w="med" len="med"/>
-                    </a:lnB>
-                  </a:tcPr>
-                </a:tc>
-                <a:tc>
-                  <a:txBody>
-                    <a:bodyPr/>
-                    <a:lstStyle/>
-                    <a:p>
-                      <a:pPr indent="0" marL="0">
-                        <a:buNone/>
-                      </a:pPr>
-                      <a:endParaRPr lang="en-US" sz="1200" dirty="0"/>
-                    </a:p>
-                  </a:txBody>
-                  <a:tcPr marL="91440" marR="91440" marT="45720" marB="45720">
-                    <a:lnL w="6350" cap="flat" cmpd="sng" algn="ctr">
-                      <a:solidFill>
-                        <a:srgbClr val="E5E7EB"/>
-                      </a:solidFill>
-                      <a:prstDash val="solid"/>
-                      <a:round/>
-                      <a:headEnd type="none" w="med" len="med"/>
-                      <a:tailEnd type="none" w="med" len="med"/>
-                    </a:lnL>
-                    <a:lnR w="6350" cap="flat" cmpd="sng" algn="ctr">
-                      <a:solidFill>
-                        <a:srgbClr val="E5E7EB"/>
-                      </a:solidFill>
-                      <a:prstDash val="solid"/>
-                      <a:round/>
-                      <a:headEnd type="none" w="med" len="med"/>
-                      <a:tailEnd type="none" w="med" len="med"/>
-                    </a:lnR>
-                    <a:lnT w="6350" cap="flat" cmpd="sng" algn="ctr">
-                      <a:solidFill>
-                        <a:srgbClr val="E5E7EB"/>
-                      </a:solidFill>
-                      <a:prstDash val="solid"/>
-                      <a:round/>
-                      <a:headEnd type="none" w="med" len="med"/>
-                      <a:tailEnd type="none" w="med" len="med"/>
-                    </a:lnT>
-                    <a:lnB w="6350" cap="flat" cmpd="sng" algn="ctr">
-                      <a:solidFill>
-                        <a:srgbClr val="E5E7EB"/>
-                      </a:solidFill>
-                      <a:prstDash val="solid"/>
-                      <a:round/>
-                      <a:headEnd type="none" w="med" len="med"/>
-                      <a:tailEnd type="none" w="med" len="med"/>
-                    </a:lnB>
-                  </a:tcPr>
-                </a:tc>
-                <a:tc>
-                  <a:txBody>
-                    <a:bodyPr/>
-                    <a:lstStyle/>
-                    <a:p>
-                      <a:pPr indent="0" marL="0">
-                        <a:buNone/>
-                      </a:pPr>
-                      <a:endParaRPr lang="en-US" sz="1200" dirty="0"/>
-                    </a:p>
-                  </a:txBody>
-                  <a:tcPr marL="91440" marR="91440" marT="45720" marB="45720">
-                    <a:lnL w="6350" cap="flat" cmpd="sng" algn="ctr">
-                      <a:solidFill>
-                        <a:srgbClr val="E5E7EB"/>
-                      </a:solidFill>
-                      <a:prstDash val="solid"/>
-                      <a:round/>
-                      <a:headEnd type="none" w="med" len="med"/>
-                      <a:tailEnd type="none" w="med" len="med"/>
-                    </a:lnL>
-                    <a:lnR w="6350" cap="flat" cmpd="sng" algn="ctr">
-                      <a:solidFill>
-                        <a:srgbClr val="E5E7EB"/>
-                      </a:solidFill>
-                      <a:prstDash val="solid"/>
-                      <a:round/>
-                      <a:headEnd type="none" w="med" len="med"/>
-                      <a:tailEnd type="none" w="med" len="med"/>
-                    </a:lnR>
-                    <a:lnT w="6350" cap="flat" cmpd="sng" algn="ctr">
-                      <a:solidFill>
-                        <a:srgbClr val="E5E7EB"/>
-                      </a:solidFill>
-                      <a:prstDash val="solid"/>
-                      <a:round/>
-                      <a:headEnd type="none" w="med" len="med"/>
-                      <a:tailEnd type="none" w="med" len="med"/>
-                    </a:lnT>
-                    <a:lnB w="6350" cap="flat" cmpd="sng" algn="ctr">
-                      <a:solidFill>
-                        <a:srgbClr val="E5E7EB"/>
-                      </a:solidFill>
-                      <a:prstDash val="solid"/>
-                      <a:round/>
-                      <a:headEnd type="none" w="med" len="med"/>
-                      <a:tailEnd type="none" w="med" len="med"/>
-                    </a:lnB>
-                  </a:tcPr>
-                </a:tc>
-                <a:tc>
-                  <a:txBody>
-                    <a:bodyPr/>
-                    <a:lstStyle/>
-                    <a:p>
-                      <a:pPr indent="0" marL="0">
-                        <a:buNone/>
-                      </a:pPr>
-                      <a:endParaRPr lang="en-US" sz="1200" dirty="0"/>
-                    </a:p>
-                  </a:txBody>
-                  <a:tcPr marL="91440" marR="91440" marT="45720" marB="45720">
-                    <a:lnL w="6350" cap="flat" cmpd="sng" algn="ctr">
-                      <a:solidFill>
-                        <a:srgbClr val="E5E7EB"/>
-                      </a:solidFill>
-                      <a:prstDash val="solid"/>
-                      <a:round/>
-                      <a:headEnd type="none" w="med" len="med"/>
-                      <a:tailEnd type="none" w="med" len="med"/>
-                    </a:lnL>
-                    <a:lnR w="6350" cap="flat" cmpd="sng" algn="ctr">
-                      <a:solidFill>
-                        <a:srgbClr val="E5E7EB"/>
-                      </a:solidFill>
-                      <a:prstDash val="solid"/>
-                      <a:round/>
-                      <a:headEnd type="none" w="med" len="med"/>
-                      <a:tailEnd type="none" w="med" len="med"/>
-                    </a:lnR>
-                    <a:lnT w="6350" cap="flat" cmpd="sng" algn="ctr">
-                      <a:solidFill>
-                        <a:srgbClr val="E5E7EB"/>
-                      </a:solidFill>
-                      <a:prstDash val="solid"/>
-                      <a:round/>
-                      <a:headEnd type="none" w="med" len="med"/>
-                      <a:tailEnd type="none" w="med" len="med"/>
-                    </a:lnT>
-                    <a:lnB w="6350" cap="flat" cmpd="sng" algn="ctr">
-                      <a:solidFill>
-                        <a:srgbClr val="E5E7EB"/>
-                      </a:solidFill>
-                      <a:prstDash val="solid"/>
-                      <a:round/>
-                      <a:headEnd type="none" w="med" len="med"/>
-                      <a:tailEnd type="none" w="med" len="med"/>
-                    </a:lnB>
-                  </a:tcPr>
-                </a:tc>
-              </a:tr>
-            </a:tbl>
-          </a:graphicData>
-        </a:graphic>
-      </p:graphicFrame>
-      <p:sp>
-        <p:nvSpPr>
-          <p:cNvPr id="7" name="Shape 4"/>
+      <p:sp>
+        <p:nvSpPr>
+          <p:cNvPr id="6" name="Shape 4"/>
+          <p:cNvSpPr/>
+          <p:nvPr/>
+        </p:nvSpPr>
+        <p:spPr>
+          <a:xfrm>
+            <a:off x="548640" y="1463040"/>
+            <a:ext cx="5303520" cy="1005840"/>
+          </a:xfrm>
+          <a:prstGeom prst="rect">
+            <a:avLst/>
+          </a:prstGeom>
+          <a:solidFill>
+            <a:srgbClr val="E3ECF5"/>
+          </a:solidFill>
+          <a:ln w="12700">
+            <a:solidFill>
+              <a:srgbClr val="1B4B8F"/>
+            </a:solidFill>
+            <a:prstDash val="solid"/>
+          </a:ln>
+        </p:spPr>
+      </p:sp>
+      <p:sp>
+        <p:nvSpPr>
+          <p:cNvPr id="7" name="Text 5"/>
+          <p:cNvSpPr/>
+          <p:nvPr/>
+        </p:nvSpPr>
+        <p:spPr>
+          <a:xfrm>
+            <a:off x="731520" y="1536192"/>
+            <a:ext cx="3840480" cy="320040"/>
+          </a:xfrm>
+          <a:prstGeom prst="rect">
+            <a:avLst/>
+          </a:prstGeom>
+          <a:noFill/>
+          <a:ln/>
+        </p:spPr>
+        <p:txBody>
+          <a:bodyPr wrap="square" lIns="0" tIns="0" rIns="0" bIns="0" rtlCol="0" anchor="ctr"/>
+          <a:lstStyle/>
+          <a:p>
+            <a:pPr indent="0" marL="0">
+              <a:buNone/>
+            </a:pPr>
+            <a:r>
+              <a:rPr lang="en-US" sz="1400" b="1" dirty="0">
+                <a:solidFill>
+                  <a:srgbClr val="0A1F3D"/>
+                </a:solidFill>
+                <a:latin typeface="Arial" pitchFamily="34" charset="0"/>
+                <a:ea typeface="Arial" pitchFamily="34" charset="-122"/>
+                <a:cs typeface="Arial" pitchFamily="34" charset="-120"/>
+              </a:rPr>
+              <a:t>Curadoria científica</a:t>
+            </a:r>
+            <a:endParaRPr lang="en-US" sz="1400" dirty="0"/>
+          </a:p>
+        </p:txBody>
+      </p:sp>
+      <p:sp>
+        <p:nvSpPr>
+          <p:cNvPr id="8" name="Text 6"/>
+          <p:cNvSpPr/>
+          <p:nvPr/>
+        </p:nvSpPr>
+        <p:spPr>
+          <a:xfrm>
+            <a:off x="4663440" y="1536192"/>
+            <a:ext cx="1005840" cy="320040"/>
+          </a:xfrm>
+          <a:prstGeom prst="rect">
+            <a:avLst/>
+          </a:prstGeom>
+          <a:noFill/>
+          <a:ln/>
+        </p:spPr>
+        <p:txBody>
+          <a:bodyPr wrap="square" lIns="0" tIns="0" rIns="0" bIns="0" rtlCol="0" anchor="ctr"/>
+          <a:lstStyle/>
+          <a:p>
+            <a:pPr algn="r" indent="0" marL="0">
+              <a:buNone/>
+            </a:pPr>
+            <a:r>
+              <a:rPr lang="en-US" sz="1000" b="1" dirty="0">
+                <a:solidFill>
+                  <a:srgbClr val="1B4B8F"/>
+                </a:solidFill>
+                <a:latin typeface="Arial" pitchFamily="34" charset="0"/>
+                <a:ea typeface="Arial" pitchFamily="34" charset="-122"/>
+                <a:cs typeface="Arial" pitchFamily="34" charset="-120"/>
+              </a:rPr>
+              <a:t>EINSTEIN</a:t>
+            </a:r>
+            <a:endParaRPr lang="en-US" sz="1000" dirty="0"/>
+          </a:p>
+        </p:txBody>
+      </p:sp>
+      <p:sp>
+        <p:nvSpPr>
+          <p:cNvPr id="9" name="Text 7"/>
+          <p:cNvSpPr/>
+          <p:nvPr/>
+        </p:nvSpPr>
+        <p:spPr>
+          <a:xfrm>
+            <a:off x="731520" y="1874520"/>
+            <a:ext cx="4937760" cy="502920"/>
+          </a:xfrm>
+          <a:prstGeom prst="rect">
+            <a:avLst/>
+          </a:prstGeom>
+          <a:noFill/>
+          <a:ln/>
+        </p:spPr>
+        <p:txBody>
+          <a:bodyPr wrap="square" lIns="0" tIns="0" rIns="0" bIns="0" rtlCol="0" anchor="ctr"/>
+          <a:lstStyle/>
+          <a:p>
+            <a:pPr indent="0" marL="0">
+              <a:buNone/>
+            </a:pPr>
+            <a:r>
+              <a:rPr lang="en-US" sz="1200" dirty="0">
+                <a:solidFill>
+                  <a:srgbClr val="1B2A4A"/>
+                </a:solidFill>
+                <a:latin typeface="Arial" pitchFamily="34" charset="0"/>
+                <a:ea typeface="Arial" pitchFamily="34" charset="-122"/>
+                <a:cs typeface="Arial" pitchFamily="34" charset="-120"/>
+              </a:rPr>
+              <a:t>Validação clínica, protocolos, acervo</a:t>
+            </a:r>
+            <a:endParaRPr lang="en-US" sz="1200" dirty="0"/>
+          </a:p>
+        </p:txBody>
+      </p:sp>
+      <p:sp>
+        <p:nvSpPr>
+          <p:cNvPr id="10" name="Shape 8"/>
+          <p:cNvSpPr/>
+          <p:nvPr/>
+        </p:nvSpPr>
+        <p:spPr>
+          <a:xfrm>
+            <a:off x="6217920" y="1463040"/>
+            <a:ext cx="5303520" cy="1005840"/>
+          </a:xfrm>
+          <a:prstGeom prst="rect">
+            <a:avLst/>
+          </a:prstGeom>
+          <a:solidFill>
+            <a:srgbClr val="E3ECF5"/>
+          </a:solidFill>
+          <a:ln w="12700">
+            <a:solidFill>
+              <a:srgbClr val="1B4B8F"/>
+            </a:solidFill>
+            <a:prstDash val="solid"/>
+          </a:ln>
+        </p:spPr>
+      </p:sp>
+      <p:sp>
+        <p:nvSpPr>
+          <p:cNvPr id="11" name="Text 9"/>
+          <p:cNvSpPr/>
+          <p:nvPr/>
+        </p:nvSpPr>
+        <p:spPr>
+          <a:xfrm>
+            <a:off x="6400800" y="1536192"/>
+            <a:ext cx="3840480" cy="320040"/>
+          </a:xfrm>
+          <a:prstGeom prst="rect">
+            <a:avLst/>
+          </a:prstGeom>
+          <a:noFill/>
+          <a:ln/>
+        </p:spPr>
+        <p:txBody>
+          <a:bodyPr wrap="square" lIns="0" tIns="0" rIns="0" bIns="0" rtlCol="0" anchor="ctr"/>
+          <a:lstStyle/>
+          <a:p>
+            <a:pPr indent="0" marL="0">
+              <a:buNone/>
+            </a:pPr>
+            <a:r>
+              <a:rPr lang="en-US" sz="1400" b="1" dirty="0">
+                <a:solidFill>
+                  <a:srgbClr val="0A1F3D"/>
+                </a:solidFill>
+                <a:latin typeface="Arial" pitchFamily="34" charset="0"/>
+                <a:ea typeface="Arial" pitchFamily="34" charset="-122"/>
+                <a:cs typeface="Arial" pitchFamily="34" charset="-120"/>
+              </a:rPr>
+              <a:t>Comité de ética (CEP)</a:t>
+            </a:r>
+            <a:endParaRPr lang="en-US" sz="1400" dirty="0"/>
+          </a:p>
+        </p:txBody>
+      </p:sp>
+      <p:sp>
+        <p:nvSpPr>
+          <p:cNvPr id="12" name="Text 10"/>
+          <p:cNvSpPr/>
+          <p:nvPr/>
+        </p:nvSpPr>
+        <p:spPr>
+          <a:xfrm>
+            <a:off x="10332720" y="1536192"/>
+            <a:ext cx="1005840" cy="320040"/>
+          </a:xfrm>
+          <a:prstGeom prst="rect">
+            <a:avLst/>
+          </a:prstGeom>
+          <a:noFill/>
+          <a:ln/>
+        </p:spPr>
+        <p:txBody>
+          <a:bodyPr wrap="square" lIns="0" tIns="0" rIns="0" bIns="0" rtlCol="0" anchor="ctr"/>
+          <a:lstStyle/>
+          <a:p>
+            <a:pPr algn="r" indent="0" marL="0">
+              <a:buNone/>
+            </a:pPr>
+            <a:r>
+              <a:rPr lang="en-US" sz="1000" b="1" dirty="0">
+                <a:solidFill>
+                  <a:srgbClr val="1B4B8F"/>
+                </a:solidFill>
+                <a:latin typeface="Arial" pitchFamily="34" charset="0"/>
+                <a:ea typeface="Arial" pitchFamily="34" charset="-122"/>
+                <a:cs typeface="Arial" pitchFamily="34" charset="-120"/>
+              </a:rPr>
+              <a:t>EINSTEIN</a:t>
+            </a:r>
+            <a:endParaRPr lang="en-US" sz="1000" dirty="0"/>
+          </a:p>
+        </p:txBody>
+      </p:sp>
+      <p:sp>
+        <p:nvSpPr>
+          <p:cNvPr id="13" name="Text 11"/>
+          <p:cNvSpPr/>
+          <p:nvPr/>
+        </p:nvSpPr>
+        <p:spPr>
+          <a:xfrm>
+            <a:off x="6400800" y="1874520"/>
+            <a:ext cx="4937760" cy="502920"/>
+          </a:xfrm>
+          <a:prstGeom prst="rect">
+            <a:avLst/>
+          </a:prstGeom>
+          <a:noFill/>
+          <a:ln/>
+        </p:spPr>
+        <p:txBody>
+          <a:bodyPr wrap="square" lIns="0" tIns="0" rIns="0" bIns="0" rtlCol="0" anchor="ctr"/>
+          <a:lstStyle/>
+          <a:p>
+            <a:pPr indent="0" marL="0">
+              <a:buNone/>
+            </a:pPr>
+            <a:r>
+              <a:rPr lang="en-US" sz="1200" dirty="0">
+                <a:solidFill>
+                  <a:srgbClr val="1B2A4A"/>
+                </a:solidFill>
+                <a:latin typeface="Arial" pitchFamily="34" charset="0"/>
+                <a:ea typeface="Arial" pitchFamily="34" charset="-122"/>
+                <a:cs typeface="Arial" pitchFamily="34" charset="-120"/>
+              </a:rPr>
+              <a:t>Aprovação de fine-tuning e casos de uso</a:t>
+            </a:r>
+            <a:endParaRPr lang="en-US" sz="1200" dirty="0"/>
+          </a:p>
+        </p:txBody>
+      </p:sp>
+      <p:sp>
+        <p:nvSpPr>
+          <p:cNvPr id="14" name="Shape 12"/>
+          <p:cNvSpPr/>
+          <p:nvPr/>
+        </p:nvSpPr>
+        <p:spPr>
+          <a:xfrm>
+            <a:off x="548640" y="2697480"/>
+            <a:ext cx="5303520" cy="1005840"/>
+          </a:xfrm>
+          <a:prstGeom prst="rect">
+            <a:avLst/>
+          </a:prstGeom>
+          <a:solidFill>
+            <a:srgbClr val="E3ECF5"/>
+          </a:solidFill>
+          <a:ln w="12700">
+            <a:solidFill>
+              <a:srgbClr val="1B4B8F"/>
+            </a:solidFill>
+            <a:prstDash val="solid"/>
+          </a:ln>
+        </p:spPr>
+      </p:sp>
+      <p:sp>
+        <p:nvSpPr>
+          <p:cNvPr id="15" name="Text 13"/>
+          <p:cNvSpPr/>
+          <p:nvPr/>
+        </p:nvSpPr>
+        <p:spPr>
+          <a:xfrm>
+            <a:off x="731520" y="2770632"/>
+            <a:ext cx="3840480" cy="320040"/>
+          </a:xfrm>
+          <a:prstGeom prst="rect">
+            <a:avLst/>
+          </a:prstGeom>
+          <a:noFill/>
+          <a:ln/>
+        </p:spPr>
+        <p:txBody>
+          <a:bodyPr wrap="square" lIns="0" tIns="0" rIns="0" bIns="0" rtlCol="0" anchor="ctr"/>
+          <a:lstStyle/>
+          <a:p>
+            <a:pPr indent="0" marL="0">
+              <a:buNone/>
+            </a:pPr>
+            <a:r>
+              <a:rPr lang="en-US" sz="1400" b="1" dirty="0">
+                <a:solidFill>
+                  <a:srgbClr val="0A1F3D"/>
+                </a:solidFill>
+                <a:latin typeface="Arial" pitchFamily="34" charset="0"/>
+                <a:ea typeface="Arial" pitchFamily="34" charset="-122"/>
+                <a:cs typeface="Arial" pitchFamily="34" charset="-120"/>
+              </a:rPr>
+              <a:t>Decisão de modelos</a:t>
+            </a:r>
+            <a:endParaRPr lang="en-US" sz="1400" dirty="0"/>
+          </a:p>
+        </p:txBody>
+      </p:sp>
+      <p:sp>
+        <p:nvSpPr>
+          <p:cNvPr id="16" name="Text 14"/>
+          <p:cNvSpPr/>
+          <p:nvPr/>
+        </p:nvSpPr>
+        <p:spPr>
+          <a:xfrm>
+            <a:off x="4663440" y="2770632"/>
+            <a:ext cx="1005840" cy="320040"/>
+          </a:xfrm>
+          <a:prstGeom prst="rect">
+            <a:avLst/>
+          </a:prstGeom>
+          <a:noFill/>
+          <a:ln/>
+        </p:spPr>
+        <p:txBody>
+          <a:bodyPr wrap="square" lIns="0" tIns="0" rIns="0" bIns="0" rtlCol="0" anchor="ctr"/>
+          <a:lstStyle/>
+          <a:p>
+            <a:pPr algn="r" indent="0" marL="0">
+              <a:buNone/>
+            </a:pPr>
+            <a:r>
+              <a:rPr lang="en-US" sz="1000" b="1" dirty="0">
+                <a:solidFill>
+                  <a:srgbClr val="1B4B8F"/>
+                </a:solidFill>
+                <a:latin typeface="Arial" pitchFamily="34" charset="0"/>
+                <a:ea typeface="Arial" pitchFamily="34" charset="-122"/>
+                <a:cs typeface="Arial" pitchFamily="34" charset="-120"/>
+              </a:rPr>
+              <a:t>EINSTEIN</a:t>
+            </a:r>
+            <a:endParaRPr lang="en-US" sz="1000" dirty="0"/>
+          </a:p>
+        </p:txBody>
+      </p:sp>
+      <p:sp>
+        <p:nvSpPr>
+          <p:cNvPr id="17" name="Text 15"/>
+          <p:cNvSpPr/>
+          <p:nvPr/>
+        </p:nvSpPr>
+        <p:spPr>
+          <a:xfrm>
+            <a:off x="731520" y="3108960"/>
+            <a:ext cx="4937760" cy="502920"/>
+          </a:xfrm>
+          <a:prstGeom prst="rect">
+            <a:avLst/>
+          </a:prstGeom>
+          <a:noFill/>
+          <a:ln/>
+        </p:spPr>
+        <p:txBody>
+          <a:bodyPr wrap="square" lIns="0" tIns="0" rIns="0" bIns="0" rtlCol="0" anchor="ctr"/>
+          <a:lstStyle/>
+          <a:p>
+            <a:pPr indent="0" marL="0">
+              <a:buNone/>
+            </a:pPr>
+            <a:r>
+              <a:rPr lang="en-US" sz="1200" dirty="0">
+                <a:solidFill>
+                  <a:srgbClr val="1B2A4A"/>
+                </a:solidFill>
+                <a:latin typeface="Arial" pitchFamily="34" charset="0"/>
+                <a:ea typeface="Arial" pitchFamily="34" charset="-122"/>
+                <a:cs typeface="Arial" pitchFamily="34" charset="-120"/>
+              </a:rPr>
+              <a:t>Quais usar, quando atualizar, quando suspender</a:t>
+            </a:r>
+            <a:endParaRPr lang="en-US" sz="1200" dirty="0"/>
+          </a:p>
+        </p:txBody>
+      </p:sp>
+      <p:sp>
+        <p:nvSpPr>
+          <p:cNvPr id="18" name="Shape 16"/>
+          <p:cNvSpPr/>
+          <p:nvPr/>
+        </p:nvSpPr>
+        <p:spPr>
+          <a:xfrm>
+            <a:off x="6217920" y="2697480"/>
+            <a:ext cx="5303520" cy="1005840"/>
+          </a:xfrm>
+          <a:prstGeom prst="rect">
+            <a:avLst/>
+          </a:prstGeom>
+          <a:solidFill>
+            <a:srgbClr val="FFFFFF"/>
+          </a:solidFill>
+          <a:ln w="12700">
+            <a:solidFill>
+              <a:srgbClr val="E5E7EB"/>
+            </a:solidFill>
+            <a:prstDash val="solid"/>
+          </a:ln>
+        </p:spPr>
+      </p:sp>
+      <p:sp>
+        <p:nvSpPr>
+          <p:cNvPr id="19" name="Text 17"/>
+          <p:cNvSpPr/>
+          <p:nvPr/>
+        </p:nvSpPr>
+        <p:spPr>
+          <a:xfrm>
+            <a:off x="6400800" y="2770632"/>
+            <a:ext cx="3840480" cy="320040"/>
+          </a:xfrm>
+          <a:prstGeom prst="rect">
+            <a:avLst/>
+          </a:prstGeom>
+          <a:noFill/>
+          <a:ln/>
+        </p:spPr>
+        <p:txBody>
+          <a:bodyPr wrap="square" lIns="0" tIns="0" rIns="0" bIns="0" rtlCol="0" anchor="ctr"/>
+          <a:lstStyle/>
+          <a:p>
+            <a:pPr indent="0" marL="0">
+              <a:buNone/>
+            </a:pPr>
+            <a:r>
+              <a:rPr lang="en-US" sz="1400" b="1" dirty="0">
+                <a:solidFill>
+                  <a:srgbClr val="0A1F3D"/>
+                </a:solidFill>
+                <a:latin typeface="Arial" pitchFamily="34" charset="0"/>
+                <a:ea typeface="Arial" pitchFamily="34" charset="-122"/>
+                <a:cs typeface="Arial" pitchFamily="34" charset="-120"/>
+              </a:rPr>
+              <a:t>Infraestrutura</a:t>
+            </a:r>
+            <a:endParaRPr lang="en-US" sz="1400" dirty="0"/>
+          </a:p>
+        </p:txBody>
+      </p:sp>
+      <p:sp>
+        <p:nvSpPr>
+          <p:cNvPr id="20" name="Text 18"/>
+          <p:cNvSpPr/>
+          <p:nvPr/>
+        </p:nvSpPr>
+        <p:spPr>
+          <a:xfrm>
+            <a:off x="10332720" y="2770632"/>
+            <a:ext cx="1005840" cy="320040"/>
+          </a:xfrm>
+          <a:prstGeom prst="rect">
+            <a:avLst/>
+          </a:prstGeom>
+          <a:noFill/>
+          <a:ln/>
+        </p:spPr>
+        <p:txBody>
+          <a:bodyPr wrap="square" lIns="0" tIns="0" rIns="0" bIns="0" rtlCol="0" anchor="ctr"/>
+          <a:lstStyle/>
+          <a:p>
+            <a:pPr algn="r" indent="0" marL="0">
+              <a:buNone/>
+            </a:pPr>
+            <a:r>
+              <a:rPr lang="en-US" sz="1000" b="1" dirty="0">
+                <a:solidFill>
+                  <a:srgbClr val="C9A227"/>
+                </a:solidFill>
+                <a:latin typeface="Arial" pitchFamily="34" charset="0"/>
+                <a:ea typeface="Arial" pitchFamily="34" charset="-122"/>
+                <a:cs typeface="Arial" pitchFamily="34" charset="-120"/>
+              </a:rPr>
+              <a:t>BEANSTECH</a:t>
+            </a:r>
+            <a:endParaRPr lang="en-US" sz="1000" dirty="0"/>
+          </a:p>
+        </p:txBody>
+      </p:sp>
+      <p:sp>
+        <p:nvSpPr>
+          <p:cNvPr id="21" name="Text 19"/>
+          <p:cNvSpPr/>
+          <p:nvPr/>
+        </p:nvSpPr>
+        <p:spPr>
+          <a:xfrm>
+            <a:off x="6400800" y="3108960"/>
+            <a:ext cx="4937760" cy="502920"/>
+          </a:xfrm>
+          <a:prstGeom prst="rect">
+            <a:avLst/>
+          </a:prstGeom>
+          <a:noFill/>
+          <a:ln/>
+        </p:spPr>
+        <p:txBody>
+          <a:bodyPr wrap="square" lIns="0" tIns="0" rIns="0" bIns="0" rtlCol="0" anchor="ctr"/>
+          <a:lstStyle/>
+          <a:p>
+            <a:pPr indent="0" marL="0">
+              <a:buNone/>
+            </a:pPr>
+            <a:r>
+              <a:rPr lang="en-US" sz="1200" dirty="0">
+                <a:solidFill>
+                  <a:srgbClr val="1B2A4A"/>
+                </a:solidFill>
+                <a:latin typeface="Arial" pitchFamily="34" charset="0"/>
+                <a:ea typeface="Arial" pitchFamily="34" charset="-122"/>
+                <a:cs typeface="Arial" pitchFamily="34" charset="-120"/>
+              </a:rPr>
+              <a:t>GPU, rede, manutenção, disponibilidade</a:t>
+            </a:r>
+            <a:endParaRPr lang="en-US" sz="1200" dirty="0"/>
+          </a:p>
+        </p:txBody>
+      </p:sp>
+      <p:sp>
+        <p:nvSpPr>
+          <p:cNvPr id="22" name="Shape 20"/>
+          <p:cNvSpPr/>
+          <p:nvPr/>
+        </p:nvSpPr>
+        <p:spPr>
+          <a:xfrm>
+            <a:off x="548640" y="3931920"/>
+            <a:ext cx="5303520" cy="1005840"/>
+          </a:xfrm>
+          <a:prstGeom prst="rect">
+            <a:avLst/>
+          </a:prstGeom>
+          <a:solidFill>
+            <a:srgbClr val="FFFFFF"/>
+          </a:solidFill>
+          <a:ln w="12700">
+            <a:solidFill>
+              <a:srgbClr val="E5E7EB"/>
+            </a:solidFill>
+            <a:prstDash val="solid"/>
+          </a:ln>
+        </p:spPr>
+      </p:sp>
+      <p:sp>
+        <p:nvSpPr>
+          <p:cNvPr id="23" name="Text 21"/>
+          <p:cNvSpPr/>
+          <p:nvPr/>
+        </p:nvSpPr>
+        <p:spPr>
+          <a:xfrm>
+            <a:off x="731520" y="4005072"/>
+            <a:ext cx="3840480" cy="320040"/>
+          </a:xfrm>
+          <a:prstGeom prst="rect">
+            <a:avLst/>
+          </a:prstGeom>
+          <a:noFill/>
+          <a:ln/>
+        </p:spPr>
+        <p:txBody>
+          <a:bodyPr wrap="square" lIns="0" tIns="0" rIns="0" bIns="0" rtlCol="0" anchor="ctr"/>
+          <a:lstStyle/>
+          <a:p>
+            <a:pPr indent="0" marL="0">
+              <a:buNone/>
+            </a:pPr>
+            <a:r>
+              <a:rPr lang="en-US" sz="1400" b="1" dirty="0">
+                <a:solidFill>
+                  <a:srgbClr val="0A1F3D"/>
+                </a:solidFill>
+                <a:latin typeface="Arial" pitchFamily="34" charset="0"/>
+                <a:ea typeface="Arial" pitchFamily="34" charset="-122"/>
+                <a:cs typeface="Arial" pitchFamily="34" charset="-120"/>
+              </a:rPr>
+              <a:t>Monitoramento 24×7</a:t>
+            </a:r>
+            <a:endParaRPr lang="en-US" sz="1400" dirty="0"/>
+          </a:p>
+        </p:txBody>
+      </p:sp>
+      <p:sp>
+        <p:nvSpPr>
+          <p:cNvPr id="24" name="Text 22"/>
+          <p:cNvSpPr/>
+          <p:nvPr/>
+        </p:nvSpPr>
+        <p:spPr>
+          <a:xfrm>
+            <a:off x="4663440" y="4005072"/>
+            <a:ext cx="1005840" cy="320040"/>
+          </a:xfrm>
+          <a:prstGeom prst="rect">
+            <a:avLst/>
+          </a:prstGeom>
+          <a:noFill/>
+          <a:ln/>
+        </p:spPr>
+        <p:txBody>
+          <a:bodyPr wrap="square" lIns="0" tIns="0" rIns="0" bIns="0" rtlCol="0" anchor="ctr"/>
+          <a:lstStyle/>
+          <a:p>
+            <a:pPr algn="r" indent="0" marL="0">
+              <a:buNone/>
+            </a:pPr>
+            <a:r>
+              <a:rPr lang="en-US" sz="1000" b="1" dirty="0">
+                <a:solidFill>
+                  <a:srgbClr val="C9A227"/>
+                </a:solidFill>
+                <a:latin typeface="Arial" pitchFamily="34" charset="0"/>
+                <a:ea typeface="Arial" pitchFamily="34" charset="-122"/>
+                <a:cs typeface="Arial" pitchFamily="34" charset="-120"/>
+              </a:rPr>
+              <a:t>BEANSTECH</a:t>
+            </a:r>
+            <a:endParaRPr lang="en-US" sz="1000" dirty="0"/>
+          </a:p>
+        </p:txBody>
+      </p:sp>
+      <p:sp>
+        <p:nvSpPr>
+          <p:cNvPr id="25" name="Text 23"/>
+          <p:cNvSpPr/>
+          <p:nvPr/>
+        </p:nvSpPr>
+        <p:spPr>
+          <a:xfrm>
+            <a:off x="731520" y="4343400"/>
+            <a:ext cx="4937760" cy="502920"/>
+          </a:xfrm>
+          <a:prstGeom prst="rect">
+            <a:avLst/>
+          </a:prstGeom>
+          <a:noFill/>
+          <a:ln/>
+        </p:spPr>
+        <p:txBody>
+          <a:bodyPr wrap="square" lIns="0" tIns="0" rIns="0" bIns="0" rtlCol="0" anchor="ctr"/>
+          <a:lstStyle/>
+          <a:p>
+            <a:pPr indent="0" marL="0">
+              <a:buNone/>
+            </a:pPr>
+            <a:r>
+              <a:rPr lang="en-US" sz="1200" dirty="0">
+                <a:solidFill>
+                  <a:srgbClr val="1B2A4A"/>
+                </a:solidFill>
+                <a:latin typeface="Arial" pitchFamily="34" charset="0"/>
+                <a:ea typeface="Arial" pitchFamily="34" charset="-122"/>
+                <a:cs typeface="Arial" pitchFamily="34" charset="-120"/>
+              </a:rPr>
+              <a:t>Suporte técnico e SLA</a:t>
+            </a:r>
+            <a:endParaRPr lang="en-US" sz="1200" dirty="0"/>
+          </a:p>
+        </p:txBody>
+      </p:sp>
+      <p:sp>
+        <p:nvSpPr>
+          <p:cNvPr id="26" name="Shape 24"/>
           <p:cNvSpPr/>
           <p:nvPr/>
         </p:nvSpPr>
@@ -8642,7 +8813,7 @@
       </p:sp>
       <p:sp>
         <p:nvSpPr>
-          <p:cNvPr id="8" name="Text 5"/>
+          <p:cNvPr id="27" name="Text 25"/>
           <p:cNvSpPr/>
           <p:nvPr/>
         </p:nvSpPr>
@@ -8674,20 +8845,6 @@
                 <a:cs typeface="Arial" pitchFamily="34" charset="-120"/>
               </a:rPr>
               <a:t>O Einstein.Cloud </a:t>
-            </a:r>
-            <a:pPr indent="0" marL="0">
-              <a:buNone/>
-            </a:pPr>
-            <a:r>
-              <a:rPr lang="en-US" sz="1500" dirty="0">
-                <a:solidFill>
-                  <a:srgbClr val="1B2A4A"/>
-                </a:solidFill>
-                <a:latin typeface="Arial" pitchFamily="34" charset="0"/>
-                <a:ea typeface="Arial" pitchFamily="34" charset="-122"/>
-                <a:cs typeface="Arial" pitchFamily="34" charset="-120"/>
-              </a:rPr>
-              <a:t>não é um produto da BeansTech — </a:t>
             </a:r>
             <a:pPr indent="0" marL="0">
               <a:buNone/>

</xml_diff>

<commit_message>
Einstein S5: cards de ranking (estilo S8 aprovado); data corrigida para Setembro 2026
</commit_message>
<xml_diff>
--- a/apresentacoes/Einstein_Cloud_Apresentacao.pptx
+++ b/apresentacoes/Einstein_Cloud_Apresentacao.pptx
@@ -2194,7 +2194,7 @@
                 <a:ea typeface="Arial" pitchFamily="34" charset="-122"/>
                 <a:cs typeface="Arial" pitchFamily="34" charset="-120"/>
               </a:rPr>
-              <a:t>BeansTech Health · Matheus Feijão · Outubro 2026</a:t>
+              <a:t>BeansTech Health · Matheus Feijão · Setembro 2026</a:t>
             </a:r>
             <a:endParaRPr lang="en-US" sz="1300" dirty="0"/>
           </a:p>
@@ -6122,667 +6122,1276 @@
           </a:p>
         </p:txBody>
       </p:sp>
-      <p:graphicFrame>
-        <p:nvGraphicFramePr>
-          <p:cNvPr id="6" name="Table 0"/>
-          <p:cNvGraphicFramePr>
-            <a:graphicFrameLocks noGrp="1"/>
-          </p:cNvGraphicFramePr>
-          <p:nvPr>
-            <p:extLst>
-              <p:ext uri="{D42A27DB-BD31-4B8C-83A1-F6EECF244321}">
-                <p14:modId xmlns:p14="http://schemas.microsoft.com/office/powerpoint/2010/main" val="1579011935"/>
-              </p:ext>
-            </p:extLst>
-          </p:nvPr>
-        </p:nvGraphicFramePr>
-        <p:xfrm>
-          <a:off x="548640" y="1463040"/>
-          <a:ext cx="11091672" cy="914400"/>
-        </p:xfrm>
-        <a:graphic>
-          <a:graphicData uri="http://schemas.openxmlformats.org/drawingml/2006/table">
-            <a:tbl>
-              <a:tblPr/>
-              <a:tblGrid>
-                <a:gridCol w="3657600"/>
-                <a:gridCol w="1645920"/>
-                <a:gridCol w="1188720"/>
-                <a:gridCol w="1764792"/>
-              </a:tblGrid>
-              <a:tr h="502920">
-                <a:tc>
-                  <a:txBody>
-                    <a:bodyPr/>
-                    <a:lstStyle/>
-                    <a:p>
-                      <a:pPr indent="0" marL="0">
-                        <a:buNone/>
-                      </a:pPr>
-                      <a:r>
-                        <a:rPr lang="en-US" sz="1400" b="1" dirty="0">
-                          <a:solidFill>
-                            <a:srgbClr val="FFFFFF"/>
-                          </a:solidFill>
-                          <a:latin typeface="Arial" pitchFamily="34" charset="0"/>
-                          <a:ea typeface="Arial" pitchFamily="34" charset="-122"/>
-                          <a:cs typeface="Arial" pitchFamily="34" charset="-120"/>
-                        </a:rPr>
-                        <a:t>Modelo</a:t>
-                      </a:r>
-                      <a:endParaRPr lang="en-US" sz="1400" dirty="0">
-                        <a:latin typeface="Arial" charset="0"/>
-                        <a:ea typeface="Arial" charset="0"/>
-                        <a:cs typeface="Arial" charset="0"/>
-                      </a:endParaRPr>
-                    </a:p>
-                  </a:txBody>
-                  <a:tcPr marL="91440" marR="91440" marT="45720" marB="45720">
-                    <a:lnL w="6350" cap="flat" cmpd="sng" algn="ctr">
-                      <a:solidFill>
-                        <a:srgbClr val="E5E7EB"/>
-                      </a:solidFill>
-                      <a:prstDash val="solid"/>
-                      <a:round/>
-                      <a:headEnd type="none" w="med" len="med"/>
-                      <a:tailEnd type="none" w="med" len="med"/>
-                    </a:lnL>
-                    <a:lnR w="6350" cap="flat" cmpd="sng" algn="ctr">
-                      <a:solidFill>
-                        <a:srgbClr val="E5E7EB"/>
-                      </a:solidFill>
-                      <a:prstDash val="solid"/>
-                      <a:round/>
-                      <a:headEnd type="none" w="med" len="med"/>
-                      <a:tailEnd type="none" w="med" len="med"/>
-                    </a:lnR>
-                    <a:lnT w="6350" cap="flat" cmpd="sng" algn="ctr">
-                      <a:solidFill>
-                        <a:srgbClr val="E5E7EB"/>
-                      </a:solidFill>
-                      <a:prstDash val="solid"/>
-                      <a:round/>
-                      <a:headEnd type="none" w="med" len="med"/>
-                      <a:tailEnd type="none" w="med" len="med"/>
-                    </a:lnT>
-                    <a:lnB w="6350" cap="flat" cmpd="sng" algn="ctr">
-                      <a:solidFill>
-                        <a:srgbClr val="E5E7EB"/>
-                      </a:solidFill>
-                      <a:prstDash val="solid"/>
-                      <a:round/>
-                      <a:headEnd type="none" w="med" len="med"/>
-                      <a:tailEnd type="none" w="med" len="med"/>
-                    </a:lnB>
-                    <a:solidFill>
-                      <a:srgbClr val="0A1F3D"/>
-                    </a:solidFill>
-                  </a:tcPr>
-                </a:tc>
-                <a:tc>
-                  <a:txBody>
-                    <a:bodyPr/>
-                    <a:lstStyle/>
-                    <a:p>
-                      <a:pPr indent="0" marL="0">
-                        <a:buNone/>
-                      </a:pPr>
-                      <a:r>
-                        <a:rPr lang="en-US" sz="1400" b="1" dirty="0">
-                          <a:solidFill>
-                            <a:srgbClr val="FFFFFF"/>
-                          </a:solidFill>
-                          <a:latin typeface="Arial" pitchFamily="34" charset="0"/>
-                          <a:ea typeface="Arial" pitchFamily="34" charset="-122"/>
-                          <a:cs typeface="Arial" pitchFamily="34" charset="-120"/>
-                        </a:rPr>
-                        <a:t>Coverage</a:t>
-                      </a:r>
-                      <a:endParaRPr lang="en-US" sz="1400" dirty="0">
-                        <a:latin typeface="Arial" charset="0"/>
-                        <a:ea typeface="Arial" charset="0"/>
-                        <a:cs typeface="Arial" charset="0"/>
-                      </a:endParaRPr>
-                    </a:p>
-                  </a:txBody>
-                  <a:tcPr marL="91440" marR="91440" marT="45720" marB="45720">
-                    <a:lnL w="6350" cap="flat" cmpd="sng" algn="ctr">
-                      <a:solidFill>
-                        <a:srgbClr val="E5E7EB"/>
-                      </a:solidFill>
-                      <a:prstDash val="solid"/>
-                      <a:round/>
-                      <a:headEnd type="none" w="med" len="med"/>
-                      <a:tailEnd type="none" w="med" len="med"/>
-                    </a:lnL>
-                    <a:lnR w="6350" cap="flat" cmpd="sng" algn="ctr">
-                      <a:solidFill>
-                        <a:srgbClr val="E5E7EB"/>
-                      </a:solidFill>
-                      <a:prstDash val="solid"/>
-                      <a:round/>
-                      <a:headEnd type="none" w="med" len="med"/>
-                      <a:tailEnd type="none" w="med" len="med"/>
-                    </a:lnR>
-                    <a:lnT w="6350" cap="flat" cmpd="sng" algn="ctr">
-                      <a:solidFill>
-                        <a:srgbClr val="E5E7EB"/>
-                      </a:solidFill>
-                      <a:prstDash val="solid"/>
-                      <a:round/>
-                      <a:headEnd type="none" w="med" len="med"/>
-                      <a:tailEnd type="none" w="med" len="med"/>
-                    </a:lnT>
-                    <a:lnB w="6350" cap="flat" cmpd="sng" algn="ctr">
-                      <a:solidFill>
-                        <a:srgbClr val="E5E7EB"/>
-                      </a:solidFill>
-                      <a:prstDash val="solid"/>
-                      <a:round/>
-                      <a:headEnd type="none" w="med" len="med"/>
-                      <a:tailEnd type="none" w="med" len="med"/>
-                    </a:lnB>
-                    <a:solidFill>
-                      <a:srgbClr val="0A1F3D"/>
-                    </a:solidFill>
-                  </a:tcPr>
-                </a:tc>
-                <a:tc>
-                  <a:txBody>
-                    <a:bodyPr/>
-                    <a:lstStyle/>
-                    <a:p>
-                      <a:pPr indent="0" marL="0">
-                        <a:buNone/>
-                      </a:pPr>
-                      <a:r>
-                        <a:rPr lang="en-US" sz="1400" b="1" dirty="0">
-                          <a:solidFill>
-                            <a:srgbClr val="FFFFFF"/>
-                          </a:solidFill>
-                          <a:latin typeface="Arial" pitchFamily="34" charset="0"/>
-                          <a:ea typeface="Arial" pitchFamily="34" charset="-122"/>
-                          <a:cs typeface="Arial" pitchFamily="34" charset="-120"/>
-                        </a:rPr>
-                        <a:t>Abst.</a:t>
-                      </a:r>
-                      <a:endParaRPr lang="en-US" sz="1400" dirty="0">
-                        <a:latin typeface="Arial" charset="0"/>
-                        <a:ea typeface="Arial" charset="0"/>
-                        <a:cs typeface="Arial" charset="0"/>
-                      </a:endParaRPr>
-                    </a:p>
-                  </a:txBody>
-                  <a:tcPr marL="91440" marR="91440" marT="45720" marB="45720">
-                    <a:lnL w="6350" cap="flat" cmpd="sng" algn="ctr">
-                      <a:solidFill>
-                        <a:srgbClr val="E5E7EB"/>
-                      </a:solidFill>
-                      <a:prstDash val="solid"/>
-                      <a:round/>
-                      <a:headEnd type="none" w="med" len="med"/>
-                      <a:tailEnd type="none" w="med" len="med"/>
-                    </a:lnL>
-                    <a:lnR w="6350" cap="flat" cmpd="sng" algn="ctr">
-                      <a:solidFill>
-                        <a:srgbClr val="E5E7EB"/>
-                      </a:solidFill>
-                      <a:prstDash val="solid"/>
-                      <a:round/>
-                      <a:headEnd type="none" w="med" len="med"/>
-                      <a:tailEnd type="none" w="med" len="med"/>
-                    </a:lnR>
-                    <a:lnT w="6350" cap="flat" cmpd="sng" algn="ctr">
-                      <a:solidFill>
-                        <a:srgbClr val="E5E7EB"/>
-                      </a:solidFill>
-                      <a:prstDash val="solid"/>
-                      <a:round/>
-                      <a:headEnd type="none" w="med" len="med"/>
-                      <a:tailEnd type="none" w="med" len="med"/>
-                    </a:lnT>
-                    <a:lnB w="6350" cap="flat" cmpd="sng" algn="ctr">
-                      <a:solidFill>
-                        <a:srgbClr val="E5E7EB"/>
-                      </a:solidFill>
-                      <a:prstDash val="solid"/>
-                      <a:round/>
-                      <a:headEnd type="none" w="med" len="med"/>
-                      <a:tailEnd type="none" w="med" len="med"/>
-                    </a:lnB>
-                    <a:solidFill>
-                      <a:srgbClr val="0A1F3D"/>
-                    </a:solidFill>
-                  </a:tcPr>
-                </a:tc>
-                <a:tc>
-                  <a:txBody>
-                    <a:bodyPr/>
-                    <a:lstStyle/>
-                    <a:p>
-                      <a:pPr indent="0" marL="0">
-                        <a:buNone/>
-                      </a:pPr>
-                      <a:r>
-                        <a:rPr lang="en-US" sz="1400" b="1" dirty="0">
-                          <a:solidFill>
-                            <a:srgbClr val="FFFFFF"/>
-                          </a:solidFill>
-                          <a:latin typeface="Arial" pitchFamily="34" charset="0"/>
-                          <a:ea typeface="Arial" pitchFamily="34" charset="-122"/>
-                          <a:cs typeface="Arial" pitchFamily="34" charset="-120"/>
-                        </a:rPr>
-                        <a:t>Velocidade</a:t>
-                      </a:r>
-                      <a:endParaRPr lang="en-US" sz="1400" dirty="0">
-                        <a:latin typeface="Arial" charset="0"/>
-                        <a:ea typeface="Arial" charset="0"/>
-                        <a:cs typeface="Arial" charset="0"/>
-                      </a:endParaRPr>
-                    </a:p>
-                  </a:txBody>
-                  <a:tcPr marL="91440" marR="91440" marT="45720" marB="45720">
-                    <a:lnL w="6350" cap="flat" cmpd="sng" algn="ctr">
-                      <a:solidFill>
-                        <a:srgbClr val="E5E7EB"/>
-                      </a:solidFill>
-                      <a:prstDash val="solid"/>
-                      <a:round/>
-                      <a:headEnd type="none" w="med" len="med"/>
-                      <a:tailEnd type="none" w="med" len="med"/>
-                    </a:lnL>
-                    <a:lnR w="6350" cap="flat" cmpd="sng" algn="ctr">
-                      <a:solidFill>
-                        <a:srgbClr val="E5E7EB"/>
-                      </a:solidFill>
-                      <a:prstDash val="solid"/>
-                      <a:round/>
-                      <a:headEnd type="none" w="med" len="med"/>
-                      <a:tailEnd type="none" w="med" len="med"/>
-                    </a:lnR>
-                    <a:lnT w="6350" cap="flat" cmpd="sng" algn="ctr">
-                      <a:solidFill>
-                        <a:srgbClr val="E5E7EB"/>
-                      </a:solidFill>
-                      <a:prstDash val="solid"/>
-                      <a:round/>
-                      <a:headEnd type="none" w="med" len="med"/>
-                      <a:tailEnd type="none" w="med" len="med"/>
-                    </a:lnT>
-                    <a:lnB w="6350" cap="flat" cmpd="sng" algn="ctr">
-                      <a:solidFill>
-                        <a:srgbClr val="E5E7EB"/>
-                      </a:solidFill>
-                      <a:prstDash val="solid"/>
-                      <a:round/>
-                      <a:headEnd type="none" w="med" len="med"/>
-                      <a:tailEnd type="none" w="med" len="med"/>
-                    </a:lnB>
-                    <a:solidFill>
-                      <a:srgbClr val="0A1F3D"/>
-                    </a:solidFill>
-                  </a:tcPr>
-                </a:tc>
-              </a:tr>
-              <a:tr h="502920">
-                <a:tc>
-                  <a:txBody>
-                    <a:bodyPr/>
-                    <a:lstStyle/>
-                    <a:p>
-                      <a:pPr indent="0" marL="0">
-                        <a:buNone/>
-                      </a:pPr>
-                      <a:endParaRPr lang="en-US" sz="1200" dirty="0"/>
-                    </a:p>
-                  </a:txBody>
-                  <a:tcPr marL="91440" marR="91440" marT="45720" marB="45720">
-                    <a:lnL w="6350" cap="flat" cmpd="sng" algn="ctr">
-                      <a:solidFill>
-                        <a:srgbClr val="E5E7EB"/>
-                      </a:solidFill>
-                      <a:prstDash val="solid"/>
-                      <a:round/>
-                      <a:headEnd type="none" w="med" len="med"/>
-                      <a:tailEnd type="none" w="med" len="med"/>
-                    </a:lnL>
-                    <a:lnR w="6350" cap="flat" cmpd="sng" algn="ctr">
-                      <a:solidFill>
-                        <a:srgbClr val="E5E7EB"/>
-                      </a:solidFill>
-                      <a:prstDash val="solid"/>
-                      <a:round/>
-                      <a:headEnd type="none" w="med" len="med"/>
-                      <a:tailEnd type="none" w="med" len="med"/>
-                    </a:lnR>
-                    <a:lnT w="6350" cap="flat" cmpd="sng" algn="ctr">
-                      <a:solidFill>
-                        <a:srgbClr val="E5E7EB"/>
-                      </a:solidFill>
-                      <a:prstDash val="solid"/>
-                      <a:round/>
-                      <a:headEnd type="none" w="med" len="med"/>
-                      <a:tailEnd type="none" w="med" len="med"/>
-                    </a:lnT>
-                    <a:lnB w="6350" cap="flat" cmpd="sng" algn="ctr">
-                      <a:solidFill>
-                        <a:srgbClr val="E5E7EB"/>
-                      </a:solidFill>
-                      <a:prstDash val="solid"/>
-                      <a:round/>
-                      <a:headEnd type="none" w="med" len="med"/>
-                      <a:tailEnd type="none" w="med" len="med"/>
-                    </a:lnB>
-                  </a:tcPr>
-                </a:tc>
-                <a:tc>
-                  <a:txBody>
-                    <a:bodyPr/>
-                    <a:lstStyle/>
-                    <a:p>
-                      <a:pPr indent="0" marL="0">
-                        <a:buNone/>
-                      </a:pPr>
-                      <a:endParaRPr lang="en-US" sz="1200" dirty="0"/>
-                    </a:p>
-                  </a:txBody>
-                  <a:tcPr marL="91440" marR="91440" marT="45720" marB="45720">
-                    <a:lnL w="6350" cap="flat" cmpd="sng" algn="ctr">
-                      <a:solidFill>
-                        <a:srgbClr val="E5E7EB"/>
-                      </a:solidFill>
-                      <a:prstDash val="solid"/>
-                      <a:round/>
-                      <a:headEnd type="none" w="med" len="med"/>
-                      <a:tailEnd type="none" w="med" len="med"/>
-                    </a:lnL>
-                    <a:lnR w="6350" cap="flat" cmpd="sng" algn="ctr">
-                      <a:solidFill>
-                        <a:srgbClr val="E5E7EB"/>
-                      </a:solidFill>
-                      <a:prstDash val="solid"/>
-                      <a:round/>
-                      <a:headEnd type="none" w="med" len="med"/>
-                      <a:tailEnd type="none" w="med" len="med"/>
-                    </a:lnR>
-                    <a:lnT w="6350" cap="flat" cmpd="sng" algn="ctr">
-                      <a:solidFill>
-                        <a:srgbClr val="E5E7EB"/>
-                      </a:solidFill>
-                      <a:prstDash val="solid"/>
-                      <a:round/>
-                      <a:headEnd type="none" w="med" len="med"/>
-                      <a:tailEnd type="none" w="med" len="med"/>
-                    </a:lnT>
-                    <a:lnB w="6350" cap="flat" cmpd="sng" algn="ctr">
-                      <a:solidFill>
-                        <a:srgbClr val="E5E7EB"/>
-                      </a:solidFill>
-                      <a:prstDash val="solid"/>
-                      <a:round/>
-                      <a:headEnd type="none" w="med" len="med"/>
-                      <a:tailEnd type="none" w="med" len="med"/>
-                    </a:lnB>
-                  </a:tcPr>
-                </a:tc>
-                <a:tc>
-                  <a:txBody>
-                    <a:bodyPr/>
-                    <a:lstStyle/>
-                    <a:p>
-                      <a:pPr indent="0" marL="0">
-                        <a:buNone/>
-                      </a:pPr>
-                      <a:endParaRPr lang="en-US" sz="1200" dirty="0"/>
-                    </a:p>
-                  </a:txBody>
-                  <a:tcPr marL="91440" marR="91440" marT="45720" marB="45720">
-                    <a:lnL w="6350" cap="flat" cmpd="sng" algn="ctr">
-                      <a:solidFill>
-                        <a:srgbClr val="E5E7EB"/>
-                      </a:solidFill>
-                      <a:prstDash val="solid"/>
-                      <a:round/>
-                      <a:headEnd type="none" w="med" len="med"/>
-                      <a:tailEnd type="none" w="med" len="med"/>
-                    </a:lnL>
-                    <a:lnR w="6350" cap="flat" cmpd="sng" algn="ctr">
-                      <a:solidFill>
-                        <a:srgbClr val="E5E7EB"/>
-                      </a:solidFill>
-                      <a:prstDash val="solid"/>
-                      <a:round/>
-                      <a:headEnd type="none" w="med" len="med"/>
-                      <a:tailEnd type="none" w="med" len="med"/>
-                    </a:lnR>
-                    <a:lnT w="6350" cap="flat" cmpd="sng" algn="ctr">
-                      <a:solidFill>
-                        <a:srgbClr val="E5E7EB"/>
-                      </a:solidFill>
-                      <a:prstDash val="solid"/>
-                      <a:round/>
-                      <a:headEnd type="none" w="med" len="med"/>
-                      <a:tailEnd type="none" w="med" len="med"/>
-                    </a:lnT>
-                    <a:lnB w="6350" cap="flat" cmpd="sng" algn="ctr">
-                      <a:solidFill>
-                        <a:srgbClr val="E5E7EB"/>
-                      </a:solidFill>
-                      <a:prstDash val="solid"/>
-                      <a:round/>
-                      <a:headEnd type="none" w="med" len="med"/>
-                      <a:tailEnd type="none" w="med" len="med"/>
-                    </a:lnB>
-                  </a:tcPr>
-                </a:tc>
-                <a:tc>
-                  <a:txBody>
-                    <a:bodyPr/>
-                    <a:lstStyle/>
-                    <a:p>
-                      <a:pPr indent="0" marL="0">
-                        <a:buNone/>
-                      </a:pPr>
-                      <a:endParaRPr lang="en-US" sz="1200" dirty="0"/>
-                    </a:p>
-                  </a:txBody>
-                  <a:tcPr marL="91440" marR="91440" marT="45720" marB="45720">
-                    <a:lnL w="6350" cap="flat" cmpd="sng" algn="ctr">
-                      <a:solidFill>
-                        <a:srgbClr val="E5E7EB"/>
-                      </a:solidFill>
-                      <a:prstDash val="solid"/>
-                      <a:round/>
-                      <a:headEnd type="none" w="med" len="med"/>
-                      <a:tailEnd type="none" w="med" len="med"/>
-                    </a:lnL>
-                    <a:lnR w="6350" cap="flat" cmpd="sng" algn="ctr">
-                      <a:solidFill>
-                        <a:srgbClr val="E5E7EB"/>
-                      </a:solidFill>
-                      <a:prstDash val="solid"/>
-                      <a:round/>
-                      <a:headEnd type="none" w="med" len="med"/>
-                      <a:tailEnd type="none" w="med" len="med"/>
-                    </a:lnR>
-                    <a:lnT w="6350" cap="flat" cmpd="sng" algn="ctr">
-                      <a:solidFill>
-                        <a:srgbClr val="E5E7EB"/>
-                      </a:solidFill>
-                      <a:prstDash val="solid"/>
-                      <a:round/>
-                      <a:headEnd type="none" w="med" len="med"/>
-                      <a:tailEnd type="none" w="med" len="med"/>
-                    </a:lnT>
-                    <a:lnB w="6350" cap="flat" cmpd="sng" algn="ctr">
-                      <a:solidFill>
-                        <a:srgbClr val="E5E7EB"/>
-                      </a:solidFill>
-                      <a:prstDash val="solid"/>
-                      <a:round/>
-                      <a:headEnd type="none" w="med" len="med"/>
-                      <a:tailEnd type="none" w="med" len="med"/>
-                    </a:lnB>
-                  </a:tcPr>
-                </a:tc>
-                <a:tc>
-                  <a:txBody>
-                    <a:bodyPr/>
-                    <a:lstStyle/>
-                    <a:p>
-                      <a:pPr indent="0" marL="0">
-                        <a:buNone/>
-                      </a:pPr>
-                      <a:endParaRPr lang="en-US" sz="1200" dirty="0"/>
-                    </a:p>
-                  </a:txBody>
-                  <a:tcPr marL="91440" marR="91440" marT="45720" marB="45720">
-                    <a:lnL w="6350" cap="flat" cmpd="sng" algn="ctr">
-                      <a:solidFill>
-                        <a:srgbClr val="E5E7EB"/>
-                      </a:solidFill>
-                      <a:prstDash val="solid"/>
-                      <a:round/>
-                      <a:headEnd type="none" w="med" len="med"/>
-                      <a:tailEnd type="none" w="med" len="med"/>
-                    </a:lnL>
-                    <a:lnR w="6350" cap="flat" cmpd="sng" algn="ctr">
-                      <a:solidFill>
-                        <a:srgbClr val="E5E7EB"/>
-                      </a:solidFill>
-                      <a:prstDash val="solid"/>
-                      <a:round/>
-                      <a:headEnd type="none" w="med" len="med"/>
-                      <a:tailEnd type="none" w="med" len="med"/>
-                    </a:lnR>
-                    <a:lnT w="6350" cap="flat" cmpd="sng" algn="ctr">
-                      <a:solidFill>
-                        <a:srgbClr val="E5E7EB"/>
-                      </a:solidFill>
-                      <a:prstDash val="solid"/>
-                      <a:round/>
-                      <a:headEnd type="none" w="med" len="med"/>
-                      <a:tailEnd type="none" w="med" len="med"/>
-                    </a:lnT>
-                    <a:lnB w="6350" cap="flat" cmpd="sng" algn="ctr">
-                      <a:solidFill>
-                        <a:srgbClr val="E5E7EB"/>
-                      </a:solidFill>
-                      <a:prstDash val="solid"/>
-                      <a:round/>
-                      <a:headEnd type="none" w="med" len="med"/>
-                      <a:tailEnd type="none" w="med" len="med"/>
-                    </a:lnB>
-                  </a:tcPr>
-                </a:tc>
-                <a:tc>
-                  <a:txBody>
-                    <a:bodyPr/>
-                    <a:lstStyle/>
-                    <a:p>
-                      <a:pPr indent="0" marL="0">
-                        <a:buNone/>
-                      </a:pPr>
-                      <a:endParaRPr lang="en-US" sz="1200" dirty="0"/>
-                    </a:p>
-                  </a:txBody>
-                  <a:tcPr marL="91440" marR="91440" marT="45720" marB="45720">
-                    <a:lnL w="6350" cap="flat" cmpd="sng" algn="ctr">
-                      <a:solidFill>
-                        <a:srgbClr val="E5E7EB"/>
-                      </a:solidFill>
-                      <a:prstDash val="solid"/>
-                      <a:round/>
-                      <a:headEnd type="none" w="med" len="med"/>
-                      <a:tailEnd type="none" w="med" len="med"/>
-                    </a:lnL>
-                    <a:lnR w="6350" cap="flat" cmpd="sng" algn="ctr">
-                      <a:solidFill>
-                        <a:srgbClr val="E5E7EB"/>
-                      </a:solidFill>
-                      <a:prstDash val="solid"/>
-                      <a:round/>
-                      <a:headEnd type="none" w="med" len="med"/>
-                      <a:tailEnd type="none" w="med" len="med"/>
-                    </a:lnR>
-                    <a:lnT w="6350" cap="flat" cmpd="sng" algn="ctr">
-                      <a:solidFill>
-                        <a:srgbClr val="E5E7EB"/>
-                      </a:solidFill>
-                      <a:prstDash val="solid"/>
-                      <a:round/>
-                      <a:headEnd type="none" w="med" len="med"/>
-                      <a:tailEnd type="none" w="med" len="med"/>
-                    </a:lnT>
-                    <a:lnB w="6350" cap="flat" cmpd="sng" algn="ctr">
-                      <a:solidFill>
-                        <a:srgbClr val="E5E7EB"/>
-                      </a:solidFill>
-                      <a:prstDash val="solid"/>
-                      <a:round/>
-                      <a:headEnd type="none" w="med" len="med"/>
-                      <a:tailEnd type="none" w="med" len="med"/>
-                    </a:lnB>
-                  </a:tcPr>
-                </a:tc>
-                <a:tc>
-                  <a:txBody>
-                    <a:bodyPr/>
-                    <a:lstStyle/>
-                    <a:p>
-                      <a:pPr indent="0" marL="0">
-                        <a:buNone/>
-                      </a:pPr>
-                      <a:endParaRPr lang="en-US" sz="1200" dirty="0"/>
-                    </a:p>
-                  </a:txBody>
-                  <a:tcPr marL="91440" marR="91440" marT="45720" marB="45720">
-                    <a:lnL w="6350" cap="flat" cmpd="sng" algn="ctr">
-                      <a:solidFill>
-                        <a:srgbClr val="E5E7EB"/>
-                      </a:solidFill>
-                      <a:prstDash val="solid"/>
-                      <a:round/>
-                      <a:headEnd type="none" w="med" len="med"/>
-                      <a:tailEnd type="none" w="med" len="med"/>
-                    </a:lnL>
-                    <a:lnR w="6350" cap="flat" cmpd="sng" algn="ctr">
-                      <a:solidFill>
-                        <a:srgbClr val="E5E7EB"/>
-                      </a:solidFill>
-                      <a:prstDash val="solid"/>
-                      <a:round/>
-                      <a:headEnd type="none" w="med" len="med"/>
-                      <a:tailEnd type="none" w="med" len="med"/>
-                    </a:lnR>
-                    <a:lnT w="6350" cap="flat" cmpd="sng" algn="ctr">
-                      <a:solidFill>
-                        <a:srgbClr val="E5E7EB"/>
-                      </a:solidFill>
-                      <a:prstDash val="solid"/>
-                      <a:round/>
-                      <a:headEnd type="none" w="med" len="med"/>
-                      <a:tailEnd type="none" w="med" len="med"/>
-                    </a:lnT>
-                    <a:lnB w="6350" cap="flat" cmpd="sng" algn="ctr">
-                      <a:solidFill>
-                        <a:srgbClr val="E5E7EB"/>
-                      </a:solidFill>
-                      <a:prstDash val="solid"/>
-                      <a:round/>
-                      <a:headEnd type="none" w="med" len="med"/>
-                      <a:tailEnd type="none" w="med" len="med"/>
-                    </a:lnB>
-                  </a:tcPr>
-                </a:tc>
-              </a:tr>
-            </a:tbl>
-          </a:graphicData>
-        </a:graphic>
-      </p:graphicFrame>
-      <p:sp>
-        <p:nvSpPr>
-          <p:cNvPr id="7" name="Shape 4"/>
+      <p:sp>
+        <p:nvSpPr>
+          <p:cNvPr id="6" name="Shape 4"/>
+          <p:cNvSpPr/>
+          <p:nvPr/>
+        </p:nvSpPr>
+        <p:spPr>
+          <a:xfrm>
+            <a:off x="548640" y="1463040"/>
+            <a:ext cx="5303520" cy="731520"/>
+          </a:xfrm>
+          <a:prstGeom prst="rect">
+            <a:avLst/>
+          </a:prstGeom>
+          <a:solidFill>
+            <a:srgbClr val="E3ECF5"/>
+          </a:solidFill>
+          <a:ln w="12700">
+            <a:solidFill>
+              <a:srgbClr val="1B4B8F"/>
+            </a:solidFill>
+            <a:prstDash val="solid"/>
+          </a:ln>
+        </p:spPr>
+      </p:sp>
+      <p:sp>
+        <p:nvSpPr>
+          <p:cNvPr id="7" name="Text 5"/>
+          <p:cNvSpPr/>
+          <p:nvPr/>
+        </p:nvSpPr>
+        <p:spPr>
+          <a:xfrm>
+            <a:off x="685800" y="1536192"/>
+            <a:ext cx="457200" cy="548640"/>
+          </a:xfrm>
+          <a:prstGeom prst="rect">
+            <a:avLst/>
+          </a:prstGeom>
+          <a:noFill/>
+          <a:ln/>
+        </p:spPr>
+        <p:txBody>
+          <a:bodyPr wrap="square" lIns="0" tIns="0" rIns="0" bIns="0" rtlCol="0" anchor="ctr"/>
+          <a:lstStyle/>
+          <a:p>
+            <a:pPr indent="0" marL="0">
+              <a:buNone/>
+            </a:pPr>
+            <a:r>
+              <a:rPr lang="en-US" sz="2400" b="1" dirty="0">
+                <a:solidFill>
+                  <a:srgbClr val="1B4B8F"/>
+                </a:solidFill>
+                <a:latin typeface="Georgia" pitchFamily="34" charset="0"/>
+                <a:ea typeface="Georgia" pitchFamily="34" charset="-122"/>
+                <a:cs typeface="Georgia" pitchFamily="34" charset="-120"/>
+              </a:rPr>
+              <a:t>1º</a:t>
+            </a:r>
+            <a:endParaRPr lang="en-US" sz="2400" dirty="0"/>
+          </a:p>
+        </p:txBody>
+      </p:sp>
+      <p:sp>
+        <p:nvSpPr>
+          <p:cNvPr id="8" name="Text 6"/>
+          <p:cNvSpPr/>
+          <p:nvPr/>
+        </p:nvSpPr>
+        <p:spPr>
+          <a:xfrm>
+            <a:off x="1280160" y="1536192"/>
+            <a:ext cx="2926080" cy="320040"/>
+          </a:xfrm>
+          <a:prstGeom prst="rect">
+            <a:avLst/>
+          </a:prstGeom>
+          <a:noFill/>
+          <a:ln/>
+        </p:spPr>
+        <p:txBody>
+          <a:bodyPr wrap="square" lIns="0" tIns="0" rIns="0" bIns="0" rtlCol="0" anchor="ctr"/>
+          <a:lstStyle/>
+          <a:p>
+            <a:pPr indent="0" marL="0">
+              <a:buNone/>
+            </a:pPr>
+            <a:r>
+              <a:rPr lang="en-US" sz="1300" b="1" dirty="0">
+                <a:solidFill>
+                  <a:srgbClr val="0A1F3D"/>
+                </a:solidFill>
+                <a:latin typeface="Arial" pitchFamily="34" charset="0"/>
+                <a:ea typeface="Arial" pitchFamily="34" charset="-122"/>
+                <a:cs typeface="Arial" pitchFamily="34" charset="-120"/>
+              </a:rPr>
+              <a:t>GLM-5.3 (Z.ai)</a:t>
+            </a:r>
+            <a:endParaRPr lang="en-US" sz="1300" dirty="0"/>
+          </a:p>
+        </p:txBody>
+      </p:sp>
+      <p:sp>
+        <p:nvSpPr>
+          <p:cNvPr id="9" name="Text 7"/>
+          <p:cNvSpPr/>
+          <p:nvPr/>
+        </p:nvSpPr>
+        <p:spPr>
+          <a:xfrm>
+            <a:off x="1280160" y="1828800"/>
+            <a:ext cx="1371600" cy="320040"/>
+          </a:xfrm>
+          <a:prstGeom prst="rect">
+            <a:avLst/>
+          </a:prstGeom>
+          <a:noFill/>
+          <a:ln/>
+        </p:spPr>
+        <p:txBody>
+          <a:bodyPr wrap="square" lIns="0" tIns="0" rIns="0" bIns="0" rtlCol="0" anchor="ctr"/>
+          <a:lstStyle/>
+          <a:p>
+            <a:pPr indent="0" marL="0">
+              <a:buNone/>
+            </a:pPr>
+            <a:r>
+              <a:rPr lang="en-US" sz="1300" b="1" dirty="0">
+                <a:solidFill>
+                  <a:srgbClr val="1B4B8F"/>
+                </a:solidFill>
+                <a:latin typeface="Arial" pitchFamily="34" charset="0"/>
+                <a:ea typeface="Arial" pitchFamily="34" charset="-122"/>
+                <a:cs typeface="Arial" pitchFamily="34" charset="-120"/>
+              </a:rPr>
+              <a:t>cov 0,486</a:t>
+            </a:r>
+            <a:endParaRPr lang="en-US" sz="1300" dirty="0"/>
+          </a:p>
+        </p:txBody>
+      </p:sp>
+      <p:sp>
+        <p:nvSpPr>
+          <p:cNvPr id="10" name="Text 8"/>
+          <p:cNvSpPr/>
+          <p:nvPr/>
+        </p:nvSpPr>
+        <p:spPr>
+          <a:xfrm>
+            <a:off x="2743200" y="1828800"/>
+            <a:ext cx="2286000" cy="320040"/>
+          </a:xfrm>
+          <a:prstGeom prst="rect">
+            <a:avLst/>
+          </a:prstGeom>
+          <a:noFill/>
+          <a:ln/>
+        </p:spPr>
+        <p:txBody>
+          <a:bodyPr wrap="square" lIns="0" tIns="0" rIns="0" bIns="0" rtlCol="0" anchor="ctr"/>
+          <a:lstStyle/>
+          <a:p>
+            <a:pPr indent="0" marL="0">
+              <a:buNone/>
+            </a:pPr>
+            <a:r>
+              <a:rPr lang="en-US" sz="1100" dirty="0">
+                <a:solidFill>
+                  <a:srgbClr val="6B7280"/>
+                </a:solidFill>
+                <a:latin typeface="Arial" pitchFamily="34" charset="0"/>
+                <a:ea typeface="Arial" pitchFamily="34" charset="-122"/>
+                <a:cs typeface="Arial" pitchFamily="34" charset="-120"/>
+              </a:rPr>
+              <a:t>20 abst · 23s</a:t>
+            </a:r>
+            <a:endParaRPr lang="en-US" sz="1100" dirty="0"/>
+          </a:p>
+        </p:txBody>
+      </p:sp>
+      <p:sp>
+        <p:nvSpPr>
+          <p:cNvPr id="11" name="Shape 9"/>
+          <p:cNvSpPr/>
+          <p:nvPr/>
+        </p:nvSpPr>
+        <p:spPr>
+          <a:xfrm>
+            <a:off x="6217920" y="1463040"/>
+            <a:ext cx="5303520" cy="731520"/>
+          </a:xfrm>
+          <a:prstGeom prst="rect">
+            <a:avLst/>
+          </a:prstGeom>
+          <a:solidFill>
+            <a:srgbClr val="E3ECF5"/>
+          </a:solidFill>
+          <a:ln w="12700">
+            <a:solidFill>
+              <a:srgbClr val="1B4B8F"/>
+            </a:solidFill>
+            <a:prstDash val="solid"/>
+          </a:ln>
+        </p:spPr>
+      </p:sp>
+      <p:sp>
+        <p:nvSpPr>
+          <p:cNvPr id="12" name="Text 10"/>
+          <p:cNvSpPr/>
+          <p:nvPr/>
+        </p:nvSpPr>
+        <p:spPr>
+          <a:xfrm>
+            <a:off x="6355080" y="1536192"/>
+            <a:ext cx="457200" cy="548640"/>
+          </a:xfrm>
+          <a:prstGeom prst="rect">
+            <a:avLst/>
+          </a:prstGeom>
+          <a:noFill/>
+          <a:ln/>
+        </p:spPr>
+        <p:txBody>
+          <a:bodyPr wrap="square" lIns="0" tIns="0" rIns="0" bIns="0" rtlCol="0" anchor="ctr"/>
+          <a:lstStyle/>
+          <a:p>
+            <a:pPr indent="0" marL="0">
+              <a:buNone/>
+            </a:pPr>
+            <a:r>
+              <a:rPr lang="en-US" sz="2400" b="1" dirty="0">
+                <a:solidFill>
+                  <a:srgbClr val="1B4B8F"/>
+                </a:solidFill>
+                <a:latin typeface="Georgia" pitchFamily="34" charset="0"/>
+                <a:ea typeface="Georgia" pitchFamily="34" charset="-122"/>
+                <a:cs typeface="Georgia" pitchFamily="34" charset="-120"/>
+              </a:rPr>
+              <a:t>2º</a:t>
+            </a:r>
+            <a:endParaRPr lang="en-US" sz="2400" dirty="0"/>
+          </a:p>
+        </p:txBody>
+      </p:sp>
+      <p:sp>
+        <p:nvSpPr>
+          <p:cNvPr id="13" name="Text 11"/>
+          <p:cNvSpPr/>
+          <p:nvPr/>
+        </p:nvSpPr>
+        <p:spPr>
+          <a:xfrm>
+            <a:off x="6949440" y="1536192"/>
+            <a:ext cx="2926080" cy="320040"/>
+          </a:xfrm>
+          <a:prstGeom prst="rect">
+            <a:avLst/>
+          </a:prstGeom>
+          <a:noFill/>
+          <a:ln/>
+        </p:spPr>
+        <p:txBody>
+          <a:bodyPr wrap="square" lIns="0" tIns="0" rIns="0" bIns="0" rtlCol="0" anchor="ctr"/>
+          <a:lstStyle/>
+          <a:p>
+            <a:pPr indent="0" marL="0">
+              <a:buNone/>
+            </a:pPr>
+            <a:r>
+              <a:rPr lang="en-US" sz="1300" b="1" dirty="0">
+                <a:solidFill>
+                  <a:srgbClr val="0A1F3D"/>
+                </a:solidFill>
+                <a:latin typeface="Arial" pitchFamily="34" charset="0"/>
+                <a:ea typeface="Arial" pitchFamily="34" charset="-122"/>
+                <a:cs typeface="Arial" pitchFamily="34" charset="-120"/>
+              </a:rPr>
+              <a:t>Qwen 3.8-Max (Alibaba)</a:t>
+            </a:r>
+            <a:endParaRPr lang="en-US" sz="1300" dirty="0"/>
+          </a:p>
+        </p:txBody>
+      </p:sp>
+      <p:sp>
+        <p:nvSpPr>
+          <p:cNvPr id="14" name="Text 12"/>
+          <p:cNvSpPr/>
+          <p:nvPr/>
+        </p:nvSpPr>
+        <p:spPr>
+          <a:xfrm>
+            <a:off x="6949440" y="1828800"/>
+            <a:ext cx="1371600" cy="320040"/>
+          </a:xfrm>
+          <a:prstGeom prst="rect">
+            <a:avLst/>
+          </a:prstGeom>
+          <a:noFill/>
+          <a:ln/>
+        </p:spPr>
+        <p:txBody>
+          <a:bodyPr wrap="square" lIns="0" tIns="0" rIns="0" bIns="0" rtlCol="0" anchor="ctr"/>
+          <a:lstStyle/>
+          <a:p>
+            <a:pPr indent="0" marL="0">
+              <a:buNone/>
+            </a:pPr>
+            <a:r>
+              <a:rPr lang="en-US" sz="1300" b="1" dirty="0">
+                <a:solidFill>
+                  <a:srgbClr val="1B4B8F"/>
+                </a:solidFill>
+                <a:latin typeface="Arial" pitchFamily="34" charset="0"/>
+                <a:ea typeface="Arial" pitchFamily="34" charset="-122"/>
+                <a:cs typeface="Arial" pitchFamily="34" charset="-120"/>
+              </a:rPr>
+              <a:t>cov 0,437</a:t>
+            </a:r>
+            <a:endParaRPr lang="en-US" sz="1300" dirty="0"/>
+          </a:p>
+        </p:txBody>
+      </p:sp>
+      <p:sp>
+        <p:nvSpPr>
+          <p:cNvPr id="15" name="Text 13"/>
+          <p:cNvSpPr/>
+          <p:nvPr/>
+        </p:nvSpPr>
+        <p:spPr>
+          <a:xfrm>
+            <a:off x="8412480" y="1828800"/>
+            <a:ext cx="2286000" cy="320040"/>
+          </a:xfrm>
+          <a:prstGeom prst="rect">
+            <a:avLst/>
+          </a:prstGeom>
+          <a:noFill/>
+          <a:ln/>
+        </p:spPr>
+        <p:txBody>
+          <a:bodyPr wrap="square" lIns="0" tIns="0" rIns="0" bIns="0" rtlCol="0" anchor="ctr"/>
+          <a:lstStyle/>
+          <a:p>
+            <a:pPr indent="0" marL="0">
+              <a:buNone/>
+            </a:pPr>
+            <a:r>
+              <a:rPr lang="en-US" sz="1100" dirty="0">
+                <a:solidFill>
+                  <a:srgbClr val="6B7280"/>
+                </a:solidFill>
+                <a:latin typeface="Arial" pitchFamily="34" charset="0"/>
+                <a:ea typeface="Arial" pitchFamily="34" charset="-122"/>
+                <a:cs typeface="Arial" pitchFamily="34" charset="-120"/>
+              </a:rPr>
+              <a:t>11 abst · 36s</a:t>
+            </a:r>
+            <a:endParaRPr lang="en-US" sz="1100" dirty="0"/>
+          </a:p>
+        </p:txBody>
+      </p:sp>
+      <p:sp>
+        <p:nvSpPr>
+          <p:cNvPr id="16" name="Shape 14"/>
+          <p:cNvSpPr/>
+          <p:nvPr/>
+        </p:nvSpPr>
+        <p:spPr>
+          <a:xfrm>
+            <a:off x="548640" y="2377440"/>
+            <a:ext cx="5303520" cy="731520"/>
+          </a:xfrm>
+          <a:prstGeom prst="rect">
+            <a:avLst/>
+          </a:prstGeom>
+          <a:solidFill>
+            <a:srgbClr val="E3ECF5"/>
+          </a:solidFill>
+          <a:ln w="12700">
+            <a:solidFill>
+              <a:srgbClr val="1B4B8F"/>
+            </a:solidFill>
+            <a:prstDash val="solid"/>
+          </a:ln>
+        </p:spPr>
+      </p:sp>
+      <p:sp>
+        <p:nvSpPr>
+          <p:cNvPr id="17" name="Text 15"/>
+          <p:cNvSpPr/>
+          <p:nvPr/>
+        </p:nvSpPr>
+        <p:spPr>
+          <a:xfrm>
+            <a:off x="685800" y="2450592"/>
+            <a:ext cx="457200" cy="548640"/>
+          </a:xfrm>
+          <a:prstGeom prst="rect">
+            <a:avLst/>
+          </a:prstGeom>
+          <a:noFill/>
+          <a:ln/>
+        </p:spPr>
+        <p:txBody>
+          <a:bodyPr wrap="square" lIns="0" tIns="0" rIns="0" bIns="0" rtlCol="0" anchor="ctr"/>
+          <a:lstStyle/>
+          <a:p>
+            <a:pPr indent="0" marL="0">
+              <a:buNone/>
+            </a:pPr>
+            <a:r>
+              <a:rPr lang="en-US" sz="2400" b="1" dirty="0">
+                <a:solidFill>
+                  <a:srgbClr val="1B4B8F"/>
+                </a:solidFill>
+                <a:latin typeface="Georgia" pitchFamily="34" charset="0"/>
+                <a:ea typeface="Georgia" pitchFamily="34" charset="-122"/>
+                <a:cs typeface="Georgia" pitchFamily="34" charset="-120"/>
+              </a:rPr>
+              <a:t>3º</a:t>
+            </a:r>
+            <a:endParaRPr lang="en-US" sz="2400" dirty="0"/>
+          </a:p>
+        </p:txBody>
+      </p:sp>
+      <p:sp>
+        <p:nvSpPr>
+          <p:cNvPr id="18" name="Text 16"/>
+          <p:cNvSpPr/>
+          <p:nvPr/>
+        </p:nvSpPr>
+        <p:spPr>
+          <a:xfrm>
+            <a:off x="1280160" y="2450592"/>
+            <a:ext cx="2926080" cy="320040"/>
+          </a:xfrm>
+          <a:prstGeom prst="rect">
+            <a:avLst/>
+          </a:prstGeom>
+          <a:noFill/>
+          <a:ln/>
+        </p:spPr>
+        <p:txBody>
+          <a:bodyPr wrap="square" lIns="0" tIns="0" rIns="0" bIns="0" rtlCol="0" anchor="ctr"/>
+          <a:lstStyle/>
+          <a:p>
+            <a:pPr indent="0" marL="0">
+              <a:buNone/>
+            </a:pPr>
+            <a:r>
+              <a:rPr lang="en-US" sz="1300" b="1" dirty="0">
+                <a:solidFill>
+                  <a:srgbClr val="0A1F3D"/>
+                </a:solidFill>
+                <a:latin typeface="Arial" pitchFamily="34" charset="0"/>
+                <a:ea typeface="Arial" pitchFamily="34" charset="-122"/>
+                <a:cs typeface="Arial" pitchFamily="34" charset="-120"/>
+              </a:rPr>
+              <a:t>DeepSeek v4 Pro</a:t>
+            </a:r>
+            <a:endParaRPr lang="en-US" sz="1300" dirty="0"/>
+          </a:p>
+        </p:txBody>
+      </p:sp>
+      <p:sp>
+        <p:nvSpPr>
+          <p:cNvPr id="19" name="Text 17"/>
+          <p:cNvSpPr/>
+          <p:nvPr/>
+        </p:nvSpPr>
+        <p:spPr>
+          <a:xfrm>
+            <a:off x="1280160" y="2743200"/>
+            <a:ext cx="1371600" cy="320040"/>
+          </a:xfrm>
+          <a:prstGeom prst="rect">
+            <a:avLst/>
+          </a:prstGeom>
+          <a:noFill/>
+          <a:ln/>
+        </p:spPr>
+        <p:txBody>
+          <a:bodyPr wrap="square" lIns="0" tIns="0" rIns="0" bIns="0" rtlCol="0" anchor="ctr"/>
+          <a:lstStyle/>
+          <a:p>
+            <a:pPr indent="0" marL="0">
+              <a:buNone/>
+            </a:pPr>
+            <a:r>
+              <a:rPr lang="en-US" sz="1300" b="1" dirty="0">
+                <a:solidFill>
+                  <a:srgbClr val="1B4B8F"/>
+                </a:solidFill>
+                <a:latin typeface="Arial" pitchFamily="34" charset="0"/>
+                <a:ea typeface="Arial" pitchFamily="34" charset="-122"/>
+                <a:cs typeface="Arial" pitchFamily="34" charset="-120"/>
+              </a:rPr>
+              <a:t>cov 0,396</a:t>
+            </a:r>
+            <a:endParaRPr lang="en-US" sz="1300" dirty="0"/>
+          </a:p>
+        </p:txBody>
+      </p:sp>
+      <p:sp>
+        <p:nvSpPr>
+          <p:cNvPr id="20" name="Text 18"/>
+          <p:cNvSpPr/>
+          <p:nvPr/>
+        </p:nvSpPr>
+        <p:spPr>
+          <a:xfrm>
+            <a:off x="2743200" y="2743200"/>
+            <a:ext cx="2286000" cy="320040"/>
+          </a:xfrm>
+          <a:prstGeom prst="rect">
+            <a:avLst/>
+          </a:prstGeom>
+          <a:noFill/>
+          <a:ln/>
+        </p:spPr>
+        <p:txBody>
+          <a:bodyPr wrap="square" lIns="0" tIns="0" rIns="0" bIns="0" rtlCol="0" anchor="ctr"/>
+          <a:lstStyle/>
+          <a:p>
+            <a:pPr indent="0" marL="0">
+              <a:buNone/>
+            </a:pPr>
+            <a:r>
+              <a:rPr lang="en-US" sz="1100" dirty="0">
+                <a:solidFill>
+                  <a:srgbClr val="6B7280"/>
+                </a:solidFill>
+                <a:latin typeface="Arial" pitchFamily="34" charset="0"/>
+                <a:ea typeface="Arial" pitchFamily="34" charset="-122"/>
+                <a:cs typeface="Arial" pitchFamily="34" charset="-120"/>
+              </a:rPr>
+              <a:t>3 abst · 37s</a:t>
+            </a:r>
+            <a:endParaRPr lang="en-US" sz="1100" dirty="0"/>
+          </a:p>
+        </p:txBody>
+      </p:sp>
+      <p:sp>
+        <p:nvSpPr>
+          <p:cNvPr id="21" name="Shape 19"/>
+          <p:cNvSpPr/>
+          <p:nvPr/>
+        </p:nvSpPr>
+        <p:spPr>
+          <a:xfrm>
+            <a:off x="6217920" y="2377440"/>
+            <a:ext cx="5303520" cy="731520"/>
+          </a:xfrm>
+          <a:prstGeom prst="rect">
+            <a:avLst/>
+          </a:prstGeom>
+          <a:solidFill>
+            <a:srgbClr val="FFFFFF"/>
+          </a:solidFill>
+          <a:ln w="12700">
+            <a:solidFill>
+              <a:srgbClr val="E5E7EB"/>
+            </a:solidFill>
+            <a:prstDash val="solid"/>
+          </a:ln>
+        </p:spPr>
+      </p:sp>
+      <p:sp>
+        <p:nvSpPr>
+          <p:cNvPr id="22" name="Text 20"/>
+          <p:cNvSpPr/>
+          <p:nvPr/>
+        </p:nvSpPr>
+        <p:spPr>
+          <a:xfrm>
+            <a:off x="6355080" y="2450592"/>
+            <a:ext cx="457200" cy="548640"/>
+          </a:xfrm>
+          <a:prstGeom prst="rect">
+            <a:avLst/>
+          </a:prstGeom>
+          <a:noFill/>
+          <a:ln/>
+        </p:spPr>
+        <p:txBody>
+          <a:bodyPr wrap="square" lIns="0" tIns="0" rIns="0" bIns="0" rtlCol="0" anchor="ctr"/>
+          <a:lstStyle/>
+          <a:p>
+            <a:pPr indent="0" marL="0">
+              <a:buNone/>
+            </a:pPr>
+            <a:r>
+              <a:rPr lang="en-US" sz="2400" b="1" dirty="0">
+                <a:solidFill>
+                  <a:srgbClr val="6B7280"/>
+                </a:solidFill>
+                <a:latin typeface="Georgia" pitchFamily="34" charset="0"/>
+                <a:ea typeface="Georgia" pitchFamily="34" charset="-122"/>
+                <a:cs typeface="Georgia" pitchFamily="34" charset="-120"/>
+              </a:rPr>
+              <a:t>4º</a:t>
+            </a:r>
+            <a:endParaRPr lang="en-US" sz="2400" dirty="0"/>
+          </a:p>
+        </p:txBody>
+      </p:sp>
+      <p:sp>
+        <p:nvSpPr>
+          <p:cNvPr id="23" name="Text 21"/>
+          <p:cNvSpPr/>
+          <p:nvPr/>
+        </p:nvSpPr>
+        <p:spPr>
+          <a:xfrm>
+            <a:off x="6949440" y="2450592"/>
+            <a:ext cx="2926080" cy="320040"/>
+          </a:xfrm>
+          <a:prstGeom prst="rect">
+            <a:avLst/>
+          </a:prstGeom>
+          <a:noFill/>
+          <a:ln/>
+        </p:spPr>
+        <p:txBody>
+          <a:bodyPr wrap="square" lIns="0" tIns="0" rIns="0" bIns="0" rtlCol="0" anchor="ctr"/>
+          <a:lstStyle/>
+          <a:p>
+            <a:pPr indent="0" marL="0">
+              <a:buNone/>
+            </a:pPr>
+            <a:r>
+              <a:rPr lang="en-US" sz="1300" dirty="0">
+                <a:solidFill>
+                  <a:srgbClr val="0A1F3D"/>
+                </a:solidFill>
+                <a:latin typeface="Arial" pitchFamily="34" charset="0"/>
+                <a:ea typeface="Arial" pitchFamily="34" charset="-122"/>
+                <a:cs typeface="Arial" pitchFamily="34" charset="-120"/>
+              </a:rPr>
+              <a:t>Baichuan-M3 (GPU própria)</a:t>
+            </a:r>
+            <a:endParaRPr lang="en-US" sz="1300" dirty="0"/>
+          </a:p>
+        </p:txBody>
+      </p:sp>
+      <p:sp>
+        <p:nvSpPr>
+          <p:cNvPr id="24" name="Text 22"/>
+          <p:cNvSpPr/>
+          <p:nvPr/>
+        </p:nvSpPr>
+        <p:spPr>
+          <a:xfrm>
+            <a:off x="6949440" y="2743200"/>
+            <a:ext cx="1371600" cy="320040"/>
+          </a:xfrm>
+          <a:prstGeom prst="rect">
+            <a:avLst/>
+          </a:prstGeom>
+          <a:noFill/>
+          <a:ln/>
+        </p:spPr>
+        <p:txBody>
+          <a:bodyPr wrap="square" lIns="0" tIns="0" rIns="0" bIns="0" rtlCol="0" anchor="ctr"/>
+          <a:lstStyle/>
+          <a:p>
+            <a:pPr indent="0" marL="0">
+              <a:buNone/>
+            </a:pPr>
+            <a:r>
+              <a:rPr lang="en-US" sz="1300" b="1" dirty="0">
+                <a:solidFill>
+                  <a:srgbClr val="0A1F3D"/>
+                </a:solidFill>
+                <a:latin typeface="Arial" pitchFamily="34" charset="0"/>
+                <a:ea typeface="Arial" pitchFamily="34" charset="-122"/>
+                <a:cs typeface="Arial" pitchFamily="34" charset="-120"/>
+              </a:rPr>
+              <a:t>cov 0,392</a:t>
+            </a:r>
+            <a:endParaRPr lang="en-US" sz="1300" dirty="0"/>
+          </a:p>
+        </p:txBody>
+      </p:sp>
+      <p:sp>
+        <p:nvSpPr>
+          <p:cNvPr id="25" name="Text 23"/>
+          <p:cNvSpPr/>
+          <p:nvPr/>
+        </p:nvSpPr>
+        <p:spPr>
+          <a:xfrm>
+            <a:off x="8412480" y="2743200"/>
+            <a:ext cx="2286000" cy="320040"/>
+          </a:xfrm>
+          <a:prstGeom prst="rect">
+            <a:avLst/>
+          </a:prstGeom>
+          <a:noFill/>
+          <a:ln/>
+        </p:spPr>
+        <p:txBody>
+          <a:bodyPr wrap="square" lIns="0" tIns="0" rIns="0" bIns="0" rtlCol="0" anchor="ctr"/>
+          <a:lstStyle/>
+          <a:p>
+            <a:pPr indent="0" marL="0">
+              <a:buNone/>
+            </a:pPr>
+            <a:r>
+              <a:rPr lang="en-US" sz="1100" dirty="0">
+                <a:solidFill>
+                  <a:srgbClr val="6B7280"/>
+                </a:solidFill>
+                <a:latin typeface="Arial" pitchFamily="34" charset="0"/>
+                <a:ea typeface="Arial" pitchFamily="34" charset="-122"/>
+                <a:cs typeface="Arial" pitchFamily="34" charset="-120"/>
+              </a:rPr>
+              <a:t>12 abst · 33s</a:t>
+            </a:r>
+            <a:endParaRPr lang="en-US" sz="1100" dirty="0"/>
+          </a:p>
+        </p:txBody>
+      </p:sp>
+      <p:sp>
+        <p:nvSpPr>
+          <p:cNvPr id="26" name="Shape 24"/>
+          <p:cNvSpPr/>
+          <p:nvPr/>
+        </p:nvSpPr>
+        <p:spPr>
+          <a:xfrm>
+            <a:off x="548640" y="3291840"/>
+            <a:ext cx="5303520" cy="731520"/>
+          </a:xfrm>
+          <a:prstGeom prst="rect">
+            <a:avLst/>
+          </a:prstGeom>
+          <a:solidFill>
+            <a:srgbClr val="FFFFFF"/>
+          </a:solidFill>
+          <a:ln w="12700">
+            <a:solidFill>
+              <a:srgbClr val="E5E7EB"/>
+            </a:solidFill>
+            <a:prstDash val="solid"/>
+          </a:ln>
+        </p:spPr>
+      </p:sp>
+      <p:sp>
+        <p:nvSpPr>
+          <p:cNvPr id="27" name="Text 25"/>
+          <p:cNvSpPr/>
+          <p:nvPr/>
+        </p:nvSpPr>
+        <p:spPr>
+          <a:xfrm>
+            <a:off x="685800" y="3364992"/>
+            <a:ext cx="457200" cy="548640"/>
+          </a:xfrm>
+          <a:prstGeom prst="rect">
+            <a:avLst/>
+          </a:prstGeom>
+          <a:noFill/>
+          <a:ln/>
+        </p:spPr>
+        <p:txBody>
+          <a:bodyPr wrap="square" lIns="0" tIns="0" rIns="0" bIns="0" rtlCol="0" anchor="ctr"/>
+          <a:lstStyle/>
+          <a:p>
+            <a:pPr indent="0" marL="0">
+              <a:buNone/>
+            </a:pPr>
+            <a:r>
+              <a:rPr lang="en-US" sz="2400" b="1" dirty="0">
+                <a:solidFill>
+                  <a:srgbClr val="6B7280"/>
+                </a:solidFill>
+                <a:latin typeface="Georgia" pitchFamily="34" charset="0"/>
+                <a:ea typeface="Georgia" pitchFamily="34" charset="-122"/>
+                <a:cs typeface="Georgia" pitchFamily="34" charset="-120"/>
+              </a:rPr>
+              <a:t>5º</a:t>
+            </a:r>
+            <a:endParaRPr lang="en-US" sz="2400" dirty="0"/>
+          </a:p>
+        </p:txBody>
+      </p:sp>
+      <p:sp>
+        <p:nvSpPr>
+          <p:cNvPr id="28" name="Text 26"/>
+          <p:cNvSpPr/>
+          <p:nvPr/>
+        </p:nvSpPr>
+        <p:spPr>
+          <a:xfrm>
+            <a:off x="1280160" y="3364992"/>
+            <a:ext cx="2926080" cy="320040"/>
+          </a:xfrm>
+          <a:prstGeom prst="rect">
+            <a:avLst/>
+          </a:prstGeom>
+          <a:noFill/>
+          <a:ln/>
+        </p:spPr>
+        <p:txBody>
+          <a:bodyPr wrap="square" lIns="0" tIns="0" rIns="0" bIns="0" rtlCol="0" anchor="ctr"/>
+          <a:lstStyle/>
+          <a:p>
+            <a:pPr indent="0" marL="0">
+              <a:buNone/>
+            </a:pPr>
+            <a:r>
+              <a:rPr lang="en-US" sz="1300" dirty="0">
+                <a:solidFill>
+                  <a:srgbClr val="0A1F3D"/>
+                </a:solidFill>
+                <a:latin typeface="Arial" pitchFamily="34" charset="0"/>
+                <a:ea typeface="Arial" pitchFamily="34" charset="-122"/>
+                <a:cs typeface="Arial" pitchFamily="34" charset="-120"/>
+              </a:rPr>
+              <a:t>GPT-6 Astra (OpenAI)</a:t>
+            </a:r>
+            <a:endParaRPr lang="en-US" sz="1300" dirty="0"/>
+          </a:p>
+        </p:txBody>
+      </p:sp>
+      <p:sp>
+        <p:nvSpPr>
+          <p:cNvPr id="29" name="Text 27"/>
+          <p:cNvSpPr/>
+          <p:nvPr/>
+        </p:nvSpPr>
+        <p:spPr>
+          <a:xfrm>
+            <a:off x="1280160" y="3657600"/>
+            <a:ext cx="1371600" cy="320040"/>
+          </a:xfrm>
+          <a:prstGeom prst="rect">
+            <a:avLst/>
+          </a:prstGeom>
+          <a:noFill/>
+          <a:ln/>
+        </p:spPr>
+        <p:txBody>
+          <a:bodyPr wrap="square" lIns="0" tIns="0" rIns="0" bIns="0" rtlCol="0" anchor="ctr"/>
+          <a:lstStyle/>
+          <a:p>
+            <a:pPr indent="0" marL="0">
+              <a:buNone/>
+            </a:pPr>
+            <a:r>
+              <a:rPr lang="en-US" sz="1300" b="1" dirty="0">
+                <a:solidFill>
+                  <a:srgbClr val="0A1F3D"/>
+                </a:solidFill>
+                <a:latin typeface="Arial" pitchFamily="34" charset="0"/>
+                <a:ea typeface="Arial" pitchFamily="34" charset="-122"/>
+                <a:cs typeface="Arial" pitchFamily="34" charset="-120"/>
+              </a:rPr>
+              <a:t>cov 0,377</a:t>
+            </a:r>
+            <a:endParaRPr lang="en-US" sz="1300" dirty="0"/>
+          </a:p>
+        </p:txBody>
+      </p:sp>
+      <p:sp>
+        <p:nvSpPr>
+          <p:cNvPr id="30" name="Text 28"/>
+          <p:cNvSpPr/>
+          <p:nvPr/>
+        </p:nvSpPr>
+        <p:spPr>
+          <a:xfrm>
+            <a:off x="2743200" y="3657600"/>
+            <a:ext cx="2286000" cy="320040"/>
+          </a:xfrm>
+          <a:prstGeom prst="rect">
+            <a:avLst/>
+          </a:prstGeom>
+          <a:noFill/>
+          <a:ln/>
+        </p:spPr>
+        <p:txBody>
+          <a:bodyPr wrap="square" lIns="0" tIns="0" rIns="0" bIns="0" rtlCol="0" anchor="ctr"/>
+          <a:lstStyle/>
+          <a:p>
+            <a:pPr indent="0" marL="0">
+              <a:buNone/>
+            </a:pPr>
+            <a:r>
+              <a:rPr lang="en-US" sz="1100" dirty="0">
+                <a:solidFill>
+                  <a:srgbClr val="6B7280"/>
+                </a:solidFill>
+                <a:latin typeface="Arial" pitchFamily="34" charset="0"/>
+                <a:ea typeface="Arial" pitchFamily="34" charset="-122"/>
+                <a:cs typeface="Arial" pitchFamily="34" charset="-120"/>
+              </a:rPr>
+              <a:t>15 abst · 17s</a:t>
+            </a:r>
+            <a:endParaRPr lang="en-US" sz="1100" dirty="0"/>
+          </a:p>
+        </p:txBody>
+      </p:sp>
+      <p:sp>
+        <p:nvSpPr>
+          <p:cNvPr id="31" name="Shape 29"/>
+          <p:cNvSpPr/>
+          <p:nvPr/>
+        </p:nvSpPr>
+        <p:spPr>
+          <a:xfrm>
+            <a:off x="6217920" y="3291840"/>
+            <a:ext cx="5303520" cy="731520"/>
+          </a:xfrm>
+          <a:prstGeom prst="rect">
+            <a:avLst/>
+          </a:prstGeom>
+          <a:solidFill>
+            <a:srgbClr val="FFFFFF"/>
+          </a:solidFill>
+          <a:ln w="12700">
+            <a:solidFill>
+              <a:srgbClr val="E5E7EB"/>
+            </a:solidFill>
+            <a:prstDash val="solid"/>
+          </a:ln>
+        </p:spPr>
+      </p:sp>
+      <p:sp>
+        <p:nvSpPr>
+          <p:cNvPr id="32" name="Text 30"/>
+          <p:cNvSpPr/>
+          <p:nvPr/>
+        </p:nvSpPr>
+        <p:spPr>
+          <a:xfrm>
+            <a:off x="6355080" y="3364992"/>
+            <a:ext cx="457200" cy="548640"/>
+          </a:xfrm>
+          <a:prstGeom prst="rect">
+            <a:avLst/>
+          </a:prstGeom>
+          <a:noFill/>
+          <a:ln/>
+        </p:spPr>
+        <p:txBody>
+          <a:bodyPr wrap="square" lIns="0" tIns="0" rIns="0" bIns="0" rtlCol="0" anchor="ctr"/>
+          <a:lstStyle/>
+          <a:p>
+            <a:pPr indent="0" marL="0">
+              <a:buNone/>
+            </a:pPr>
+            <a:r>
+              <a:rPr lang="en-US" sz="2400" b="1" dirty="0">
+                <a:solidFill>
+                  <a:srgbClr val="6B7280"/>
+                </a:solidFill>
+                <a:latin typeface="Georgia" pitchFamily="34" charset="0"/>
+                <a:ea typeface="Georgia" pitchFamily="34" charset="-122"/>
+                <a:cs typeface="Georgia" pitchFamily="34" charset="-120"/>
+              </a:rPr>
+              <a:t>6º</a:t>
+            </a:r>
+            <a:endParaRPr lang="en-US" sz="2400" dirty="0"/>
+          </a:p>
+        </p:txBody>
+      </p:sp>
+      <p:sp>
+        <p:nvSpPr>
+          <p:cNvPr id="33" name="Text 31"/>
+          <p:cNvSpPr/>
+          <p:nvPr/>
+        </p:nvSpPr>
+        <p:spPr>
+          <a:xfrm>
+            <a:off x="6949440" y="3364992"/>
+            <a:ext cx="2926080" cy="320040"/>
+          </a:xfrm>
+          <a:prstGeom prst="rect">
+            <a:avLst/>
+          </a:prstGeom>
+          <a:noFill/>
+          <a:ln/>
+        </p:spPr>
+        <p:txBody>
+          <a:bodyPr wrap="square" lIns="0" tIns="0" rIns="0" bIns="0" rtlCol="0" anchor="ctr"/>
+          <a:lstStyle/>
+          <a:p>
+            <a:pPr indent="0" marL="0">
+              <a:buNone/>
+            </a:pPr>
+            <a:r>
+              <a:rPr lang="en-US" sz="1300" dirty="0">
+                <a:solidFill>
+                  <a:srgbClr val="0A1F3D"/>
+                </a:solidFill>
+                <a:latin typeface="Arial" pitchFamily="34" charset="0"/>
+                <a:ea typeface="Arial" pitchFamily="34" charset="-122"/>
+                <a:cs typeface="Arial" pitchFamily="34" charset="-120"/>
+              </a:rPr>
+              <a:t>Claude Opus 5 (Anthropic)</a:t>
+            </a:r>
+            <a:endParaRPr lang="en-US" sz="1300" dirty="0"/>
+          </a:p>
+        </p:txBody>
+      </p:sp>
+      <p:sp>
+        <p:nvSpPr>
+          <p:cNvPr id="34" name="Text 32"/>
+          <p:cNvSpPr/>
+          <p:nvPr/>
+        </p:nvSpPr>
+        <p:spPr>
+          <a:xfrm>
+            <a:off x="6949440" y="3657600"/>
+            <a:ext cx="1371600" cy="320040"/>
+          </a:xfrm>
+          <a:prstGeom prst="rect">
+            <a:avLst/>
+          </a:prstGeom>
+          <a:noFill/>
+          <a:ln/>
+        </p:spPr>
+        <p:txBody>
+          <a:bodyPr wrap="square" lIns="0" tIns="0" rIns="0" bIns="0" rtlCol="0" anchor="ctr"/>
+          <a:lstStyle/>
+          <a:p>
+            <a:pPr indent="0" marL="0">
+              <a:buNone/>
+            </a:pPr>
+            <a:r>
+              <a:rPr lang="en-US" sz="1300" b="1" dirty="0">
+                <a:solidFill>
+                  <a:srgbClr val="0A1F3D"/>
+                </a:solidFill>
+                <a:latin typeface="Arial" pitchFamily="34" charset="0"/>
+                <a:ea typeface="Arial" pitchFamily="34" charset="-122"/>
+                <a:cs typeface="Arial" pitchFamily="34" charset="-120"/>
+              </a:rPr>
+              <a:t>cov 0,347</a:t>
+            </a:r>
+            <a:endParaRPr lang="en-US" sz="1300" dirty="0"/>
+          </a:p>
+        </p:txBody>
+      </p:sp>
+      <p:sp>
+        <p:nvSpPr>
+          <p:cNvPr id="35" name="Text 33"/>
+          <p:cNvSpPr/>
+          <p:nvPr/>
+        </p:nvSpPr>
+        <p:spPr>
+          <a:xfrm>
+            <a:off x="8412480" y="3657600"/>
+            <a:ext cx="2286000" cy="320040"/>
+          </a:xfrm>
+          <a:prstGeom prst="rect">
+            <a:avLst/>
+          </a:prstGeom>
+          <a:noFill/>
+          <a:ln/>
+        </p:spPr>
+        <p:txBody>
+          <a:bodyPr wrap="square" lIns="0" tIns="0" rIns="0" bIns="0" rtlCol="0" anchor="ctr"/>
+          <a:lstStyle/>
+          <a:p>
+            <a:pPr indent="0" marL="0">
+              <a:buNone/>
+            </a:pPr>
+            <a:r>
+              <a:rPr lang="en-US" sz="1100" dirty="0">
+                <a:solidFill>
+                  <a:srgbClr val="6B7280"/>
+                </a:solidFill>
+                <a:latin typeface="Arial" pitchFamily="34" charset="0"/>
+                <a:ea typeface="Arial" pitchFamily="34" charset="-122"/>
+                <a:cs typeface="Arial" pitchFamily="34" charset="-120"/>
+              </a:rPr>
+              <a:t>6 abst · 24s</a:t>
+            </a:r>
+            <a:endParaRPr lang="en-US" sz="1100" dirty="0"/>
+          </a:p>
+        </p:txBody>
+      </p:sp>
+      <p:sp>
+        <p:nvSpPr>
+          <p:cNvPr id="36" name="Shape 34"/>
+          <p:cNvSpPr/>
+          <p:nvPr/>
+        </p:nvSpPr>
+        <p:spPr>
+          <a:xfrm>
+            <a:off x="548640" y="4206240"/>
+            <a:ext cx="5303520" cy="731520"/>
+          </a:xfrm>
+          <a:prstGeom prst="rect">
+            <a:avLst/>
+          </a:prstGeom>
+          <a:solidFill>
+            <a:srgbClr val="FFFFFF"/>
+          </a:solidFill>
+          <a:ln w="12700">
+            <a:solidFill>
+              <a:srgbClr val="E5E7EB"/>
+            </a:solidFill>
+            <a:prstDash val="solid"/>
+          </a:ln>
+        </p:spPr>
+      </p:sp>
+      <p:sp>
+        <p:nvSpPr>
+          <p:cNvPr id="37" name="Text 35"/>
+          <p:cNvSpPr/>
+          <p:nvPr/>
+        </p:nvSpPr>
+        <p:spPr>
+          <a:xfrm>
+            <a:off x="685800" y="4279392"/>
+            <a:ext cx="457200" cy="548640"/>
+          </a:xfrm>
+          <a:prstGeom prst="rect">
+            <a:avLst/>
+          </a:prstGeom>
+          <a:noFill/>
+          <a:ln/>
+        </p:spPr>
+        <p:txBody>
+          <a:bodyPr wrap="square" lIns="0" tIns="0" rIns="0" bIns="0" rtlCol="0" anchor="ctr"/>
+          <a:lstStyle/>
+          <a:p>
+            <a:pPr indent="0" marL="0">
+              <a:buNone/>
+            </a:pPr>
+            <a:r>
+              <a:rPr lang="en-US" sz="2400" b="1" dirty="0">
+                <a:solidFill>
+                  <a:srgbClr val="6B7280"/>
+                </a:solidFill>
+                <a:latin typeface="Georgia" pitchFamily="34" charset="0"/>
+                <a:ea typeface="Georgia" pitchFamily="34" charset="-122"/>
+                <a:cs typeface="Georgia" pitchFamily="34" charset="-120"/>
+              </a:rPr>
+              <a:t>7º</a:t>
+            </a:r>
+            <a:endParaRPr lang="en-US" sz="2400" dirty="0"/>
+          </a:p>
+        </p:txBody>
+      </p:sp>
+      <p:sp>
+        <p:nvSpPr>
+          <p:cNvPr id="38" name="Text 36"/>
+          <p:cNvSpPr/>
+          <p:nvPr/>
+        </p:nvSpPr>
+        <p:spPr>
+          <a:xfrm>
+            <a:off x="1280160" y="4279392"/>
+            <a:ext cx="2926080" cy="320040"/>
+          </a:xfrm>
+          <a:prstGeom prst="rect">
+            <a:avLst/>
+          </a:prstGeom>
+          <a:noFill/>
+          <a:ln/>
+        </p:spPr>
+        <p:txBody>
+          <a:bodyPr wrap="square" lIns="0" tIns="0" rIns="0" bIns="0" rtlCol="0" anchor="ctr"/>
+          <a:lstStyle/>
+          <a:p>
+            <a:pPr indent="0" marL="0">
+              <a:buNone/>
+            </a:pPr>
+            <a:r>
+              <a:rPr lang="en-US" sz="1300" dirty="0">
+                <a:solidFill>
+                  <a:srgbClr val="0A1F3D"/>
+                </a:solidFill>
+                <a:latin typeface="Arial" pitchFamily="34" charset="0"/>
+                <a:ea typeface="Arial" pitchFamily="34" charset="-122"/>
+                <a:cs typeface="Arial" pitchFamily="34" charset="-120"/>
+              </a:rPr>
+              <a:t>Lingshu-32B (DAMO)</a:t>
+            </a:r>
+            <a:endParaRPr lang="en-US" sz="1300" dirty="0"/>
+          </a:p>
+        </p:txBody>
+      </p:sp>
+      <p:sp>
+        <p:nvSpPr>
+          <p:cNvPr id="39" name="Text 37"/>
+          <p:cNvSpPr/>
+          <p:nvPr/>
+        </p:nvSpPr>
+        <p:spPr>
+          <a:xfrm>
+            <a:off x="1280160" y="4572000"/>
+            <a:ext cx="1371600" cy="320040"/>
+          </a:xfrm>
+          <a:prstGeom prst="rect">
+            <a:avLst/>
+          </a:prstGeom>
+          <a:noFill/>
+          <a:ln/>
+        </p:spPr>
+        <p:txBody>
+          <a:bodyPr wrap="square" lIns="0" tIns="0" rIns="0" bIns="0" rtlCol="0" anchor="ctr"/>
+          <a:lstStyle/>
+          <a:p>
+            <a:pPr indent="0" marL="0">
+              <a:buNone/>
+            </a:pPr>
+            <a:r>
+              <a:rPr lang="en-US" sz="1300" b="1" dirty="0">
+                <a:solidFill>
+                  <a:srgbClr val="0A1F3D"/>
+                </a:solidFill>
+                <a:latin typeface="Arial" pitchFamily="34" charset="0"/>
+                <a:ea typeface="Arial" pitchFamily="34" charset="-122"/>
+                <a:cs typeface="Arial" pitchFamily="34" charset="-120"/>
+              </a:rPr>
+              <a:t>cov 0,274</a:t>
+            </a:r>
+            <a:endParaRPr lang="en-US" sz="1300" dirty="0"/>
+          </a:p>
+        </p:txBody>
+      </p:sp>
+      <p:sp>
+        <p:nvSpPr>
+          <p:cNvPr id="40" name="Text 38"/>
+          <p:cNvSpPr/>
+          <p:nvPr/>
+        </p:nvSpPr>
+        <p:spPr>
+          <a:xfrm>
+            <a:off x="2743200" y="4572000"/>
+            <a:ext cx="2286000" cy="320040"/>
+          </a:xfrm>
+          <a:prstGeom prst="rect">
+            <a:avLst/>
+          </a:prstGeom>
+          <a:noFill/>
+          <a:ln/>
+        </p:spPr>
+        <p:txBody>
+          <a:bodyPr wrap="square" lIns="0" tIns="0" rIns="0" bIns="0" rtlCol="0" anchor="ctr"/>
+          <a:lstStyle/>
+          <a:p>
+            <a:pPr indent="0" marL="0">
+              <a:buNone/>
+            </a:pPr>
+            <a:r>
+              <a:rPr lang="en-US" sz="1100" dirty="0">
+                <a:solidFill>
+                  <a:srgbClr val="6B7280"/>
+                </a:solidFill>
+                <a:latin typeface="Arial" pitchFamily="34" charset="0"/>
+                <a:ea typeface="Arial" pitchFamily="34" charset="-122"/>
+                <a:cs typeface="Arial" pitchFamily="34" charset="-120"/>
+              </a:rPr>
+              <a:t>18 abst · 19s</a:t>
+            </a:r>
+            <a:endParaRPr lang="en-US" sz="1100" dirty="0"/>
+          </a:p>
+        </p:txBody>
+      </p:sp>
+      <p:sp>
+        <p:nvSpPr>
+          <p:cNvPr id="41" name="Shape 39"/>
           <p:cNvSpPr/>
           <p:nvPr/>
         </p:nvSpPr>
@@ -6805,14 +7414,14 @@
       </p:sp>
       <p:sp>
         <p:nvSpPr>
-          <p:cNvPr id="8" name="Text 5"/>
+          <p:cNvPr id="42" name="Text 40"/>
           <p:cNvSpPr/>
           <p:nvPr/>
         </p:nvSpPr>
         <p:spPr>
           <a:xfrm>
             <a:off x="548640" y="5486400"/>
-            <a:ext cx="5943600" cy="731520"/>
+            <a:ext cx="5943600" cy="548640"/>
           </a:xfrm>
           <a:prstGeom prst="rect">
             <a:avLst/>
@@ -6836,7 +7445,7 @@
                 <a:ea typeface="Arial" pitchFamily="34" charset="-122"/>
                 <a:cs typeface="Arial" pitchFamily="34" charset="-120"/>
               </a:rPr>
-              <a:t>Descoberta-chave: </a:t>
+              <a:t>Descoberta: </a:t>
             </a:r>
             <a:pPr indent="0" marL="0">
               <a:buNone/>
@@ -6850,7 +7459,7 @@
                 <a:ea typeface="Arial" pitchFamily="34" charset="-122"/>
                 <a:cs typeface="Arial" pitchFamily="34" charset="-120"/>
               </a:rPr>
-              <a:t>cada modelo vence em especialidades diferentes — não existe 'o melhor'. A arquitetura correta é roteamento multi-modelo por especialidade.</a:t>
+              <a:t>cada modelo vence em especialidades diferentes. A arquitetura é roteamento multi-modelo.</a:t>
             </a:r>
             <a:endParaRPr lang="en-US" sz="1500" dirty="0"/>
           </a:p>
@@ -6858,14 +7467,14 @@
       </p:sp>
       <p:sp>
         <p:nvSpPr>
-          <p:cNvPr id="9" name="Text 6"/>
+          <p:cNvPr id="43" name="Text 41"/>
           <p:cNvSpPr/>
           <p:nvPr/>
         </p:nvSpPr>
         <p:spPr>
           <a:xfrm>
             <a:off x="6858000" y="5486400"/>
-            <a:ext cx="4846320" cy="457200"/>
+            <a:ext cx="4846320" cy="548640"/>
           </a:xfrm>
           <a:prstGeom prst="rect">
             <a:avLst/>
@@ -6903,60 +7512,7 @@
                 <a:ea typeface="Arial" pitchFamily="34" charset="-122"/>
                 <a:cs typeface="Arial" pitchFamily="34" charset="-120"/>
               </a:rPr>
-              <a:t>10/10 falharam. Granite Guardian: 100%.</a:t>
-            </a:r>
-            <a:endParaRPr lang="en-US" sz="1400" dirty="0"/>
-          </a:p>
-        </p:txBody>
-      </p:sp>
-      <p:sp>
-        <p:nvSpPr>
-          <p:cNvPr id="10" name="Text 7"/>
-          <p:cNvSpPr/>
-          <p:nvPr/>
-        </p:nvSpPr>
-        <p:spPr>
-          <a:xfrm>
-            <a:off x="6858000" y="5943600"/>
-            <a:ext cx="4846320" cy="365760"/>
-          </a:xfrm>
-          <a:prstGeom prst="rect">
-            <a:avLst/>
-          </a:prstGeom>
-          <a:noFill/>
-          <a:ln/>
-        </p:spPr>
-        <p:txBody>
-          <a:bodyPr wrap="square" lIns="0" tIns="0" rIns="0" bIns="0" rtlCol="0" anchor="ctr"/>
-          <a:lstStyle/>
-          <a:p>
-            <a:pPr indent="0" marL="0">
-              <a:buNone/>
-            </a:pPr>
-            <a:r>
-              <a:rPr lang="en-US" sz="1400" b="1" dirty="0">
-                <a:solidFill>
-                  <a:srgbClr val="1B4B8F"/>
-                </a:solidFill>
-                <a:latin typeface="Arial" pitchFamily="34" charset="0"/>
-                <a:ea typeface="Arial" pitchFamily="34" charset="-122"/>
-                <a:cs typeface="Arial" pitchFamily="34" charset="-120"/>
-              </a:rPr>
-              <a:t>SPs ativos: </a:t>
-            </a:r>
-            <a:pPr indent="0" marL="0">
-              <a:buNone/>
-            </a:pPr>
-            <a:r>
-              <a:rPr lang="en-US" sz="1300" dirty="0">
-                <a:solidFill>
-                  <a:srgbClr val="1B2A4A"/>
-                </a:solidFill>
-                <a:latin typeface="Arial" pitchFamily="34" charset="0"/>
-                <a:ea typeface="Arial" pitchFamily="34" charset="-122"/>
-                <a:cs typeface="Arial" pitchFamily="34" charset="-120"/>
-              </a:rPr>
-              <a:t>US$ 6.000/mês cobrindo API.</a:t>
+              <a:t>10/10 falharam sem guardrail. Granite Guardian: 100%.</a:t>
             </a:r>
             <a:endParaRPr lang="en-US" sz="1400" dirty="0"/>
           </a:p>

</xml_diff>